<commit_message>
Título da disciplina nos slides e apostila de referência na página de apresentação
Capas e slides de dados passam a exibir "Estado, Governo e Mercado";
slides de conteúdo ganham a identificação da disciplina e da unidade.
Página de apresentação: novo cartão com o link oficial do livro-texto
(COELHO, 2014) no Portal EduCAPES. Plano de ensino com o link da apostila.

Co-Authored-By: Claude Opus 5.5 <noreply@anthropic.com>
Claude-Session: https://claude.ai/code/session_01PyQDDPKwUxu1Vg7o8uyr7W
</commit_message>
<xml_diff>
--- a/disciplina-01-estado-governo-mercado/materiais/00_Videoaula_de_Apresentacao.pptx
+++ b/disciplina-01-estado-governo-mercado/materiais/00_Videoaula_de_Apresentacao.pptx
@@ -2030,8 +2030,8 @@
         </p:nvSpPr>
         <p:spPr>
           <a:xfrm>
-            <a:off x="1188720" y="1828800"/>
-            <a:ext cx="7223760" cy="1463040"/>
+            <a:off x="1188720" y="1810512"/>
+            <a:ext cx="7223760" cy="365760"/>
           </a:xfrm>
           <a:prstGeom prst="rect">
             <a:avLst/>
@@ -2050,37 +2050,17 @@
               <a:buNone/>
             </a:pPr>
             <a:r>
-              <a:rPr lang="en-US" sz="4600" b="1" dirty="0">
-                <a:solidFill>
-                  <a:srgbClr val="13294B"/>
-                </a:solidFill>
-                <a:latin typeface="Calibri" pitchFamily="34" charset="0"/>
-                <a:ea typeface="Calibri" pitchFamily="34" charset="-122"/>
-                <a:cs typeface="Calibri" pitchFamily="34" charset="-120"/>
-              </a:rPr>
-              <a:t>Especialização em</a:t>
-            </a:r>
-            <a:endParaRPr lang="en-US" sz="4600" dirty="0"/>
-          </a:p>
-          <a:p>
-            <a:pPr algn="l" indent="0" marL="0">
-              <a:lnSpc>
-                <a:spcPct val="100000"/>
-              </a:lnSpc>
-              <a:buNone/>
-            </a:pPr>
-            <a:r>
-              <a:rPr lang="en-US" sz="4600" b="1" dirty="0">
-                <a:solidFill>
-                  <a:srgbClr val="13294B"/>
-                </a:solidFill>
-                <a:latin typeface="Calibri" pitchFamily="34" charset="0"/>
-                <a:ea typeface="Calibri" pitchFamily="34" charset="-122"/>
-                <a:cs typeface="Calibri" pitchFamily="34" charset="-120"/>
-              </a:rPr>
-              <a:t>Gestão Pública</a:t>
-            </a:r>
-            <a:endParaRPr lang="en-US" sz="4600" dirty="0"/>
+              <a:rPr lang="en-US" sz="2000" b="1" dirty="0">
+                <a:solidFill>
+                  <a:srgbClr val="2A8C85"/>
+                </a:solidFill>
+                <a:latin typeface="Calibri" pitchFamily="34" charset="0"/>
+                <a:ea typeface="Calibri" pitchFamily="34" charset="-122"/>
+                <a:cs typeface="Calibri" pitchFamily="34" charset="-120"/>
+              </a:rPr>
+              <a:t>Especialização em Gestão Pública</a:t>
+            </a:r>
+            <a:endParaRPr lang="en-US" sz="2000" dirty="0"/>
           </a:p>
         </p:txBody>
       </p:sp>
@@ -2092,8 +2072,92 @@
         </p:nvSpPr>
         <p:spPr>
           <a:xfrm>
-            <a:off x="1243584" y="3456432"/>
-            <a:ext cx="3017520" cy="420624"/>
+            <a:off x="1188720" y="2157984"/>
+            <a:ext cx="7223760" cy="786384"/>
+          </a:xfrm>
+          <a:prstGeom prst="rect">
+            <a:avLst/>
+          </a:prstGeom>
+          <a:noFill/>
+          <a:ln/>
+        </p:spPr>
+        <p:txBody>
+          <a:bodyPr wrap="square" lIns="0" tIns="0" rIns="0" bIns="0" rtlCol="0" anchor="ctr"/>
+          <a:lstStyle/>
+          <a:p>
+            <a:pPr algn="l" indent="0" marL="0">
+              <a:lnSpc>
+                <a:spcPct val="100000"/>
+              </a:lnSpc>
+              <a:buNone/>
+            </a:pPr>
+            <a:r>
+              <a:rPr lang="en-US" sz="4800" b="1" dirty="0">
+                <a:solidFill>
+                  <a:srgbClr val="13294B"/>
+                </a:solidFill>
+                <a:latin typeface="Calibri" pitchFamily="34" charset="0"/>
+                <a:ea typeface="Calibri" pitchFamily="34" charset="-122"/>
+                <a:cs typeface="Calibri" pitchFamily="34" charset="-120"/>
+              </a:rPr>
+              <a:t>Estado, Governo e Mercado</a:t>
+            </a:r>
+            <a:endParaRPr lang="en-US" sz="4800" dirty="0"/>
+          </a:p>
+        </p:txBody>
+      </p:sp>
+      <p:sp>
+        <p:nvSpPr>
+          <p:cNvPr id="7" name="Text 2"/>
+          <p:cNvSpPr txBox="1"/>
+          <p:nvPr/>
+        </p:nvSpPr>
+        <p:spPr>
+          <a:xfrm>
+            <a:off x="1188720" y="2926080"/>
+            <a:ext cx="7223760" cy="384048"/>
+          </a:xfrm>
+          <a:prstGeom prst="rect">
+            <a:avLst/>
+          </a:prstGeom>
+          <a:noFill/>
+          <a:ln/>
+        </p:spPr>
+        <p:txBody>
+          <a:bodyPr wrap="square" lIns="0" tIns="0" rIns="0" bIns="0" rtlCol="0" anchor="ctr"/>
+          <a:lstStyle/>
+          <a:p>
+            <a:pPr algn="l" indent="0" marL="0">
+              <a:lnSpc>
+                <a:spcPct val="100000"/>
+              </a:lnSpc>
+              <a:buNone/>
+            </a:pPr>
+            <a:r>
+              <a:rPr lang="en-US" sz="1900" dirty="0">
+                <a:solidFill>
+                  <a:srgbClr val="1F2A37"/>
+                </a:solidFill>
+                <a:latin typeface="Calibri" pitchFamily="34" charset="0"/>
+                <a:ea typeface="Calibri" pitchFamily="34" charset="-122"/>
+                <a:cs typeface="Calibri" pitchFamily="34" charset="-120"/>
+              </a:rPr>
+              <a:t>Videoaula de apresentação da disciplina</a:t>
+            </a:r>
+            <a:endParaRPr lang="en-US" sz="1900" dirty="0"/>
+          </a:p>
+        </p:txBody>
+      </p:sp>
+      <p:sp>
+        <p:nvSpPr>
+          <p:cNvPr id="8" name="Text 3"/>
+          <p:cNvSpPr txBox="1"/>
+          <p:nvPr/>
+        </p:nvSpPr>
+        <p:spPr>
+          <a:xfrm>
+            <a:off x="1243584" y="3474720"/>
+            <a:ext cx="4572000" cy="420624"/>
           </a:xfrm>
           <a:prstGeom prst="roundRect">
             <a:avLst>
@@ -2124,7 +2188,7 @@
                 <a:ea typeface="Calibri" pitchFamily="34" charset="-122"/>
                 <a:cs typeface="Calibri" pitchFamily="34" charset="-120"/>
               </a:rPr>
-              <a:t>DEAD · UAB · Turma 2026/2</a:t>
+              <a:t>DEAD · UAB · Turma 2026/2 · Prof. Dr. Cleiton Franco</a:t>
             </a:r>
             <a:endParaRPr lang="en-US" sz="1500" dirty="0"/>
           </a:p>
@@ -2536,6 +2600,48 @@
               <a:t>Data definida pela Coordenação.</a:t>
             </a:r>
             <a:endParaRPr lang="en-US" sz="1200" dirty="0"/>
+          </a:p>
+        </p:txBody>
+      </p:sp>
+      <p:sp>
+        <p:nvSpPr>
+          <p:cNvPr id="6" name="Text 4"/>
+          <p:cNvSpPr txBox="1"/>
+          <p:nvPr/>
+        </p:nvSpPr>
+        <p:spPr>
+          <a:xfrm>
+            <a:off x="4206240" y="36576"/>
+            <a:ext cx="4800600" cy="219456"/>
+          </a:xfrm>
+          <a:prstGeom prst="rect">
+            <a:avLst/>
+          </a:prstGeom>
+          <a:noFill/>
+          <a:ln/>
+        </p:spPr>
+        <p:txBody>
+          <a:bodyPr wrap="square" lIns="0" tIns="0" rIns="0" bIns="0" rtlCol="0" anchor="ctr"/>
+          <a:lstStyle/>
+          <a:p>
+            <a:pPr algn="r" indent="0" marL="0">
+              <a:lnSpc>
+                <a:spcPct val="100000"/>
+              </a:lnSpc>
+              <a:buNone/>
+            </a:pPr>
+            <a:r>
+              <a:rPr lang="en-US" sz="950" dirty="0">
+                <a:solidFill>
+                  <a:srgbClr val="5B6770"/>
+                </a:solidFill>
+                <a:latin typeface="Calibri" pitchFamily="34" charset="0"/>
+                <a:ea typeface="Calibri" pitchFamily="34" charset="-122"/>
+                <a:cs typeface="Calibri" pitchFamily="34" charset="-120"/>
+              </a:rPr>
+              <a:t>Estado, Governo e Mercado · Apresentação da disciplina</a:t>
+            </a:r>
+            <a:endParaRPr lang="en-US" sz="950" dirty="0"/>
           </a:p>
         </p:txBody>
       </p:sp>
@@ -4930,6 +5036,48 @@
           </a:graphicData>
         </a:graphic>
       </p:graphicFrame>
+      <p:sp>
+        <p:nvSpPr>
+          <p:cNvPr id="6" name="Text 2"/>
+          <p:cNvSpPr txBox="1"/>
+          <p:nvPr/>
+        </p:nvSpPr>
+        <p:spPr>
+          <a:xfrm>
+            <a:off x="4206240" y="36576"/>
+            <a:ext cx="4800600" cy="219456"/>
+          </a:xfrm>
+          <a:prstGeom prst="rect">
+            <a:avLst/>
+          </a:prstGeom>
+          <a:noFill/>
+          <a:ln/>
+        </p:spPr>
+        <p:txBody>
+          <a:bodyPr wrap="square" lIns="0" tIns="0" rIns="0" bIns="0" rtlCol="0" anchor="ctr"/>
+          <a:lstStyle/>
+          <a:p>
+            <a:pPr algn="r" indent="0" marL="0">
+              <a:lnSpc>
+                <a:spcPct val="100000"/>
+              </a:lnSpc>
+              <a:buNone/>
+            </a:pPr>
+            <a:r>
+              <a:rPr lang="en-US" sz="950" dirty="0">
+                <a:solidFill>
+                  <a:srgbClr val="5B6770"/>
+                </a:solidFill>
+                <a:latin typeface="Calibri" pitchFamily="34" charset="0"/>
+                <a:ea typeface="Calibri" pitchFamily="34" charset="-122"/>
+                <a:cs typeface="Calibri" pitchFamily="34" charset="-120"/>
+              </a:rPr>
+              <a:t>Estado, Governo e Mercado · Apresentação da disciplina</a:t>
+            </a:r>
+            <a:endParaRPr lang="en-US" sz="950" dirty="0"/>
+          </a:p>
+        </p:txBody>
+      </p:sp>
     </p:spTree>
   </p:cSld>
   <p:clrMapOvr>
@@ -5579,6 +5727,48 @@
           </a:p>
         </p:txBody>
       </p:sp>
+      <p:sp>
+        <p:nvSpPr>
+          <p:cNvPr id="10" name="Text 8"/>
+          <p:cNvSpPr txBox="1"/>
+          <p:nvPr/>
+        </p:nvSpPr>
+        <p:spPr>
+          <a:xfrm>
+            <a:off x="4206240" y="36576"/>
+            <a:ext cx="4800600" cy="219456"/>
+          </a:xfrm>
+          <a:prstGeom prst="rect">
+            <a:avLst/>
+          </a:prstGeom>
+          <a:noFill/>
+          <a:ln/>
+        </p:spPr>
+        <p:txBody>
+          <a:bodyPr wrap="square" lIns="0" tIns="0" rIns="0" bIns="0" rtlCol="0" anchor="ctr"/>
+          <a:lstStyle/>
+          <a:p>
+            <a:pPr algn="r" indent="0" marL="0">
+              <a:lnSpc>
+                <a:spcPct val="100000"/>
+              </a:lnSpc>
+              <a:buNone/>
+            </a:pPr>
+            <a:r>
+              <a:rPr lang="en-US" sz="950" dirty="0">
+                <a:solidFill>
+                  <a:srgbClr val="5B6770"/>
+                </a:solidFill>
+                <a:latin typeface="Calibri" pitchFamily="34" charset="0"/>
+                <a:ea typeface="Calibri" pitchFamily="34" charset="-122"/>
+                <a:cs typeface="Calibri" pitchFamily="34" charset="-120"/>
+              </a:rPr>
+              <a:t>Estado, Governo e Mercado · Apresentação da disciplina</a:t>
+            </a:r>
+            <a:endParaRPr lang="en-US" sz="950" dirty="0"/>
+          </a:p>
+        </p:txBody>
+      </p:sp>
     </p:spTree>
   </p:cSld>
   <p:clrMapOvr>
@@ -6137,6 +6327,48 @@
           </a:p>
         </p:txBody>
       </p:sp>
+      <p:sp>
+        <p:nvSpPr>
+          <p:cNvPr id="16" name="Text 11"/>
+          <p:cNvSpPr txBox="1"/>
+          <p:nvPr/>
+        </p:nvSpPr>
+        <p:spPr>
+          <a:xfrm>
+            <a:off x="4206240" y="36576"/>
+            <a:ext cx="4800600" cy="219456"/>
+          </a:xfrm>
+          <a:prstGeom prst="rect">
+            <a:avLst/>
+          </a:prstGeom>
+          <a:noFill/>
+          <a:ln/>
+        </p:spPr>
+        <p:txBody>
+          <a:bodyPr wrap="square" lIns="0" tIns="0" rIns="0" bIns="0" rtlCol="0" anchor="ctr"/>
+          <a:lstStyle/>
+          <a:p>
+            <a:pPr algn="r" indent="0" marL="0">
+              <a:lnSpc>
+                <a:spcPct val="100000"/>
+              </a:lnSpc>
+              <a:buNone/>
+            </a:pPr>
+            <a:r>
+              <a:rPr lang="en-US" sz="950" dirty="0">
+                <a:solidFill>
+                  <a:srgbClr val="5B6770"/>
+                </a:solidFill>
+                <a:latin typeface="Calibri" pitchFamily="34" charset="0"/>
+                <a:ea typeface="Calibri" pitchFamily="34" charset="-122"/>
+                <a:cs typeface="Calibri" pitchFamily="34" charset="-120"/>
+              </a:rPr>
+              <a:t>Estado, Governo e Mercado · Apresentação da disciplina</a:t>
+            </a:r>
+            <a:endParaRPr lang="en-US" sz="950" dirty="0"/>
+          </a:p>
+        </p:txBody>
+      </p:sp>
     </p:spTree>
   </p:cSld>
   <p:clrMapOvr>
@@ -6226,8 +6458,8 @@
         </p:nvSpPr>
         <p:spPr>
           <a:xfrm>
-            <a:off x="1920240" y="969264"/>
-            <a:ext cx="5303520" cy="402336"/>
+            <a:off x="1371600" y="969264"/>
+            <a:ext cx="6400800" cy="402336"/>
           </a:xfrm>
           <a:prstGeom prst="roundRect">
             <a:avLst>
@@ -7490,6 +7722,48 @@
           </a:p>
         </p:txBody>
       </p:sp>
+      <p:sp>
+        <p:nvSpPr>
+          <p:cNvPr id="14" name="Text 10"/>
+          <p:cNvSpPr txBox="1"/>
+          <p:nvPr/>
+        </p:nvSpPr>
+        <p:spPr>
+          <a:xfrm>
+            <a:off x="4206240" y="36576"/>
+            <a:ext cx="4800600" cy="219456"/>
+          </a:xfrm>
+          <a:prstGeom prst="rect">
+            <a:avLst/>
+          </a:prstGeom>
+          <a:noFill/>
+          <a:ln/>
+        </p:spPr>
+        <p:txBody>
+          <a:bodyPr wrap="square" lIns="0" tIns="0" rIns="0" bIns="0" rtlCol="0" anchor="ctr"/>
+          <a:lstStyle/>
+          <a:p>
+            <a:pPr algn="r" indent="0" marL="0">
+              <a:lnSpc>
+                <a:spcPct val="100000"/>
+              </a:lnSpc>
+              <a:buNone/>
+            </a:pPr>
+            <a:r>
+              <a:rPr lang="en-US" sz="950" dirty="0">
+                <a:solidFill>
+                  <a:srgbClr val="5B6770"/>
+                </a:solidFill>
+                <a:latin typeface="Calibri" pitchFamily="34" charset="0"/>
+                <a:ea typeface="Calibri" pitchFamily="34" charset="-122"/>
+                <a:cs typeface="Calibri" pitchFamily="34" charset="-120"/>
+              </a:rPr>
+              <a:t>Estado, Governo e Mercado · Apresentação da disciplina</a:t>
+            </a:r>
+            <a:endParaRPr lang="en-US" sz="950" dirty="0"/>
+          </a:p>
+        </p:txBody>
+      </p:sp>
     </p:spTree>
   </p:cSld>
   <p:clrMapOvr>
@@ -7952,6 +8226,48 @@
           </a:p>
         </p:txBody>
       </p:sp>
+      <p:sp>
+        <p:nvSpPr>
+          <p:cNvPr id="13" name="Text 9"/>
+          <p:cNvSpPr txBox="1"/>
+          <p:nvPr/>
+        </p:nvSpPr>
+        <p:spPr>
+          <a:xfrm>
+            <a:off x="4206240" y="36576"/>
+            <a:ext cx="4800600" cy="219456"/>
+          </a:xfrm>
+          <a:prstGeom prst="rect">
+            <a:avLst/>
+          </a:prstGeom>
+          <a:noFill/>
+          <a:ln/>
+        </p:spPr>
+        <p:txBody>
+          <a:bodyPr wrap="square" lIns="0" tIns="0" rIns="0" bIns="0" rtlCol="0" anchor="ctr"/>
+          <a:lstStyle/>
+          <a:p>
+            <a:pPr algn="r" indent="0" marL="0">
+              <a:lnSpc>
+                <a:spcPct val="100000"/>
+              </a:lnSpc>
+              <a:buNone/>
+            </a:pPr>
+            <a:r>
+              <a:rPr lang="en-US" sz="950" dirty="0">
+                <a:solidFill>
+                  <a:srgbClr val="5B6770"/>
+                </a:solidFill>
+                <a:latin typeface="Calibri" pitchFamily="34" charset="0"/>
+                <a:ea typeface="Calibri" pitchFamily="34" charset="-122"/>
+                <a:cs typeface="Calibri" pitchFamily="34" charset="-120"/>
+              </a:rPr>
+              <a:t>Estado, Governo e Mercado · Apresentação da disciplina</a:t>
+            </a:r>
+            <a:endParaRPr lang="en-US" sz="950" dirty="0"/>
+          </a:p>
+        </p:txBody>
+      </p:sp>
     </p:spTree>
   </p:cSld>
   <p:clrMapOvr>
@@ -8217,6 +8533,48 @@
           </a:p>
         </p:txBody>
       </p:sp>
+      <p:sp>
+        <p:nvSpPr>
+          <p:cNvPr id="6" name="Text 4"/>
+          <p:cNvSpPr txBox="1"/>
+          <p:nvPr/>
+        </p:nvSpPr>
+        <p:spPr>
+          <a:xfrm>
+            <a:off x="4206240" y="36576"/>
+            <a:ext cx="4800600" cy="219456"/>
+          </a:xfrm>
+          <a:prstGeom prst="rect">
+            <a:avLst/>
+          </a:prstGeom>
+          <a:noFill/>
+          <a:ln/>
+        </p:spPr>
+        <p:txBody>
+          <a:bodyPr wrap="square" lIns="0" tIns="0" rIns="0" bIns="0" rtlCol="0" anchor="ctr"/>
+          <a:lstStyle/>
+          <a:p>
+            <a:pPr algn="r" indent="0" marL="0">
+              <a:lnSpc>
+                <a:spcPct val="100000"/>
+              </a:lnSpc>
+              <a:buNone/>
+            </a:pPr>
+            <a:r>
+              <a:rPr lang="en-US" sz="950" dirty="0">
+                <a:solidFill>
+                  <a:srgbClr val="5B6770"/>
+                </a:solidFill>
+                <a:latin typeface="Calibri" pitchFamily="34" charset="0"/>
+                <a:ea typeface="Calibri" pitchFamily="34" charset="-122"/>
+                <a:cs typeface="Calibri" pitchFamily="34" charset="-120"/>
+              </a:rPr>
+              <a:t>Estado, Governo e Mercado · Apresentação da disciplina</a:t>
+            </a:r>
+            <a:endParaRPr lang="en-US" sz="950" dirty="0"/>
+          </a:p>
+        </p:txBody>
+      </p:sp>
     </p:spTree>
   </p:cSld>
   <p:clrMapOvr>
@@ -8770,6 +9128,48 @@
           </a:p>
         </p:txBody>
       </p:sp>
+      <p:sp>
+        <p:nvSpPr>
+          <p:cNvPr id="9" name="Text 7"/>
+          <p:cNvSpPr txBox="1"/>
+          <p:nvPr/>
+        </p:nvSpPr>
+        <p:spPr>
+          <a:xfrm>
+            <a:off x="4206240" y="36576"/>
+            <a:ext cx="4800600" cy="219456"/>
+          </a:xfrm>
+          <a:prstGeom prst="rect">
+            <a:avLst/>
+          </a:prstGeom>
+          <a:noFill/>
+          <a:ln/>
+        </p:spPr>
+        <p:txBody>
+          <a:bodyPr wrap="square" lIns="0" tIns="0" rIns="0" bIns="0" rtlCol="0" anchor="ctr"/>
+          <a:lstStyle/>
+          <a:p>
+            <a:pPr algn="r" indent="0" marL="0">
+              <a:lnSpc>
+                <a:spcPct val="100000"/>
+              </a:lnSpc>
+              <a:buNone/>
+            </a:pPr>
+            <a:r>
+              <a:rPr lang="en-US" sz="950" dirty="0">
+                <a:solidFill>
+                  <a:srgbClr val="5B6770"/>
+                </a:solidFill>
+                <a:latin typeface="Calibri" pitchFamily="34" charset="0"/>
+                <a:ea typeface="Calibri" pitchFamily="34" charset="-122"/>
+                <a:cs typeface="Calibri" pitchFamily="34" charset="-120"/>
+              </a:rPr>
+              <a:t>Estado, Governo e Mercado · Apresentação da disciplina</a:t>
+            </a:r>
+            <a:endParaRPr lang="en-US" sz="950" dirty="0"/>
+          </a:p>
+        </p:txBody>
+      </p:sp>
     </p:spTree>
   </p:cSld>
   <p:clrMapOvr>
@@ -8982,7 +9382,7 @@
                 <a:ea typeface="Calibri" pitchFamily="34" charset="-122"/>
                 <a:cs typeface="Calibri" pitchFamily="34" charset="-120"/>
               </a:rPr>
-              <a:t>Leitura obrigatória em todas as unidades. Disponível no Portal EduCAPES.</a:t>
+              <a:t>Leitura obrigatória em todas as unidades. Acesso livre no Portal EduCAPES (coleção PNAP, Módulo Básico) e na página da disciplina.</a:t>
             </a:r>
             <a:endParaRPr lang="en-US" sz="1150" dirty="0"/>
           </a:p>
@@ -9200,6 +9600,48 @@
               <a:t>Portal EduCAPES · Biblioteca Virtual da UNEMAT · BDTD · fontes oficiais</a:t>
             </a:r>
             <a:endParaRPr lang="en-US" sz="1500" dirty="0"/>
+          </a:p>
+        </p:txBody>
+      </p:sp>
+      <p:sp>
+        <p:nvSpPr>
+          <p:cNvPr id="7" name="Text 5"/>
+          <p:cNvSpPr txBox="1"/>
+          <p:nvPr/>
+        </p:nvSpPr>
+        <p:spPr>
+          <a:xfrm>
+            <a:off x="4206240" y="36576"/>
+            <a:ext cx="4800600" cy="219456"/>
+          </a:xfrm>
+          <a:prstGeom prst="rect">
+            <a:avLst/>
+          </a:prstGeom>
+          <a:noFill/>
+          <a:ln/>
+        </p:spPr>
+        <p:txBody>
+          <a:bodyPr wrap="square" lIns="0" tIns="0" rIns="0" bIns="0" rtlCol="0" anchor="ctr"/>
+          <a:lstStyle/>
+          <a:p>
+            <a:pPr algn="r" indent="0" marL="0">
+              <a:lnSpc>
+                <a:spcPct val="100000"/>
+              </a:lnSpc>
+              <a:buNone/>
+            </a:pPr>
+            <a:r>
+              <a:rPr lang="en-US" sz="950" dirty="0">
+                <a:solidFill>
+                  <a:srgbClr val="5B6770"/>
+                </a:solidFill>
+                <a:latin typeface="Calibri" pitchFamily="34" charset="0"/>
+                <a:ea typeface="Calibri" pitchFamily="34" charset="-122"/>
+                <a:cs typeface="Calibri" pitchFamily="34" charset="-120"/>
+              </a:rPr>
+              <a:t>Estado, Governo e Mercado · Apresentação da disciplina</a:t>
+            </a:r>
+            <a:endParaRPr lang="en-US" sz="950" dirty="0"/>
           </a:p>
         </p:txBody>
       </p:sp>
@@ -9855,6 +10297,48 @@
           </a:p>
         </p:txBody>
       </p:sp>
+      <p:sp>
+        <p:nvSpPr>
+          <p:cNvPr id="17" name="Text 12"/>
+          <p:cNvSpPr txBox="1"/>
+          <p:nvPr/>
+        </p:nvSpPr>
+        <p:spPr>
+          <a:xfrm>
+            <a:off x="4206240" y="36576"/>
+            <a:ext cx="4800600" cy="219456"/>
+          </a:xfrm>
+          <a:prstGeom prst="rect">
+            <a:avLst/>
+          </a:prstGeom>
+          <a:noFill/>
+          <a:ln/>
+        </p:spPr>
+        <p:txBody>
+          <a:bodyPr wrap="square" lIns="0" tIns="0" rIns="0" bIns="0" rtlCol="0" anchor="ctr"/>
+          <a:lstStyle/>
+          <a:p>
+            <a:pPr algn="r" indent="0" marL="0">
+              <a:lnSpc>
+                <a:spcPct val="100000"/>
+              </a:lnSpc>
+              <a:buNone/>
+            </a:pPr>
+            <a:r>
+              <a:rPr lang="en-US" sz="950" dirty="0">
+                <a:solidFill>
+                  <a:srgbClr val="5B6770"/>
+                </a:solidFill>
+                <a:latin typeface="Calibri" pitchFamily="34" charset="0"/>
+                <a:ea typeface="Calibri" pitchFamily="34" charset="-122"/>
+                <a:cs typeface="Calibri" pitchFamily="34" charset="-120"/>
+              </a:rPr>
+              <a:t>Estado, Governo e Mercado · Apresentação da disciplina</a:t>
+            </a:r>
+            <a:endParaRPr lang="en-US" sz="950" dirty="0"/>
+          </a:p>
+        </p:txBody>
+      </p:sp>
     </p:spTree>
   </p:cSld>
   <p:clrMapOvr>
@@ -10309,6 +10793,48 @@
               <a:t>Aprovação: nota final igual ou superior a 7,0 e 75% de frequência. Exercícios de fixação (sem nota) ajudam a preparar cada avaliação.</a:t>
             </a:r>
             <a:endParaRPr lang="en-US" sz="1350" dirty="0"/>
+          </a:p>
+        </p:txBody>
+      </p:sp>
+      <p:sp>
+        <p:nvSpPr>
+          <p:cNvPr id="8" name="Text 6"/>
+          <p:cNvSpPr txBox="1"/>
+          <p:nvPr/>
+        </p:nvSpPr>
+        <p:spPr>
+          <a:xfrm>
+            <a:off x="4206240" y="36576"/>
+            <a:ext cx="4800600" cy="219456"/>
+          </a:xfrm>
+          <a:prstGeom prst="rect">
+            <a:avLst/>
+          </a:prstGeom>
+          <a:noFill/>
+          <a:ln/>
+        </p:spPr>
+        <p:txBody>
+          <a:bodyPr wrap="square" lIns="0" tIns="0" rIns="0" bIns="0" rtlCol="0" anchor="ctr"/>
+          <a:lstStyle/>
+          <a:p>
+            <a:pPr algn="r" indent="0" marL="0">
+              <a:lnSpc>
+                <a:spcPct val="100000"/>
+              </a:lnSpc>
+              <a:buNone/>
+            </a:pPr>
+            <a:r>
+              <a:rPr lang="en-US" sz="950" dirty="0">
+                <a:solidFill>
+                  <a:srgbClr val="5B6770"/>
+                </a:solidFill>
+                <a:latin typeface="Calibri" pitchFamily="34" charset="0"/>
+                <a:ea typeface="Calibri" pitchFamily="34" charset="-122"/>
+                <a:cs typeface="Calibri" pitchFamily="34" charset="-120"/>
+              </a:rPr>
+              <a:t>Estado, Governo e Mercado · Apresentação da disciplina</a:t>
+            </a:r>
+            <a:endParaRPr lang="en-US" sz="950" dirty="0"/>
           </a:p>
         </p:txBody>
       </p:sp>

</xml_diff>

<commit_message>
Um único encontro síncrono (28/10/2026, 19h) no lugar de cinco webaulas
A disciplina prevê apenas um encontro síncrono. Slides (apresentação e
unidades), plano de ensino e página de conteúdos atualizados: 28,5 h
assíncronas e 1,5 h síncrona, com presença obrigatória.

Co-Authored-By: Claude Opus 5.5 <noreply@anthropic.com>
Claude-Session: https://claude.ai/code/session_01PyQDDPKwUxu1Vg7o8uyr7W
</commit_message>
<xml_diff>
--- a/disciplina-01-estado-governo-mercado/materiais/00_Videoaula_de_Apresentacao.pptx
+++ b/disciplina-01-estado-governo-mercado/materiais/00_Videoaula_de_Apresentacao.pptx
@@ -690,7 +690,7 @@
           <a:p>
             <a:r>
               <a:rPr lang="en-US" dirty="0"/>
-              <a:t>Este é o mapa do bloco. Anote as datas: webaulas às quartas, 14, 21 e 28 de outubro e 4 e 11 de novembro; A1 até 25 de outubro; A2 até 8 de novembro; A3 até 15 de novembro, quando a disciplina se encerra. Todas as entregas até 23h55.</a:t>
+              <a:t>Este é o mapa do bloco. Anote as datas: o encontro síncrono é no dia 28 de outubro, às 19h; A1 até 25 de outubro; A2 até 8 de novembro; A3 até 15 de novembro, quando a disciplina se encerra. Todas as entregas até 23h55.</a:t>
             </a:r>
             <a:endParaRPr lang="en-US" dirty="0"/>
           </a:p>
@@ -778,7 +778,7 @@
           <a:p>
             <a:r>
               <a:rPr lang="en-US" dirty="0"/>
-              <a:t>Sugestão de rotina: assista à videoaula, leia o livro e a página de conteúdos, revise com os slides e os exercícios de fixação, participe do fórum e da webaula e entregue as atividades antes das 23h55 do prazo.</a:t>
+              <a:t>Sugestão de rotina: assista à videoaula, leia o livro e a página de conteúdos, revise com os slides e os exercícios de fixação, participe dos fóruns e do encontro síncrono e entregue as atividades antes das 23h55 do prazo.</a:t>
             </a:r>
             <a:endParaRPr lang="en-US" dirty="0"/>
           </a:p>
@@ -866,7 +866,7 @@
           <a:p>
             <a:r>
               <a:rPr lang="en-US" dirty="0"/>
-              <a:t>Para começar: acesse o SIGAA, apresente-se no fórum até 18 de outubro e participe da aula inaugural em 14 de outubro, às 19h. Bons estudos e até a nossa primeira webaula!</a:t>
+              <a:t>Para começar: acesse o SIGAA, apresente-se no fórum até 18 de outubro e anote na agenda o nosso encontro síncrono, em 28 de outubro, às 19h. Bons estudos!</a:t>
             </a:r>
             <a:endParaRPr lang="en-US" dirty="0"/>
           </a:p>
@@ -1482,7 +1482,7 @@
           <a:p>
             <a:r>
               <a:rPr lang="en-US" dirty="0"/>
-              <a:t>São 30 horas: cerca de 22 horas e meia de estudo assíncrono no SIGAA e 7 horas e meia em cinco webaulas de 1h30, às quartas às 19h, nos dias 14, 21 e 28 de outubro e 4 e 11 de novembro. A frequência mínima nas atividades síncronas é de 75%. (Horários sugeridos; confirmar com a Coordenação.)</a:t>
+              <a:t>São 30 horas: 28 horas e meia de estudo assíncrono no SIGAA e um encontro síncrono de 1h30 pelo Google Meet, na quarta-feira, 28 de outubro, das 19h às 20h30. A presença nesse encontro é obrigatória, porque o PPC exige 75% de frequência nas atividades síncronas. O encontro fica gravado no SIGAA.</a:t>
             </a:r>
             <a:endParaRPr lang="en-US" dirty="0"/>
           </a:p>
@@ -2762,7 +2762,7 @@
                 <a:ea typeface="Calibri" pitchFamily="34" charset="-122"/>
                 <a:cs typeface="Calibri" pitchFamily="34" charset="-120"/>
               </a:rPr>
-              <a:t>Datas das unidades, webaulas e avaliações</a:t>
+              <a:t>Datas das unidades, do encontro síncrono e das avaliações</a:t>
             </a:r>
             <a:endParaRPr lang="en-US" sz="1400" dirty="0"/>
           </a:p>
@@ -3088,144 +3088,6 @@
                           <a:ea typeface="Calibri" pitchFamily="34" charset="-122"/>
                           <a:cs typeface="Calibri" pitchFamily="34" charset="-120"/>
                         </a:rPr>
-                        <a:t>14/10 (qua)</a:t>
-                      </a:r>
-                      <a:endParaRPr lang="en-US" sz="1200" dirty="0">
-                        <a:latin typeface="Calibri" charset="0"/>
-                        <a:ea typeface="Calibri" charset="0"/>
-                        <a:cs typeface="Calibri" charset="0"/>
-                      </a:endParaRPr>
-                    </a:p>
-                  </a:txBody>
-                  <a:tcPr marL="50800" marR="50800" marT="50800" marB="50800" anchor="ctr">
-                    <a:lnL w="9525" cap="flat" cmpd="sng" algn="ctr">
-                      <a:solidFill>
-                        <a:srgbClr val="DCD5C1"/>
-                      </a:solidFill>
-                      <a:prstDash val="solid"/>
-                      <a:round/>
-                      <a:headEnd type="none" w="med" len="med"/>
-                      <a:tailEnd type="none" w="med" len="med"/>
-                    </a:lnL>
-                    <a:lnR w="9525" cap="flat" cmpd="sng" algn="ctr">
-                      <a:solidFill>
-                        <a:srgbClr val="DCD5C1"/>
-                      </a:solidFill>
-                      <a:prstDash val="solid"/>
-                      <a:round/>
-                      <a:headEnd type="none" w="med" len="med"/>
-                      <a:tailEnd type="none" w="med" len="med"/>
-                    </a:lnR>
-                    <a:lnT w="9525" cap="flat" cmpd="sng" algn="ctr">
-                      <a:solidFill>
-                        <a:srgbClr val="DCD5C1"/>
-                      </a:solidFill>
-                      <a:prstDash val="solid"/>
-                      <a:round/>
-                      <a:headEnd type="none" w="med" len="med"/>
-                      <a:tailEnd type="none" w="med" len="med"/>
-                    </a:lnT>
-                    <a:lnB w="9525" cap="flat" cmpd="sng" algn="ctr">
-                      <a:solidFill>
-                        <a:srgbClr val="DCD5C1"/>
-                      </a:solidFill>
-                      <a:prstDash val="solid"/>
-                      <a:round/>
-                      <a:headEnd type="none" w="med" len="med"/>
-                      <a:tailEnd type="none" w="med" len="med"/>
-                    </a:lnB>
-                    <a:solidFill>
-                      <a:srgbClr val="F4F7F8"/>
-                    </a:solidFill>
-                  </a:tcPr>
-                </a:tc>
-                <a:tc>
-                  <a:txBody>
-                    <a:bodyPr/>
-                    <a:lstStyle/>
-                    <a:p>
-                      <a:pPr indent="0" marL="0">
-                        <a:buNone/>
-                      </a:pPr>
-                      <a:r>
-                        <a:rPr lang="en-US" sz="1200" dirty="0">
-                          <a:solidFill>
-                            <a:srgbClr val="1F2A37"/>
-                          </a:solidFill>
-                          <a:latin typeface="Calibri" pitchFamily="34" charset="0"/>
-                          <a:ea typeface="Calibri" pitchFamily="34" charset="-122"/>
-                          <a:cs typeface="Calibri" pitchFamily="34" charset="-120"/>
-                        </a:rPr>
-                        <a:t>1ª webaula: aula inaugural</a:t>
-                      </a:r>
-                      <a:endParaRPr lang="en-US" sz="1200" dirty="0">
-                        <a:latin typeface="Calibri" charset="0"/>
-                        <a:ea typeface="Calibri" charset="0"/>
-                        <a:cs typeface="Calibri" charset="0"/>
-                      </a:endParaRPr>
-                    </a:p>
-                  </a:txBody>
-                  <a:tcPr marL="50800" marR="50800" marT="50800" marB="50800" anchor="ctr">
-                    <a:lnL w="9525" cap="flat" cmpd="sng" algn="ctr">
-                      <a:solidFill>
-                        <a:srgbClr val="DCD5C1"/>
-                      </a:solidFill>
-                      <a:prstDash val="solid"/>
-                      <a:round/>
-                      <a:headEnd type="none" w="med" len="med"/>
-                      <a:tailEnd type="none" w="med" len="med"/>
-                    </a:lnL>
-                    <a:lnR w="9525" cap="flat" cmpd="sng" algn="ctr">
-                      <a:solidFill>
-                        <a:srgbClr val="DCD5C1"/>
-                      </a:solidFill>
-                      <a:prstDash val="solid"/>
-                      <a:round/>
-                      <a:headEnd type="none" w="med" len="med"/>
-                      <a:tailEnd type="none" w="med" len="med"/>
-                    </a:lnR>
-                    <a:lnT w="9525" cap="flat" cmpd="sng" algn="ctr">
-                      <a:solidFill>
-                        <a:srgbClr val="DCD5C1"/>
-                      </a:solidFill>
-                      <a:prstDash val="solid"/>
-                      <a:round/>
-                      <a:headEnd type="none" w="med" len="med"/>
-                      <a:tailEnd type="none" w="med" len="med"/>
-                    </a:lnT>
-                    <a:lnB w="9525" cap="flat" cmpd="sng" algn="ctr">
-                      <a:solidFill>
-                        <a:srgbClr val="DCD5C1"/>
-                      </a:solidFill>
-                      <a:prstDash val="solid"/>
-                      <a:round/>
-                      <a:headEnd type="none" w="med" len="med"/>
-                      <a:tailEnd type="none" w="med" len="med"/>
-                    </a:lnB>
-                    <a:solidFill>
-                      <a:srgbClr val="F4F7F8"/>
-                    </a:solidFill>
-                  </a:tcPr>
-                </a:tc>
-              </a:tr>
-              <a:tr h="0">
-                <a:tc>
-                  <a:txBody>
-                    <a:bodyPr/>
-                    <a:lstStyle/>
-                    <a:p>
-                      <a:pPr indent="0" marL="0">
-                        <a:buNone/>
-                      </a:pPr>
-                      <a:r>
-                        <a:rPr lang="en-US" sz="1200" dirty="0">
-                          <a:solidFill>
-                            <a:srgbClr val="1F2A37"/>
-                          </a:solidFill>
-                          <a:latin typeface="Calibri" pitchFamily="34" charset="0"/>
-                          <a:ea typeface="Calibri" pitchFamily="34" charset="-122"/>
-                          <a:cs typeface="Calibri" pitchFamily="34" charset="-120"/>
-                        </a:rPr>
                         <a:t>18/10 (dom)</a:t>
                       </a:r>
                       <a:endParaRPr lang="en-US" sz="1200" dirty="0">
@@ -3273,7 +3135,7 @@
                       <a:tailEnd type="none" w="med" len="med"/>
                     </a:lnB>
                     <a:solidFill>
-                      <a:srgbClr val="FFFFFF"/>
+                      <a:srgbClr val="F4F7F8"/>
                     </a:solidFill>
                   </a:tcPr>
                 </a:tc>
@@ -3341,7 +3203,7 @@
                       <a:tailEnd type="none" w="med" len="med"/>
                     </a:lnB>
                     <a:solidFill>
-                      <a:srgbClr val="FFFFFF"/>
+                      <a:srgbClr val="F4F7F8"/>
                     </a:solidFill>
                   </a:tcPr>
                 </a:tc>
@@ -3411,7 +3273,7 @@
                       <a:tailEnd type="none" w="med" len="med"/>
                     </a:lnB>
                     <a:solidFill>
-                      <a:srgbClr val="F4F7F8"/>
+                      <a:srgbClr val="FFFFFF"/>
                     </a:solidFill>
                   </a:tcPr>
                 </a:tc>
@@ -3433,144 +3295,6 @@
                           <a:cs typeface="Calibri" pitchFamily="34" charset="-120"/>
                         </a:rPr>
                         <a:t>Início da Unidade 2</a:t>
-                      </a:r>
-                      <a:endParaRPr lang="en-US" sz="1200" dirty="0">
-                        <a:latin typeface="Calibri" charset="0"/>
-                        <a:ea typeface="Calibri" charset="0"/>
-                        <a:cs typeface="Calibri" charset="0"/>
-                      </a:endParaRPr>
-                    </a:p>
-                  </a:txBody>
-                  <a:tcPr marL="50800" marR="50800" marT="50800" marB="50800" anchor="ctr">
-                    <a:lnL w="9525" cap="flat" cmpd="sng" algn="ctr">
-                      <a:solidFill>
-                        <a:srgbClr val="DCD5C1"/>
-                      </a:solidFill>
-                      <a:prstDash val="solid"/>
-                      <a:round/>
-                      <a:headEnd type="none" w="med" len="med"/>
-                      <a:tailEnd type="none" w="med" len="med"/>
-                    </a:lnL>
-                    <a:lnR w="9525" cap="flat" cmpd="sng" algn="ctr">
-                      <a:solidFill>
-                        <a:srgbClr val="DCD5C1"/>
-                      </a:solidFill>
-                      <a:prstDash val="solid"/>
-                      <a:round/>
-                      <a:headEnd type="none" w="med" len="med"/>
-                      <a:tailEnd type="none" w="med" len="med"/>
-                    </a:lnR>
-                    <a:lnT w="9525" cap="flat" cmpd="sng" algn="ctr">
-                      <a:solidFill>
-                        <a:srgbClr val="DCD5C1"/>
-                      </a:solidFill>
-                      <a:prstDash val="solid"/>
-                      <a:round/>
-                      <a:headEnd type="none" w="med" len="med"/>
-                      <a:tailEnd type="none" w="med" len="med"/>
-                    </a:lnT>
-                    <a:lnB w="9525" cap="flat" cmpd="sng" algn="ctr">
-                      <a:solidFill>
-                        <a:srgbClr val="DCD5C1"/>
-                      </a:solidFill>
-                      <a:prstDash val="solid"/>
-                      <a:round/>
-                      <a:headEnd type="none" w="med" len="med"/>
-                      <a:tailEnd type="none" w="med" len="med"/>
-                    </a:lnB>
-                    <a:solidFill>
-                      <a:srgbClr val="F4F7F8"/>
-                    </a:solidFill>
-                  </a:tcPr>
-                </a:tc>
-              </a:tr>
-              <a:tr h="0">
-                <a:tc>
-                  <a:txBody>
-                    <a:bodyPr/>
-                    <a:lstStyle/>
-                    <a:p>
-                      <a:pPr indent="0" marL="0">
-                        <a:buNone/>
-                      </a:pPr>
-                      <a:r>
-                        <a:rPr lang="en-US" sz="1200" dirty="0">
-                          <a:solidFill>
-                            <a:srgbClr val="1F2A37"/>
-                          </a:solidFill>
-                          <a:latin typeface="Calibri" pitchFamily="34" charset="0"/>
-                          <a:ea typeface="Calibri" pitchFamily="34" charset="-122"/>
-                          <a:cs typeface="Calibri" pitchFamily="34" charset="-120"/>
-                        </a:rPr>
-                        <a:t>21/10 (qua)</a:t>
-                      </a:r>
-                      <a:endParaRPr lang="en-US" sz="1200" dirty="0">
-                        <a:latin typeface="Calibri" charset="0"/>
-                        <a:ea typeface="Calibri" charset="0"/>
-                        <a:cs typeface="Calibri" charset="0"/>
-                      </a:endParaRPr>
-                    </a:p>
-                  </a:txBody>
-                  <a:tcPr marL="50800" marR="50800" marT="50800" marB="50800" anchor="ctr">
-                    <a:lnL w="9525" cap="flat" cmpd="sng" algn="ctr">
-                      <a:solidFill>
-                        <a:srgbClr val="DCD5C1"/>
-                      </a:solidFill>
-                      <a:prstDash val="solid"/>
-                      <a:round/>
-                      <a:headEnd type="none" w="med" len="med"/>
-                      <a:tailEnd type="none" w="med" len="med"/>
-                    </a:lnL>
-                    <a:lnR w="9525" cap="flat" cmpd="sng" algn="ctr">
-                      <a:solidFill>
-                        <a:srgbClr val="DCD5C1"/>
-                      </a:solidFill>
-                      <a:prstDash val="solid"/>
-                      <a:round/>
-                      <a:headEnd type="none" w="med" len="med"/>
-                      <a:tailEnd type="none" w="med" len="med"/>
-                    </a:lnR>
-                    <a:lnT w="9525" cap="flat" cmpd="sng" algn="ctr">
-                      <a:solidFill>
-                        <a:srgbClr val="DCD5C1"/>
-                      </a:solidFill>
-                      <a:prstDash val="solid"/>
-                      <a:round/>
-                      <a:headEnd type="none" w="med" len="med"/>
-                      <a:tailEnd type="none" w="med" len="med"/>
-                    </a:lnT>
-                    <a:lnB w="9525" cap="flat" cmpd="sng" algn="ctr">
-                      <a:solidFill>
-                        <a:srgbClr val="DCD5C1"/>
-                      </a:solidFill>
-                      <a:prstDash val="solid"/>
-                      <a:round/>
-                      <a:headEnd type="none" w="med" len="med"/>
-                      <a:tailEnd type="none" w="med" len="med"/>
-                    </a:lnB>
-                    <a:solidFill>
-                      <a:srgbClr val="FFFFFF"/>
-                    </a:solidFill>
-                  </a:tcPr>
-                </a:tc>
-                <a:tc>
-                  <a:txBody>
-                    <a:bodyPr/>
-                    <a:lstStyle/>
-                    <a:p>
-                      <a:pPr indent="0" marL="0">
-                        <a:buNone/>
-                      </a:pPr>
-                      <a:r>
-                        <a:rPr lang="en-US" sz="1200" dirty="0">
-                          <a:solidFill>
-                            <a:srgbClr val="1F2A37"/>
-                          </a:solidFill>
-                          <a:latin typeface="Calibri" pitchFamily="34" charset="0"/>
-                          <a:ea typeface="Calibri" pitchFamily="34" charset="-122"/>
-                          <a:cs typeface="Calibri" pitchFamily="34" charset="-120"/>
-                        </a:rPr>
-                        <a:t>2ª webaula</a:t>
                       </a:r>
                       <a:endParaRPr lang="en-US" sz="1200" dirty="0">
                         <a:latin typeface="Calibri" charset="0"/>
@@ -3778,7 +3502,7 @@
                           <a:ea typeface="Calibri" pitchFamily="34" charset="-122"/>
                           <a:cs typeface="Calibri" pitchFamily="34" charset="-120"/>
                         </a:rPr>
-                        <a:t>28/10 (qua)</a:t>
+                        <a:t>26/10 (seg)</a:t>
                       </a:r>
                       <a:endParaRPr lang="en-US" sz="1200" dirty="0">
                         <a:latin typeface="Calibri" charset="0"/>
@@ -3846,7 +3570,7 @@
                           <a:ea typeface="Calibri" pitchFamily="34" charset="-122"/>
                           <a:cs typeface="Calibri" pitchFamily="34" charset="-120"/>
                         </a:rPr>
-                        <a:t>Unidade 3 · 3ª webaula</a:t>
+                        <a:t>Início da Unidade 3</a:t>
                       </a:r>
                       <a:endParaRPr lang="en-US" sz="1200" dirty="0">
                         <a:latin typeface="Calibri" charset="0"/>
@@ -3894,6 +3618,144 @@
                     </a:lnB>
                     <a:solidFill>
                       <a:srgbClr val="FFFFFF"/>
+                    </a:solidFill>
+                  </a:tcPr>
+                </a:tc>
+              </a:tr>
+              <a:tr h="0">
+                <a:tc>
+                  <a:txBody>
+                    <a:bodyPr/>
+                    <a:lstStyle/>
+                    <a:p>
+                      <a:pPr indent="0" marL="0">
+                        <a:buNone/>
+                      </a:pPr>
+                      <a:r>
+                        <a:rPr lang="en-US" sz="1200" dirty="0">
+                          <a:solidFill>
+                            <a:srgbClr val="1F2A37"/>
+                          </a:solidFill>
+                          <a:latin typeface="Calibri" pitchFamily="34" charset="0"/>
+                          <a:ea typeface="Calibri" pitchFamily="34" charset="-122"/>
+                          <a:cs typeface="Calibri" pitchFamily="34" charset="-120"/>
+                        </a:rPr>
+                        <a:t>28/10 (qua)</a:t>
+                      </a:r>
+                      <a:endParaRPr lang="en-US" sz="1200" dirty="0">
+                        <a:latin typeface="Calibri" charset="0"/>
+                        <a:ea typeface="Calibri" charset="0"/>
+                        <a:cs typeface="Calibri" charset="0"/>
+                      </a:endParaRPr>
+                    </a:p>
+                  </a:txBody>
+                  <a:tcPr marL="50800" marR="50800" marT="50800" marB="50800" anchor="ctr">
+                    <a:lnL w="9525" cap="flat" cmpd="sng" algn="ctr">
+                      <a:solidFill>
+                        <a:srgbClr val="DCD5C1"/>
+                      </a:solidFill>
+                      <a:prstDash val="solid"/>
+                      <a:round/>
+                      <a:headEnd type="none" w="med" len="med"/>
+                      <a:tailEnd type="none" w="med" len="med"/>
+                    </a:lnL>
+                    <a:lnR w="9525" cap="flat" cmpd="sng" algn="ctr">
+                      <a:solidFill>
+                        <a:srgbClr val="DCD5C1"/>
+                      </a:solidFill>
+                      <a:prstDash val="solid"/>
+                      <a:round/>
+                      <a:headEnd type="none" w="med" len="med"/>
+                      <a:tailEnd type="none" w="med" len="med"/>
+                    </a:lnR>
+                    <a:lnT w="9525" cap="flat" cmpd="sng" algn="ctr">
+                      <a:solidFill>
+                        <a:srgbClr val="DCD5C1"/>
+                      </a:solidFill>
+                      <a:prstDash val="solid"/>
+                      <a:round/>
+                      <a:headEnd type="none" w="med" len="med"/>
+                      <a:tailEnd type="none" w="med" len="med"/>
+                    </a:lnT>
+                    <a:lnB w="9525" cap="flat" cmpd="sng" algn="ctr">
+                      <a:solidFill>
+                        <a:srgbClr val="DCD5C1"/>
+                      </a:solidFill>
+                      <a:prstDash val="solid"/>
+                      <a:round/>
+                      <a:headEnd type="none" w="med" len="med"/>
+                      <a:tailEnd type="none" w="med" len="med"/>
+                    </a:lnB>
+                    <a:solidFill>
+                      <a:srgbClr val="F4F7F8"/>
+                    </a:solidFill>
+                  </a:tcPr>
+                </a:tc>
+                <a:tc>
+                  <a:txBody>
+                    <a:bodyPr/>
+                    <a:lstStyle/>
+                    <a:p>
+                      <a:pPr indent="0" marL="0">
+                        <a:buNone/>
+                      </a:pPr>
+                      <a:r>
+                        <a:rPr lang="en-US" sz="1200" b="1" dirty="0">
+                          <a:solidFill>
+                            <a:srgbClr val="1F2A37"/>
+                          </a:solidFill>
+                          <a:latin typeface="Calibri" pitchFamily="34" charset="0"/>
+                          <a:ea typeface="Calibri" pitchFamily="34" charset="-122"/>
+                          <a:cs typeface="Calibri" pitchFamily="34" charset="-120"/>
+                        </a:rPr>
+                        <a:t>Encontro síncrono, 19h–20h30</a:t>
+                      </a:r>
+                      <a:endParaRPr lang="en-US" sz="1200" dirty="0">
+                        <a:latin typeface="Calibri" charset="0"/>
+                        <a:ea typeface="Calibri" charset="0"/>
+                        <a:cs typeface="Calibri" charset="0"/>
+                      </a:endParaRPr>
+                    </a:p>
+                  </a:txBody>
+                  <a:tcPr marL="50800" marR="50800" marT="50800" marB="50800" anchor="ctr">
+                    <a:lnL w="9525" cap="flat" cmpd="sng" algn="ctr">
+                      <a:solidFill>
+                        <a:srgbClr val="DCD5C1"/>
+                      </a:solidFill>
+                      <a:prstDash val="solid"/>
+                      <a:round/>
+                      <a:headEnd type="none" w="med" len="med"/>
+                      <a:tailEnd type="none" w="med" len="med"/>
+                    </a:lnL>
+                    <a:lnR w="9525" cap="flat" cmpd="sng" algn="ctr">
+                      <a:solidFill>
+                        <a:srgbClr val="DCD5C1"/>
+                      </a:solidFill>
+                      <a:prstDash val="solid"/>
+                      <a:round/>
+                      <a:headEnd type="none" w="med" len="med"/>
+                      <a:tailEnd type="none" w="med" len="med"/>
+                    </a:lnR>
+                    <a:lnT w="9525" cap="flat" cmpd="sng" algn="ctr">
+                      <a:solidFill>
+                        <a:srgbClr val="DCD5C1"/>
+                      </a:solidFill>
+                      <a:prstDash val="solid"/>
+                      <a:round/>
+                      <a:headEnd type="none" w="med" len="med"/>
+                      <a:tailEnd type="none" w="med" len="med"/>
+                    </a:lnT>
+                    <a:lnB w="9525" cap="flat" cmpd="sng" algn="ctr">
+                      <a:solidFill>
+                        <a:srgbClr val="DCD5C1"/>
+                      </a:solidFill>
+                      <a:prstDash val="solid"/>
+                      <a:round/>
+                      <a:headEnd type="none" w="med" len="med"/>
+                      <a:tailEnd type="none" w="med" len="med"/>
+                    </a:lnB>
+                    <a:solidFill>
+                      <a:srgbClr val="F4F7F8"/>
                     </a:solidFill>
                   </a:tcPr>
                 </a:tc>
@@ -4360,144 +4222,6 @@
                           <a:ea typeface="Calibri" pitchFamily="34" charset="-122"/>
                           <a:cs typeface="Calibri" pitchFamily="34" charset="-120"/>
                         </a:rPr>
-                        <a:t>04/11 (qua)</a:t>
-                      </a:r>
-                      <a:endParaRPr lang="en-US" sz="1200" dirty="0">
-                        <a:latin typeface="Calibri" charset="0"/>
-                        <a:ea typeface="Calibri" charset="0"/>
-                        <a:cs typeface="Calibri" charset="0"/>
-                      </a:endParaRPr>
-                    </a:p>
-                  </a:txBody>
-                  <a:tcPr marL="50800" marR="50800" marT="50800" marB="50800" anchor="ctr">
-                    <a:lnL w="9525" cap="flat" cmpd="sng" algn="ctr">
-                      <a:solidFill>
-                        <a:srgbClr val="DCD5C1"/>
-                      </a:solidFill>
-                      <a:prstDash val="solid"/>
-                      <a:round/>
-                      <a:headEnd type="none" w="med" len="med"/>
-                      <a:tailEnd type="none" w="med" len="med"/>
-                    </a:lnL>
-                    <a:lnR w="9525" cap="flat" cmpd="sng" algn="ctr">
-                      <a:solidFill>
-                        <a:srgbClr val="DCD5C1"/>
-                      </a:solidFill>
-                      <a:prstDash val="solid"/>
-                      <a:round/>
-                      <a:headEnd type="none" w="med" len="med"/>
-                      <a:tailEnd type="none" w="med" len="med"/>
-                    </a:lnR>
-                    <a:lnT w="9525" cap="flat" cmpd="sng" algn="ctr">
-                      <a:solidFill>
-                        <a:srgbClr val="DCD5C1"/>
-                      </a:solidFill>
-                      <a:prstDash val="solid"/>
-                      <a:round/>
-                      <a:headEnd type="none" w="med" len="med"/>
-                      <a:tailEnd type="none" w="med" len="med"/>
-                    </a:lnT>
-                    <a:lnB w="9525" cap="flat" cmpd="sng" algn="ctr">
-                      <a:solidFill>
-                        <a:srgbClr val="DCD5C1"/>
-                      </a:solidFill>
-                      <a:prstDash val="solid"/>
-                      <a:round/>
-                      <a:headEnd type="none" w="med" len="med"/>
-                      <a:tailEnd type="none" w="med" len="med"/>
-                    </a:lnB>
-                    <a:solidFill>
-                      <a:srgbClr val="FFFFFF"/>
-                    </a:solidFill>
-                  </a:tcPr>
-                </a:tc>
-                <a:tc>
-                  <a:txBody>
-                    <a:bodyPr/>
-                    <a:lstStyle/>
-                    <a:p>
-                      <a:pPr indent="0" marL="0">
-                        <a:buNone/>
-                      </a:pPr>
-                      <a:r>
-                        <a:rPr lang="en-US" sz="1200" dirty="0">
-                          <a:solidFill>
-                            <a:srgbClr val="1F2A37"/>
-                          </a:solidFill>
-                          <a:latin typeface="Calibri" pitchFamily="34" charset="0"/>
-                          <a:ea typeface="Calibri" pitchFamily="34" charset="-122"/>
-                          <a:cs typeface="Calibri" pitchFamily="34" charset="-120"/>
-                        </a:rPr>
-                        <a:t>4ª webaula</a:t>
-                      </a:r>
-                      <a:endParaRPr lang="en-US" sz="1200" dirty="0">
-                        <a:latin typeface="Calibri" charset="0"/>
-                        <a:ea typeface="Calibri" charset="0"/>
-                        <a:cs typeface="Calibri" charset="0"/>
-                      </a:endParaRPr>
-                    </a:p>
-                  </a:txBody>
-                  <a:tcPr marL="50800" marR="50800" marT="50800" marB="50800" anchor="ctr">
-                    <a:lnL w="9525" cap="flat" cmpd="sng" algn="ctr">
-                      <a:solidFill>
-                        <a:srgbClr val="DCD5C1"/>
-                      </a:solidFill>
-                      <a:prstDash val="solid"/>
-                      <a:round/>
-                      <a:headEnd type="none" w="med" len="med"/>
-                      <a:tailEnd type="none" w="med" len="med"/>
-                    </a:lnL>
-                    <a:lnR w="9525" cap="flat" cmpd="sng" algn="ctr">
-                      <a:solidFill>
-                        <a:srgbClr val="DCD5C1"/>
-                      </a:solidFill>
-                      <a:prstDash val="solid"/>
-                      <a:round/>
-                      <a:headEnd type="none" w="med" len="med"/>
-                      <a:tailEnd type="none" w="med" len="med"/>
-                    </a:lnR>
-                    <a:lnT w="9525" cap="flat" cmpd="sng" algn="ctr">
-                      <a:solidFill>
-                        <a:srgbClr val="DCD5C1"/>
-                      </a:solidFill>
-                      <a:prstDash val="solid"/>
-                      <a:round/>
-                      <a:headEnd type="none" w="med" len="med"/>
-                      <a:tailEnd type="none" w="med" len="med"/>
-                    </a:lnT>
-                    <a:lnB w="9525" cap="flat" cmpd="sng" algn="ctr">
-                      <a:solidFill>
-                        <a:srgbClr val="DCD5C1"/>
-                      </a:solidFill>
-                      <a:prstDash val="solid"/>
-                      <a:round/>
-                      <a:headEnd type="none" w="med" len="med"/>
-                      <a:tailEnd type="none" w="med" len="med"/>
-                    </a:lnB>
-                    <a:solidFill>
-                      <a:srgbClr val="FFFFFF"/>
-                    </a:solidFill>
-                  </a:tcPr>
-                </a:tc>
-              </a:tr>
-              <a:tr h="0">
-                <a:tc>
-                  <a:txBody>
-                    <a:bodyPr/>
-                    <a:lstStyle/>
-                    <a:p>
-                      <a:pPr indent="0" marL="0">
-                        <a:buNone/>
-                      </a:pPr>
-                      <a:r>
-                        <a:rPr lang="en-US" sz="1200" dirty="0">
-                          <a:solidFill>
-                            <a:srgbClr val="1F2A37"/>
-                          </a:solidFill>
-                          <a:latin typeface="Calibri" pitchFamily="34" charset="0"/>
-                          <a:ea typeface="Calibri" pitchFamily="34" charset="-122"/>
-                          <a:cs typeface="Calibri" pitchFamily="34" charset="-120"/>
-                        </a:rPr>
                         <a:t>08/11 (dom)</a:t>
                       </a:r>
                       <a:endParaRPr lang="en-US" sz="1200" dirty="0">
@@ -4545,7 +4269,7 @@
                       <a:tailEnd type="none" w="med" len="med"/>
                     </a:lnB>
                     <a:solidFill>
-                      <a:srgbClr val="F4F7F8"/>
+                      <a:srgbClr val="FFFFFF"/>
                     </a:solidFill>
                   </a:tcPr>
                 </a:tc>
@@ -4613,7 +4337,7 @@
                       <a:tailEnd type="none" w="med" len="med"/>
                     </a:lnB>
                     <a:solidFill>
-                      <a:srgbClr val="F4F7F8"/>
+                      <a:srgbClr val="FFFFFF"/>
                     </a:solidFill>
                   </a:tcPr>
                 </a:tc>
@@ -4636,7 +4360,7 @@
                           <a:ea typeface="Calibri" pitchFamily="34" charset="-122"/>
                           <a:cs typeface="Calibri" pitchFamily="34" charset="-120"/>
                         </a:rPr>
-                        <a:t>11/11 (qua)</a:t>
+                        <a:t>09/11 (seg)</a:t>
                       </a:r>
                       <a:endParaRPr lang="en-US" sz="1200" dirty="0">
                         <a:latin typeface="Calibri" charset="0"/>
@@ -4683,7 +4407,7 @@
                       <a:tailEnd type="none" w="med" len="med"/>
                     </a:lnB>
                     <a:solidFill>
-                      <a:srgbClr val="FFFFFF"/>
+                      <a:srgbClr val="F4F7F8"/>
                     </a:solidFill>
                   </a:tcPr>
                 </a:tc>
@@ -4704,7 +4428,7 @@
                           <a:ea typeface="Calibri" pitchFamily="34" charset="-122"/>
                           <a:cs typeface="Calibri" pitchFamily="34" charset="-120"/>
                         </a:rPr>
-                        <a:t>5ª webaula: revisão</a:t>
+                        <a:t>Semana de revisão</a:t>
                       </a:r>
                       <a:endParaRPr lang="en-US" sz="1200" dirty="0">
                         <a:latin typeface="Calibri" charset="0"/>
@@ -4751,7 +4475,7 @@
                       <a:tailEnd type="none" w="med" len="med"/>
                     </a:lnB>
                     <a:solidFill>
-                      <a:srgbClr val="FFFFFF"/>
+                      <a:srgbClr val="F4F7F8"/>
                     </a:solidFill>
                   </a:tcPr>
                 </a:tc>
@@ -4821,7 +4545,7 @@
                       <a:tailEnd type="none" w="med" len="med"/>
                     </a:lnB>
                     <a:solidFill>
-                      <a:srgbClr val="F4F7F8"/>
+                      <a:srgbClr val="FFFFFF"/>
                     </a:solidFill>
                   </a:tcPr>
                 </a:tc>
@@ -4889,7 +4613,7 @@
                       <a:tailEnd type="none" w="med" len="med"/>
                     </a:lnB>
                     <a:solidFill>
-                      <a:srgbClr val="F4F7F8"/>
+                      <a:srgbClr val="FFFFFF"/>
                     </a:solidFill>
                   </a:tcPr>
                 </a:tc>
@@ -4959,7 +4683,7 @@
                       <a:tailEnd type="none" w="med" len="med"/>
                     </a:lnB>
                     <a:solidFill>
-                      <a:srgbClr val="FFFFFF"/>
+                      <a:srgbClr val="F4F7F8"/>
                     </a:solidFill>
                   </a:tcPr>
                 </a:tc>
@@ -5027,7 +4751,7 @@
                       <a:tailEnd type="none" w="med" len="med"/>
                     </a:lnB>
                     <a:solidFill>
-                      <a:srgbClr val="FFFFFF"/>
+                      <a:srgbClr val="F4F7F8"/>
                     </a:solidFill>
                   </a:tcPr>
                 </a:tc>
@@ -5579,7 +5303,7 @@
                 <a:ea typeface="Calibri" pitchFamily="34" charset="-122"/>
                 <a:cs typeface="Calibri" pitchFamily="34" charset="-120"/>
               </a:rPr>
-              <a:t>do fórum e da webaula de quarta-feira.</a:t>
+              <a:t>dos fóruns e do encontro síncrono (28/10).</a:t>
             </a:r>
             <a:endParaRPr lang="en-US" sz="3000" dirty="0"/>
           </a:p>
@@ -6238,7 +5962,7 @@
                 <a:ea typeface="Calibri" pitchFamily="34" charset="-122"/>
                 <a:cs typeface="Calibri" pitchFamily="34" charset="-120"/>
               </a:rPr>
-              <a:t>3. Aula inaugural</a:t>
+              <a:t>3. Anote na agenda</a:t>
             </a:r>
             <a:endParaRPr lang="en-US" sz="1600" dirty="0"/>
           </a:p>
@@ -6258,7 +5982,7 @@
                 <a:ea typeface="Calibri" pitchFamily="34" charset="-122"/>
                 <a:cs typeface="Calibri" pitchFamily="34" charset="-120"/>
               </a:rPr>
-              <a:t>Webaula em 14/10, quarta-feira, às 19h.</a:t>
+              <a:t>Encontro síncrono em 28/10, quarta-feira, às 19h.</a:t>
             </a:r>
             <a:endParaRPr lang="en-US" sz="1600" dirty="0"/>
           </a:p>
@@ -7096,7 +6820,7 @@
                 <a:ea typeface="Calibri" pitchFamily="34" charset="-122"/>
                 <a:cs typeface="Calibri" pitchFamily="34" charset="-120"/>
               </a:rPr>
-              <a:t>22,5 h assíncronas no SIGAA · 7,5 h síncronas (5 webaulas de 1h30)</a:t>
+              <a:t>28,5 h assíncronas no SIGAA · 1,5 h síncrona (encontro virtual em 28/10, 19h)</a:t>
             </a:r>
             <a:endParaRPr lang="en-US" sz="1500" dirty="0"/>
           </a:p>
@@ -9122,7 +8846,7 @@
                 <a:ea typeface="Calibri" pitchFamily="34" charset="-122"/>
                 <a:cs typeface="Calibri" pitchFamily="34" charset="-120"/>
               </a:rPr>
-              <a:t>De 09/11 a 15/11: semana de revisão, webaula de revisão e Avaliação A3.</a:t>
+              <a:t>Encontro síncrono único: 28/10, às 19h. De 09/11 a 15/11: revisão e Avaliação A3.</a:t>
             </a:r>
             <a:endParaRPr lang="en-US" sz="1400" dirty="0"/>
           </a:p>
@@ -9777,11 +9501,11 @@
         <p:spPr>
           <a:xfrm>
             <a:off x="685800" y="1298448"/>
-            <a:ext cx="2456688" cy="2450592"/>
+            <a:ext cx="2456688" cy="2286000"/>
           </a:xfrm>
           <a:prstGeom prst="roundRect">
             <a:avLst>
-              <a:gd name="adj" fmla="val 2239"/>
+              <a:gd name="adj" fmla="val 2400"/>
             </a:avLst>
           </a:prstGeom>
           <a:solidFill>
@@ -9850,7 +9574,7 @@
         <p:spPr>
           <a:xfrm>
             <a:off x="1371600" y="1371600"/>
-            <a:ext cx="1679448" cy="2304288"/>
+            <a:ext cx="1679448" cy="2139696"/>
           </a:xfrm>
           <a:prstGeom prst="rect">
             <a:avLst/>
@@ -9880,7 +9604,7 @@
                 <a:ea typeface="Calibri" pitchFamily="34" charset="-122"/>
                 <a:cs typeface="Calibri" pitchFamily="34" charset="-120"/>
               </a:rPr>
-              <a:t>22,5 H ASSÍNCRONAS</a:t>
+              <a:t>28,5 H ASSÍNCRONAS</a:t>
             </a:r>
             <a:endParaRPr lang="en-US" sz="1100" dirty="0"/>
           </a:p>
@@ -9938,11 +9662,11 @@
         <p:spPr>
           <a:xfrm>
             <a:off x="3343656" y="1298448"/>
-            <a:ext cx="2456688" cy="2450592"/>
+            <a:ext cx="2456688" cy="2286000"/>
           </a:xfrm>
           <a:prstGeom prst="roundRect">
             <a:avLst>
-              <a:gd name="adj" fmla="val 2239"/>
+              <a:gd name="adj" fmla="val 2400"/>
             </a:avLst>
           </a:prstGeom>
           <a:solidFill>
@@ -10011,7 +9735,7 @@
         <p:spPr>
           <a:xfrm>
             <a:off x="4029456" y="1371600"/>
-            <a:ext cx="1679448" cy="2304288"/>
+            <a:ext cx="1679448" cy="2139696"/>
           </a:xfrm>
           <a:prstGeom prst="rect">
             <a:avLst/>
@@ -10041,7 +9765,7 @@
                 <a:ea typeface="Calibri" pitchFamily="34" charset="-122"/>
                 <a:cs typeface="Calibri" pitchFamily="34" charset="-120"/>
               </a:rPr>
-              <a:t>7,5 H SÍNCRONAS</a:t>
+              <a:t>1,5 H SÍNCRONA</a:t>
             </a:r>
             <a:endParaRPr lang="en-US" sz="1100" dirty="0"/>
           </a:p>
@@ -10064,7 +9788,7 @@
                 <a:ea typeface="Calibri" pitchFamily="34" charset="-122"/>
                 <a:cs typeface="Calibri" pitchFamily="34" charset="-120"/>
               </a:rPr>
-              <a:t>A conexão</a:t>
+              <a:t>O encontro</a:t>
             </a:r>
             <a:endParaRPr lang="en-US" sz="1100" dirty="0"/>
           </a:p>
@@ -10084,7 +9808,7 @@
                 <a:ea typeface="Calibri" pitchFamily="34" charset="-122"/>
                 <a:cs typeface="Calibri" pitchFamily="34" charset="-120"/>
               </a:rPr>
-              <a:t>Cinco webaulas de 1h30 no Google Meet, às quartas-feiras, às 19h: 14/10, 21/10, 28/10, 04/11 e 11/11.</a:t>
+              <a:t>Um encontro virtual no Google Meet: quarta-feira, 28/10, das 19h às 20h30. Revisão das Unidades 1 a 3 e orientações para A2 e A3.</a:t>
             </a:r>
             <a:endParaRPr lang="en-US" sz="1100" dirty="0"/>
           </a:p>
@@ -10099,11 +9823,11 @@
         <p:spPr>
           <a:xfrm>
             <a:off x="6001512" y="1298448"/>
-            <a:ext cx="2456688" cy="2450592"/>
+            <a:ext cx="2456688" cy="2286000"/>
           </a:xfrm>
           <a:prstGeom prst="roundRect">
             <a:avLst>
-              <a:gd name="adj" fmla="val 2239"/>
+              <a:gd name="adj" fmla="val 2400"/>
             </a:avLst>
           </a:prstGeom>
           <a:solidFill>
@@ -10172,7 +9896,7 @@
         <p:spPr>
           <a:xfrm>
             <a:off x="6687312" y="1371600"/>
-            <a:ext cx="1679448" cy="2304288"/>
+            <a:ext cx="1679448" cy="2139696"/>
           </a:xfrm>
           <a:prstGeom prst="rect">
             <a:avLst/>
@@ -10259,12 +9983,12 @@
         </p:nvSpPr>
         <p:spPr>
           <a:xfrm>
-            <a:off x="685800" y="3904488"/>
-            <a:ext cx="7772400" cy="475488"/>
+            <a:off x="685800" y="3730752"/>
+            <a:ext cx="7772400" cy="658368"/>
           </a:xfrm>
           <a:prstGeom prst="roundRect">
             <a:avLst>
-              <a:gd name="adj" fmla="val 15385"/>
+              <a:gd name="adj" fmla="val 11111"/>
             </a:avLst>
           </a:prstGeom>
           <a:solidFill>
@@ -10291,7 +10015,7 @@
                 <a:ea typeface="Calibri" pitchFamily="34" charset="-122"/>
                 <a:cs typeface="Calibri" pitchFamily="34" charset="-120"/>
               </a:rPr>
-              <a:t>Frequência mínima de 75% nas atividades síncronas (PPC).</a:t>
+              <a:t>Presença obrigatória no encontro síncrono (PPC: 75% de frequência nas atividades síncronas).</a:t>
             </a:r>
             <a:endParaRPr lang="en-US" sz="1400" dirty="0"/>
           </a:p>

</xml_diff>

<commit_message>
EGM: slide e seção Fóruns da disciplina na apresentação
Co-Authored-By: Claude Opus 5.5 <noreply@anthropic.com>
Claude-Session: https://claude.ai/code/session_01PyQDDPKwUxu1Vg7o8uyr7W
</commit_message>
<xml_diff>
--- a/disciplina-01-estado-governo-mercado/materiais/00_Videoaula_de_Apresentacao.pptx
+++ b/disciplina-01-estado-governo-mercado/materiais/00_Videoaula_de_Apresentacao.pptx
@@ -18,9 +18,10 @@
     <p:sldId id="266" r:id="rId12"/>
     <p:sldId id="267" r:id="rId13"/>
     <p:sldId id="268" r:id="rId14"/>
+    <p:sldId id="269" r:id="rId15"/>
   </p:sldIdLst>
   <p:notesMasterIdLst>
-    <p:notesMasterId r:id="rId15"/>
+    <p:notesMasterId r:id="rId16"/>
   </p:notesMasterIdLst>
   <p:sldSz cx="9144000" cy="5143500"/>
   <p:notesSz cx="5143500" cy="9144000"/>
@@ -602,7 +603,7 @@
           <a:p>
             <a:r>
               <a:rPr lang="en-US" dirty="0"/>
-              <a:t>Quem perder uma avaliação por motivo justificado pode requerer a 2ª chamada, com documento comprobatório. Quem não atingir a nota de aprovação pode fazer a Prova Final, conforme as normas da UNEMAT. As datas são definidas pela Coordenação.</a:t>
+              <a:t>São três avaliações a distância. A A1, até 25 de outubro, e a A2, até 8 de novembro, são questionários de dez questões. A A3, até 15 de novembro, tem dez questões objetivas e um estudo de caso discursivo. A média de A1 e A2 vale 40% e a A3 vale 60%. A aprovação exige nota 7,0 e 75% de frequência.</a:t>
             </a:r>
             <a:endParaRPr lang="en-US" dirty="0"/>
           </a:p>
@@ -690,7 +691,7 @@
           <a:p>
             <a:r>
               <a:rPr lang="en-US" dirty="0"/>
-              <a:t>Este é o mapa do bloco. Anote as datas: o encontro síncrono é no dia 28 de outubro, às 19h; A1 até 25 de outubro; A2 até 8 de novembro; A3 até 15 de novembro, quando a disciplina se encerra. Todas as entregas até 23h55.</a:t>
+              <a:t>Quem perder uma avaliação por motivo justificado pode requerer a 2ª chamada, com documento comprobatório. Quem não atingir a nota de aprovação pode fazer a Prova Final, conforme as normas da UNEMAT. As datas são definidas pela Coordenação.</a:t>
             </a:r>
             <a:endParaRPr lang="en-US" dirty="0"/>
           </a:p>
@@ -778,7 +779,7 @@
           <a:p>
             <a:r>
               <a:rPr lang="en-US" dirty="0"/>
-              <a:t>Sugestão de rotina: assista à videoaula, leia o livro e a página de conteúdos, revise com os slides e os exercícios de fixação, participe dos fóruns e do encontro síncrono e entregue as atividades antes das 23h55 do prazo.</a:t>
+              <a:t>Este é o mapa do bloco. Anote as datas: o encontro síncrono é no dia 28 de outubro, às 19h; A1 até 25 de outubro; A2 até 8 de novembro; A3 até 15 de novembro, quando a disciplina se encerra. Todas as entregas até 23h55.</a:t>
             </a:r>
             <a:endParaRPr lang="en-US" dirty="0"/>
           </a:p>
@@ -866,7 +867,7 @@
           <a:p>
             <a:r>
               <a:rPr lang="en-US" dirty="0"/>
-              <a:t>Para começar: acesse o SIGAA, apresente-se no fórum até 18 de outubro e anote na agenda o nosso encontro síncrono, em 28 de outubro, às 19h. Bons estudos!</a:t>
+              <a:t>Sugestão de rotina: assista à videoaula, leia o livro e a página de conteúdos, revise com os slides e os exercícios de fixação, participe dos fóruns e do encontro síncrono e entregue as atividades antes das 23h55 do prazo.</a:t>
             </a:r>
             <a:endParaRPr lang="en-US" dirty="0"/>
           </a:p>
@@ -890,6 +891,94 @@
             <a:fld id="{F7021451-1387-4CA6-816F-3879F97B5CBC}" type="slidenum">
               <a:rPr lang="en-US"/>
               <a:t>13</a:t>
+            </a:fld>
+            <a:endParaRPr lang="en-US"/>
+          </a:p>
+        </p:txBody>
+      </p:sp>
+    </p:spTree>
+    <p:extLst>
+      <p:ext uri="{BB962C8B-B14F-4D97-AF65-F5344CB8AC3E}">
+        <p14:creationId xmlns:p14="http://schemas.microsoft.com/office/powerpoint/2010/main" val="1024086991"/>
+      </p:ext>
+    </p:extLst>
+  </p:cSld>
+  <p:clrMapOvr>
+    <a:masterClrMapping/>
+  </p:clrMapOvr>
+</p:notes>
+</file>
+
+<file path=ppt/notesSlides/notesSlide14.xml><?xml version="1.0" encoding="utf-8"?>
+<p:notes xmlns:a="http://schemas.openxmlformats.org/drawingml/2006/main" xmlns:r="http://schemas.openxmlformats.org/officeDocument/2006/relationships" xmlns:p="http://schemas.openxmlformats.org/presentationml/2006/main">
+  <p:cSld>
+    <p:spTree>
+      <p:nvGrpSpPr>
+        <p:cNvPr id="1" name=""/>
+        <p:cNvGrpSpPr/>
+        <p:nvPr/>
+      </p:nvGrpSpPr>
+      <p:grpSpPr>
+        <a:xfrm>
+          <a:off x="0" y="0"/>
+          <a:ext cx="0" cy="0"/>
+          <a:chOff x="0" y="0"/>
+          <a:chExt cx="0" cy="0"/>
+        </a:xfrm>
+      </p:grpSpPr>
+      <p:sp>
+        <p:nvSpPr>
+          <p:cNvPr id="2" name="Slide Image Placeholder 1"/>
+          <p:cNvSpPr>
+            <a:spLocks noGrp="1" noRot="1" noChangeAspect="1"/>
+          </p:cNvSpPr>
+          <p:nvPr>
+            <p:ph type="sldImg"/>
+          </p:nvPr>
+        </p:nvSpPr>
+        <p:spPr/>
+      </p:sp>
+      <p:sp>
+        <p:nvSpPr>
+          <p:cNvPr id="3" name="Notes Placeholder 2"/>
+          <p:cNvSpPr>
+            <a:spLocks noGrp="1"/>
+          </p:cNvSpPr>
+          <p:nvPr>
+            <p:ph type="body" idx="1"/>
+          </p:nvPr>
+        </p:nvSpPr>
+        <p:spPr/>
+        <p:txBody>
+          <a:bodyPr/>
+          <a:lstStyle/>
+          <a:p>
+            <a:r>
+              <a:rPr lang="en-US" dirty="0"/>
+              <a:t>Para começar: acesse o SIGAA, apresente-se no fórum até 18 de outubro e anote na agenda o nosso encontro síncrono, em 28 de outubro, às 19h. Bons estudos!</a:t>
+            </a:r>
+            <a:endParaRPr lang="en-US" dirty="0"/>
+          </a:p>
+        </p:txBody>
+      </p:sp>
+      <p:sp>
+        <p:nvSpPr>
+          <p:cNvPr id="4" name="Slide Number Placeholder 3"/>
+          <p:cNvSpPr>
+            <a:spLocks noGrp="1"/>
+          </p:cNvSpPr>
+          <p:nvPr>
+            <p:ph type="sldNum" sz="quarter" idx="10"/>
+          </p:nvPr>
+        </p:nvSpPr>
+        <p:spPr/>
+        <p:txBody>
+          <a:bodyPr/>
+          <a:lstStyle/>
+          <a:p>
+            <a:fld id="{F7021451-1387-4CA6-816F-3879F97B5CBC}" type="slidenum">
+              <a:rPr lang="en-US"/>
+              <a:t>14</a:t>
             </a:fld>
             <a:endParaRPr lang="en-US"/>
           </a:p>
@@ -1570,7 +1659,7 @@
           <a:p>
             <a:r>
               <a:rPr lang="en-US" dirty="0"/>
-              <a:t>São três avaliações a distância. A A1, até 25 de outubro, e a A2, até 8 de novembro, são questionários de dez questões. A A3, até 15 de novembro, tem dez questões objetivas e um estudo de caso discursivo. A média de A1 e A2 vale 40% e a A3 vale 60%. A aprovação exige nota 7,0 e 75% de frequência.</a:t>
+              <a:t>A disciplina tem quatro fóruns, todos na Turma Virtual do SIGAA e nenhum vale nota, mas eles são o nosso principal espaço de diálogo. No fórum de apresentação, até 18 de outubro, você se apresenta em 5 a 10 linhas e comenta a apresentação de um colega. O fórum de dúvidas fica aberto a disciplina toda, e o mediador responde em até 48 horas úteis. O fórum temático 1, também até 18 de outubro, pergunta que falha de mercado uma política pública do seu município procura corrigir e qual função do Estado ela cumpre. O fórum temático 2, de 26 de outubro a 1º de novembro, pede que você avalie uma política pública pelos olhos de um liberal e de um marxista, um ótimo treino para a A3. Para participar, entre na Turma Virtual, vá em Fóruns, abra o fórum da semana e clique em Cadastrar novo tópico.</a:t>
             </a:r>
             <a:endParaRPr lang="en-US" dirty="0"/>
           </a:p>
@@ -2157,7 +2246,7 @@
         <p:spPr>
           <a:xfrm>
             <a:off x="1243584" y="3474720"/>
-            <a:ext cx="4572000" cy="420624"/>
+            <a:ext cx="4937760" cy="420624"/>
           </a:xfrm>
           <a:prstGeom prst="roundRect">
             <a:avLst>
@@ -2261,7 +2350,7 @@
               <a:buNone/>
             </a:pPr>
             <a:r>
-              <a:rPr lang="en-US" sz="2800" b="1" dirty="0">
+              <a:rPr lang="en-US" sz="2300" b="1" dirty="0">
                 <a:solidFill>
                   <a:srgbClr val="13294B"/>
                 </a:solidFill>
@@ -2269,9 +2358,9 @@
                 <a:ea typeface="Calibri" pitchFamily="34" charset="-122"/>
                 <a:cs typeface="Calibri" pitchFamily="34" charset="-120"/>
               </a:rPr>
-              <a:t>Redes de segurança</a:t>
-            </a:r>
-            <a:endParaRPr lang="en-US" sz="2800" dirty="0"/>
+              <a:t>A avaliação: três etapas, todas a distância</a:t>
+            </a:r>
+            <a:endParaRPr lang="en-US" sz="2300" dirty="0"/>
           </a:p>
         </p:txBody>
       </p:sp>
@@ -2311,7 +2400,7 @@
                 <a:ea typeface="Calibri" pitchFamily="34" charset="-122"/>
                 <a:cs typeface="Calibri" pitchFamily="34" charset="-120"/>
               </a:rPr>
-              <a:t>2ª chamada e Prova Final</a:t>
+              <a:t>Nota final = (((A1 + A2) / 2) × 0,4) + (A3 × 0,6)</a:t>
             </a:r>
             <a:endParaRPr lang="en-US" sz="1400" dirty="0"/>
           </a:p>
@@ -2326,11 +2415,11 @@
         <p:spPr>
           <a:xfrm>
             <a:off x="685800" y="1325880"/>
-            <a:ext cx="3794760" cy="2651760"/>
+            <a:ext cx="2456688" cy="2103120"/>
           </a:xfrm>
           <a:prstGeom prst="roundRect">
             <a:avLst>
-              <a:gd name="adj" fmla="val 2069"/>
+              <a:gd name="adj" fmla="val 2609"/>
             </a:avLst>
           </a:prstGeom>
           <a:solidFill>
@@ -2343,7 +2432,7 @@
           </a:ln>
         </p:spPr>
         <p:txBody>
-          <a:bodyPr wrap="square" lIns="127000" tIns="127000" rIns="127000" bIns="127000" rtlCol="0" anchor="t"/>
+          <a:bodyPr wrap="square" lIns="101600" tIns="101600" rIns="101600" bIns="101600" rtlCol="0" anchor="t"/>
           <a:lstStyle/>
           <a:p>
             <a:pPr algn="l" indent="0" marL="0">
@@ -2351,12 +2440,12 @@
                 <a:spcPct val="100000"/>
               </a:lnSpc>
               <a:spcAft>
-                <a:spcPts val="400"/>
+                <a:spcPts val="200"/>
               </a:spcAft>
               <a:buNone/>
             </a:pPr>
             <a:r>
-              <a:rPr lang="en-US" sz="1200" b="1" dirty="0">
+              <a:rPr lang="en-US" sz="1100" b="1" dirty="0">
                 <a:solidFill>
                   <a:srgbClr val="2A8C85"/>
                 </a:solidFill>
@@ -2364,46 +2453,42 @@
                 <a:ea typeface="Calibri" pitchFamily="34" charset="-122"/>
                 <a:cs typeface="Calibri" pitchFamily="34" charset="-120"/>
               </a:rPr>
-              <a:t>SEGUNDA CHAMADA</a:t>
-            </a:r>
-            <a:endParaRPr lang="en-US" sz="1200" dirty="0"/>
+              <a:t>ATÉ 25/10 · 40% (COM A A2)</a:t>
+            </a:r>
+            <a:endParaRPr lang="en-US" sz="1100" dirty="0"/>
           </a:p>
           <a:p>
             <a:pPr algn="l" indent="0" marL="0">
-              <a:lnSpc>
-                <a:spcPct val="100000"/>
-              </a:lnSpc>
-              <a:spcAft>
-                <a:spcPts val="600"/>
-              </a:spcAft>
-              <a:buNone/>
-            </a:pPr>
-            <a:r>
-              <a:rPr lang="en-US" sz="1500" b="1" dirty="0">
-                <a:solidFill>
-                  <a:srgbClr val="13294B"/>
-                </a:solidFill>
-                <a:latin typeface="Calibri" pitchFamily="34" charset="0"/>
-                <a:ea typeface="Calibri" pitchFamily="34" charset="-122"/>
-                <a:cs typeface="Calibri" pitchFamily="34" charset="-120"/>
-              </a:rPr>
-              <a:t>Para quem perdeu A1, A2 ou A3 por motivo justificado.</a:t>
-            </a:r>
-            <a:endParaRPr lang="en-US" sz="1200" dirty="0"/>
-          </a:p>
-          <a:p>
-            <a:pPr algn="l" marL="177800" indent="-177800">
               <a:lnSpc>
                 <a:spcPct val="100000"/>
               </a:lnSpc>
               <a:spcAft>
                 <a:spcPts val="300"/>
               </a:spcAft>
-              <a:buSzPct val="100000"/>
-              <a:buChar char="•"/>
-            </a:pPr>
-            <a:r>
-              <a:rPr lang="en-US" sz="1300" dirty="0">
+              <a:buNone/>
+            </a:pPr>
+            <a:r>
+              <a:rPr lang="en-US" sz="1600" b="1" dirty="0">
+                <a:solidFill>
+                  <a:srgbClr val="13294B"/>
+                </a:solidFill>
+                <a:latin typeface="Calibri" pitchFamily="34" charset="0"/>
+                <a:ea typeface="Calibri" pitchFamily="34" charset="-122"/>
+                <a:cs typeface="Calibri" pitchFamily="34" charset="-120"/>
+              </a:rPr>
+              <a:t>A1 · Questionário</a:t>
+            </a:r>
+            <a:endParaRPr lang="en-US" sz="1100" dirty="0"/>
+          </a:p>
+          <a:p>
+            <a:pPr algn="l" indent="0" marL="0">
+              <a:lnSpc>
+                <a:spcPct val="100000"/>
+              </a:lnSpc>
+              <a:buNone/>
+            </a:pPr>
+            <a:r>
+              <a:rPr lang="en-US" sz="1350" dirty="0">
                 <a:solidFill>
                   <a:srgbClr val="1F2A37"/>
                 </a:solidFill>
@@ -2411,23 +2496,95 @@
                 <a:ea typeface="Calibri" pitchFamily="34" charset="-122"/>
                 <a:cs typeface="Calibri" pitchFamily="34" charset="-120"/>
               </a:rPr>
-              <a:t>Requerimento com documento comprobatório, nos prazos e condições das normas da UNEMAT.</a:t>
-            </a:r>
-            <a:endParaRPr lang="en-US" sz="1200" dirty="0"/>
-          </a:p>
-          <a:p>
-            <a:pPr algn="l" marL="177800" indent="-177800">
+              <a:t>10 questões objetivas no SIGAA sobre as Unidades 1 e 2. Uma tentativa de 60 minutos.</a:t>
+            </a:r>
+            <a:endParaRPr lang="en-US" sz="1100" dirty="0"/>
+          </a:p>
+        </p:txBody>
+      </p:sp>
+      <p:sp>
+        <p:nvSpPr>
+          <p:cNvPr id="5" name="Text 3"/>
+          <p:cNvSpPr txBox="1"/>
+          <p:nvPr/>
+        </p:nvSpPr>
+        <p:spPr>
+          <a:xfrm>
+            <a:off x="3343656" y="1325880"/>
+            <a:ext cx="2456688" cy="2103120"/>
+          </a:xfrm>
+          <a:prstGeom prst="roundRect">
+            <a:avLst>
+              <a:gd name="adj" fmla="val 2609"/>
+            </a:avLst>
+          </a:prstGeom>
+          <a:solidFill>
+            <a:srgbClr val="FFFFFF"/>
+          </a:solidFill>
+          <a:ln w="12700">
+            <a:solidFill>
+              <a:srgbClr val="DCD5C1"/>
+            </a:solidFill>
+          </a:ln>
+        </p:spPr>
+        <p:txBody>
+          <a:bodyPr wrap="square" lIns="101600" tIns="101600" rIns="101600" bIns="101600" rtlCol="0" anchor="t"/>
+          <a:lstStyle/>
+          <a:p>
+            <a:pPr algn="l" indent="0" marL="0">
+              <a:lnSpc>
+                <a:spcPct val="100000"/>
+              </a:lnSpc>
+              <a:spcAft>
+                <a:spcPts val="200"/>
+              </a:spcAft>
+              <a:buNone/>
+            </a:pPr>
+            <a:r>
+              <a:rPr lang="en-US" sz="1100" b="1" dirty="0">
+                <a:solidFill>
+                  <a:srgbClr val="2A8C85"/>
+                </a:solidFill>
+                <a:latin typeface="Calibri" pitchFamily="34" charset="0"/>
+                <a:ea typeface="Calibri" pitchFamily="34" charset="-122"/>
+                <a:cs typeface="Calibri" pitchFamily="34" charset="-120"/>
+              </a:rPr>
+              <a:t>ATÉ 08/11 · 40% (COM A A1)</a:t>
+            </a:r>
+            <a:endParaRPr lang="en-US" sz="1100" dirty="0"/>
+          </a:p>
+          <a:p>
+            <a:pPr algn="l" indent="0" marL="0">
               <a:lnSpc>
                 <a:spcPct val="100000"/>
               </a:lnSpc>
               <a:spcAft>
                 <a:spcPts val="300"/>
               </a:spcAft>
-              <a:buSzPct val="100000"/>
-              <a:buChar char="•"/>
-            </a:pPr>
-            <a:r>
-              <a:rPr lang="en-US" sz="1300" dirty="0">
+              <a:buNone/>
+            </a:pPr>
+            <a:r>
+              <a:rPr lang="en-US" sz="1600" b="1" dirty="0">
+                <a:solidFill>
+                  <a:srgbClr val="13294B"/>
+                </a:solidFill>
+                <a:latin typeface="Calibri" pitchFamily="34" charset="0"/>
+                <a:ea typeface="Calibri" pitchFamily="34" charset="-122"/>
+                <a:cs typeface="Calibri" pitchFamily="34" charset="-120"/>
+              </a:rPr>
+              <a:t>A2 · Questionário</a:t>
+            </a:r>
+            <a:endParaRPr lang="en-US" sz="1100" dirty="0"/>
+          </a:p>
+          <a:p>
+            <a:pPr algn="l" indent="0" marL="0">
+              <a:lnSpc>
+                <a:spcPct val="100000"/>
+              </a:lnSpc>
+              <a:buNone/>
+            </a:pPr>
+            <a:r>
+              <a:rPr lang="en-US" sz="1350" dirty="0">
                 <a:solidFill>
                   <a:srgbClr val="1F2A37"/>
                 </a:solidFill>
@@ -2435,47 +2592,122 @@
                 <a:ea typeface="Calibri" pitchFamily="34" charset="-122"/>
                 <a:cs typeface="Calibri" pitchFamily="34" charset="-120"/>
               </a:rPr>
-              <a:t>Formato da A3: 10 objetivas + estudo de caso, a distância.</a:t>
-            </a:r>
-            <a:endParaRPr lang="en-US" sz="1200" dirty="0"/>
-          </a:p>
-          <a:p>
-            <a:pPr algn="l" marL="177800" indent="-177800">
-              <a:lnSpc>
-                <a:spcPct val="100000"/>
-              </a:lnSpc>
-              <a:buSzPct val="100000"/>
-              <a:buChar char="•"/>
-            </a:pPr>
-            <a:r>
-              <a:rPr lang="en-US" sz="1300" dirty="0">
-                <a:solidFill>
-                  <a:srgbClr val="1F2A37"/>
-                </a:solidFill>
-                <a:latin typeface="Calibri" pitchFamily="34" charset="0"/>
-                <a:ea typeface="Calibri" pitchFamily="34" charset="-122"/>
-                <a:cs typeface="Calibri" pitchFamily="34" charset="-120"/>
-              </a:rPr>
-              <a:t>Data definida pela Coordenação.</a:t>
-            </a:r>
-            <a:endParaRPr lang="en-US" sz="1200" dirty="0"/>
+              <a:t>10 questões objetivas no SIGAA sobre as Unidades 3 e 4. Uma tentativa de 60 minutos.</a:t>
+            </a:r>
+            <a:endParaRPr lang="en-US" sz="1100" dirty="0"/>
           </a:p>
         </p:txBody>
       </p:sp>
       <p:sp>
         <p:nvSpPr>
-          <p:cNvPr id="5" name="Text 3"/>
+          <p:cNvPr id="6" name="Text 4"/>
           <p:cNvSpPr txBox="1"/>
           <p:nvPr/>
         </p:nvSpPr>
         <p:spPr>
           <a:xfrm>
-            <a:off x="4663440" y="1325880"/>
-            <a:ext cx="3794760" cy="2651760"/>
+            <a:off x="6001512" y="1325880"/>
+            <a:ext cx="2456688" cy="2103120"/>
           </a:xfrm>
           <a:prstGeom prst="roundRect">
             <a:avLst>
-              <a:gd name="adj" fmla="val 2069"/>
+              <a:gd name="adj" fmla="val 2609"/>
+            </a:avLst>
+          </a:prstGeom>
+          <a:solidFill>
+            <a:srgbClr val="FFFFFF"/>
+          </a:solidFill>
+          <a:ln w="12700">
+            <a:solidFill>
+              <a:srgbClr val="DCD5C1"/>
+            </a:solidFill>
+          </a:ln>
+        </p:spPr>
+        <p:txBody>
+          <a:bodyPr wrap="square" lIns="101600" tIns="101600" rIns="101600" bIns="101600" rtlCol="0" anchor="t"/>
+          <a:lstStyle/>
+          <a:p>
+            <a:pPr algn="l" indent="0" marL="0">
+              <a:lnSpc>
+                <a:spcPct val="100000"/>
+              </a:lnSpc>
+              <a:spcAft>
+                <a:spcPts val="200"/>
+              </a:spcAft>
+              <a:buNone/>
+            </a:pPr>
+            <a:r>
+              <a:rPr lang="en-US" sz="1100" b="1" dirty="0">
+                <a:solidFill>
+                  <a:srgbClr val="2A8C85"/>
+                </a:solidFill>
+                <a:latin typeface="Calibri" pitchFamily="34" charset="0"/>
+                <a:ea typeface="Calibri" pitchFamily="34" charset="-122"/>
+                <a:cs typeface="Calibri" pitchFamily="34" charset="-120"/>
+              </a:rPr>
+              <a:t>ATÉ 15/11 · 60%</a:t>
+            </a:r>
+            <a:endParaRPr lang="en-US" sz="1100" dirty="0"/>
+          </a:p>
+          <a:p>
+            <a:pPr algn="l" indent="0" marL="0">
+              <a:lnSpc>
+                <a:spcPct val="100000"/>
+              </a:lnSpc>
+              <a:spcAft>
+                <a:spcPts val="300"/>
+              </a:spcAft>
+              <a:buNone/>
+            </a:pPr>
+            <a:r>
+              <a:rPr lang="en-US" sz="1600" b="1" dirty="0">
+                <a:solidFill>
+                  <a:srgbClr val="13294B"/>
+                </a:solidFill>
+                <a:latin typeface="Calibri" pitchFamily="34" charset="0"/>
+                <a:ea typeface="Calibri" pitchFamily="34" charset="-122"/>
+                <a:cs typeface="Calibri" pitchFamily="34" charset="-120"/>
+              </a:rPr>
+              <a:t>A3 · Objetivas + caso</a:t>
+            </a:r>
+            <a:endParaRPr lang="en-US" sz="1100" dirty="0"/>
+          </a:p>
+          <a:p>
+            <a:pPr algn="l" indent="0" marL="0">
+              <a:lnSpc>
+                <a:spcPct val="100000"/>
+              </a:lnSpc>
+              <a:buNone/>
+            </a:pPr>
+            <a:r>
+              <a:rPr lang="en-US" sz="1350" dirty="0">
+                <a:solidFill>
+                  <a:srgbClr val="1F2A37"/>
+                </a:solidFill>
+                <a:latin typeface="Calibri" pitchFamily="34" charset="0"/>
+                <a:ea typeface="Calibri" pitchFamily="34" charset="-122"/>
+                <a:cs typeface="Calibri" pitchFamily="34" charset="-120"/>
+              </a:rPr>
+              <a:t>10 questões objetivas e um estudo de caso discursivo sobre todo o conteúdo, enviado em arquivo.</a:t>
+            </a:r>
+            <a:endParaRPr lang="en-US" sz="1100" dirty="0"/>
+          </a:p>
+        </p:txBody>
+      </p:sp>
+      <p:sp>
+        <p:nvSpPr>
+          <p:cNvPr id="7" name="Text 5"/>
+          <p:cNvSpPr txBox="1"/>
+          <p:nvPr/>
+        </p:nvSpPr>
+        <p:spPr>
+          <a:xfrm>
+            <a:off x="685800" y="3657600"/>
+            <a:ext cx="7772400" cy="658368"/>
+          </a:xfrm>
+          <a:prstGeom prst="roundRect">
+            <a:avLst>
+              <a:gd name="adj" fmla="val 11111"/>
             </a:avLst>
           </a:prstGeom>
           <a:solidFill>
@@ -2484,43 +2716,17 @@
           <a:ln/>
         </p:spPr>
         <p:txBody>
-          <a:bodyPr wrap="square" lIns="127000" tIns="127000" rIns="127000" bIns="127000" rtlCol="0" anchor="t"/>
+          <a:bodyPr wrap="square" lIns="127000" tIns="127000" rIns="127000" bIns="127000" rtlCol="0" anchor="ctr"/>
           <a:lstStyle/>
           <a:p>
-            <a:pPr algn="l" indent="0" marL="0">
-              <a:lnSpc>
-                <a:spcPct val="100000"/>
-              </a:lnSpc>
-              <a:spcAft>
-                <a:spcPts val="400"/>
-              </a:spcAft>
-              <a:buNone/>
-            </a:pPr>
-            <a:r>
-              <a:rPr lang="en-US" sz="1200" b="1" dirty="0">
-                <a:solidFill>
-                  <a:srgbClr val="2A8C85"/>
-                </a:solidFill>
-                <a:latin typeface="Calibri" pitchFamily="34" charset="0"/>
-                <a:ea typeface="Calibri" pitchFamily="34" charset="-122"/>
-                <a:cs typeface="Calibri" pitchFamily="34" charset="-120"/>
-              </a:rPr>
-              <a:t>PROVA FINAL</a:t>
-            </a:r>
-            <a:endParaRPr lang="en-US" sz="1200" dirty="0"/>
-          </a:p>
-          <a:p>
-            <a:pPr algn="l" indent="0" marL="0">
-              <a:lnSpc>
-                <a:spcPct val="100000"/>
-              </a:lnSpc>
-              <a:spcAft>
-                <a:spcPts val="600"/>
-              </a:spcAft>
-              <a:buNone/>
-            </a:pPr>
-            <a:r>
-              <a:rPr lang="en-US" sz="1500" b="1" dirty="0">
+            <a:pPr algn="ctr" indent="0" marL="0">
+              <a:lnSpc>
+                <a:spcPct val="100000"/>
+              </a:lnSpc>
+              <a:buNone/>
+            </a:pPr>
+            <a:r>
+              <a:rPr lang="en-US" sz="1350" dirty="0">
                 <a:solidFill>
                   <a:srgbClr val="13294B"/>
                 </a:solidFill>
@@ -2528,84 +2734,15 @@
                 <a:ea typeface="Calibri" pitchFamily="34" charset="-122"/>
                 <a:cs typeface="Calibri" pitchFamily="34" charset="-120"/>
               </a:rPr>
-              <a:t>Para quem não atingir a nota de aprovação, nas condições das normas vigentes.</a:t>
-            </a:r>
-            <a:endParaRPr lang="en-US" sz="1200" dirty="0"/>
-          </a:p>
-          <a:p>
-            <a:pPr algn="l" marL="177800" indent="-177800">
-              <a:lnSpc>
-                <a:spcPct val="100000"/>
-              </a:lnSpc>
-              <a:spcAft>
-                <a:spcPts val="300"/>
-              </a:spcAft>
-              <a:buSzPct val="100000"/>
-              <a:buChar char="•"/>
-            </a:pPr>
-            <a:r>
-              <a:rPr lang="en-US" sz="1300" dirty="0">
-                <a:solidFill>
-                  <a:srgbClr val="1F2A37"/>
-                </a:solidFill>
-                <a:latin typeface="Calibri" pitchFamily="34" charset="0"/>
-                <a:ea typeface="Calibri" pitchFamily="34" charset="-122"/>
-                <a:cs typeface="Calibri" pitchFamily="34" charset="-120"/>
-              </a:rPr>
-              <a:t>Todo o conteúdo da disciplina.</a:t>
-            </a:r>
-            <a:endParaRPr lang="en-US" sz="1200" dirty="0"/>
-          </a:p>
-          <a:p>
-            <a:pPr algn="l" marL="177800" indent="-177800">
-              <a:lnSpc>
-                <a:spcPct val="100000"/>
-              </a:lnSpc>
-              <a:spcAft>
-                <a:spcPts val="300"/>
-              </a:spcAft>
-              <a:buSzPct val="100000"/>
-              <a:buChar char="•"/>
-            </a:pPr>
-            <a:r>
-              <a:rPr lang="en-US" sz="1300" dirty="0">
-                <a:solidFill>
-                  <a:srgbClr val="1F2A37"/>
-                </a:solidFill>
-                <a:latin typeface="Calibri" pitchFamily="34" charset="0"/>
-                <a:ea typeface="Calibri" pitchFamily="34" charset="-122"/>
-                <a:cs typeface="Calibri" pitchFamily="34" charset="-120"/>
-              </a:rPr>
-              <a:t>Formato da A3: 10 objetivas + estudo de caso, a distância.</a:t>
-            </a:r>
-            <a:endParaRPr lang="en-US" sz="1200" dirty="0"/>
-          </a:p>
-          <a:p>
-            <a:pPr algn="l" marL="177800" indent="-177800">
-              <a:lnSpc>
-                <a:spcPct val="100000"/>
-              </a:lnSpc>
-              <a:buSzPct val="100000"/>
-              <a:buChar char="•"/>
-            </a:pPr>
-            <a:r>
-              <a:rPr lang="en-US" sz="1300" dirty="0">
-                <a:solidFill>
-                  <a:srgbClr val="1F2A37"/>
-                </a:solidFill>
-                <a:latin typeface="Calibri" pitchFamily="34" charset="0"/>
-                <a:ea typeface="Calibri" pitchFamily="34" charset="-122"/>
-                <a:cs typeface="Calibri" pitchFamily="34" charset="-120"/>
-              </a:rPr>
-              <a:t>Data definida pela Coordenação.</a:t>
-            </a:r>
-            <a:endParaRPr lang="en-US" sz="1200" dirty="0"/>
+              <a:t>Aprovação: nota final igual ou superior a 7,0 e 75% de frequência. Exercícios de fixação (sem nota) ajudam a preparar cada avaliação.</a:t>
+            </a:r>
+            <a:endParaRPr lang="en-US" sz="1350" dirty="0"/>
           </a:p>
         </p:txBody>
       </p:sp>
       <p:sp>
         <p:nvSpPr>
-          <p:cNvPr id="6" name="Text 4"/>
+          <p:cNvPr id="8" name="Text 6"/>
           <p:cNvSpPr txBox="1"/>
           <p:nvPr/>
         </p:nvSpPr>
@@ -2712,7 +2849,7 @@
               <a:buNone/>
             </a:pPr>
             <a:r>
-              <a:rPr lang="en-US" sz="2600" b="1" dirty="0">
+              <a:rPr lang="en-US" sz="2800" b="1" dirty="0">
                 <a:solidFill>
                   <a:srgbClr val="13294B"/>
                 </a:solidFill>
@@ -2720,9 +2857,9 @@
                 <a:ea typeface="Calibri" pitchFamily="34" charset="-122"/>
                 <a:cs typeface="Calibri" pitchFamily="34" charset="-120"/>
               </a:rPr>
-              <a:t>O mapa do 1º bloco: 09/10 a 15/11/2026</a:t>
-            </a:r>
-            <a:endParaRPr lang="en-US" sz="2600" dirty="0"/>
+              <a:t>Redes de segurança</a:t>
+            </a:r>
+            <a:endParaRPr lang="en-US" sz="2800" dirty="0"/>
           </a:p>
         </p:txBody>
       </p:sp>
@@ -2762,6 +2899,457 @@
                 <a:ea typeface="Calibri" pitchFamily="34" charset="-122"/>
                 <a:cs typeface="Calibri" pitchFamily="34" charset="-120"/>
               </a:rPr>
+              <a:t>2ª chamada e Prova Final</a:t>
+            </a:r>
+            <a:endParaRPr lang="en-US" sz="1400" dirty="0"/>
+          </a:p>
+        </p:txBody>
+      </p:sp>
+      <p:sp>
+        <p:nvSpPr>
+          <p:cNvPr id="4" name="Text 2"/>
+          <p:cNvSpPr txBox="1"/>
+          <p:nvPr/>
+        </p:nvSpPr>
+        <p:spPr>
+          <a:xfrm>
+            <a:off x="685800" y="1325880"/>
+            <a:ext cx="3794760" cy="2651760"/>
+          </a:xfrm>
+          <a:prstGeom prst="roundRect">
+            <a:avLst>
+              <a:gd name="adj" fmla="val 2069"/>
+            </a:avLst>
+          </a:prstGeom>
+          <a:solidFill>
+            <a:srgbClr val="FFFFFF"/>
+          </a:solidFill>
+          <a:ln w="12700">
+            <a:solidFill>
+              <a:srgbClr val="DCD5C1"/>
+            </a:solidFill>
+          </a:ln>
+        </p:spPr>
+        <p:txBody>
+          <a:bodyPr wrap="square" lIns="127000" tIns="127000" rIns="127000" bIns="127000" rtlCol="0" anchor="t"/>
+          <a:lstStyle/>
+          <a:p>
+            <a:pPr algn="l" indent="0" marL="0">
+              <a:lnSpc>
+                <a:spcPct val="100000"/>
+              </a:lnSpc>
+              <a:spcAft>
+                <a:spcPts val="400"/>
+              </a:spcAft>
+              <a:buNone/>
+            </a:pPr>
+            <a:r>
+              <a:rPr lang="en-US" sz="1200" b="1" dirty="0">
+                <a:solidFill>
+                  <a:srgbClr val="2A8C85"/>
+                </a:solidFill>
+                <a:latin typeface="Calibri" pitchFamily="34" charset="0"/>
+                <a:ea typeface="Calibri" pitchFamily="34" charset="-122"/>
+                <a:cs typeface="Calibri" pitchFamily="34" charset="-120"/>
+              </a:rPr>
+              <a:t>SEGUNDA CHAMADA</a:t>
+            </a:r>
+            <a:endParaRPr lang="en-US" sz="1200" dirty="0"/>
+          </a:p>
+          <a:p>
+            <a:pPr algn="l" indent="0" marL="0">
+              <a:lnSpc>
+                <a:spcPct val="100000"/>
+              </a:lnSpc>
+              <a:spcAft>
+                <a:spcPts val="600"/>
+              </a:spcAft>
+              <a:buNone/>
+            </a:pPr>
+            <a:r>
+              <a:rPr lang="en-US" sz="1500" b="1" dirty="0">
+                <a:solidFill>
+                  <a:srgbClr val="13294B"/>
+                </a:solidFill>
+                <a:latin typeface="Calibri" pitchFamily="34" charset="0"/>
+                <a:ea typeface="Calibri" pitchFamily="34" charset="-122"/>
+                <a:cs typeface="Calibri" pitchFamily="34" charset="-120"/>
+              </a:rPr>
+              <a:t>Para quem perdeu A1, A2 ou A3 por motivo justificado.</a:t>
+            </a:r>
+            <a:endParaRPr lang="en-US" sz="1200" dirty="0"/>
+          </a:p>
+          <a:p>
+            <a:pPr algn="l" marL="177800" indent="-177800">
+              <a:lnSpc>
+                <a:spcPct val="100000"/>
+              </a:lnSpc>
+              <a:spcAft>
+                <a:spcPts val="300"/>
+              </a:spcAft>
+              <a:buSzPct val="100000"/>
+              <a:buChar char="•"/>
+            </a:pPr>
+            <a:r>
+              <a:rPr lang="en-US" sz="1300" dirty="0">
+                <a:solidFill>
+                  <a:srgbClr val="1F2A37"/>
+                </a:solidFill>
+                <a:latin typeface="Calibri" pitchFamily="34" charset="0"/>
+                <a:ea typeface="Calibri" pitchFamily="34" charset="-122"/>
+                <a:cs typeface="Calibri" pitchFamily="34" charset="-120"/>
+              </a:rPr>
+              <a:t>Requerimento com documento comprobatório, nos prazos e condições das normas da UNEMAT.</a:t>
+            </a:r>
+            <a:endParaRPr lang="en-US" sz="1200" dirty="0"/>
+          </a:p>
+          <a:p>
+            <a:pPr algn="l" marL="177800" indent="-177800">
+              <a:lnSpc>
+                <a:spcPct val="100000"/>
+              </a:lnSpc>
+              <a:spcAft>
+                <a:spcPts val="300"/>
+              </a:spcAft>
+              <a:buSzPct val="100000"/>
+              <a:buChar char="•"/>
+            </a:pPr>
+            <a:r>
+              <a:rPr lang="en-US" sz="1300" dirty="0">
+                <a:solidFill>
+                  <a:srgbClr val="1F2A37"/>
+                </a:solidFill>
+                <a:latin typeface="Calibri" pitchFamily="34" charset="0"/>
+                <a:ea typeface="Calibri" pitchFamily="34" charset="-122"/>
+                <a:cs typeface="Calibri" pitchFamily="34" charset="-120"/>
+              </a:rPr>
+              <a:t>Formato da A3: 10 objetivas + estudo de caso, a distância.</a:t>
+            </a:r>
+            <a:endParaRPr lang="en-US" sz="1200" dirty="0"/>
+          </a:p>
+          <a:p>
+            <a:pPr algn="l" marL="177800" indent="-177800">
+              <a:lnSpc>
+                <a:spcPct val="100000"/>
+              </a:lnSpc>
+              <a:buSzPct val="100000"/>
+              <a:buChar char="•"/>
+            </a:pPr>
+            <a:r>
+              <a:rPr lang="en-US" sz="1300" dirty="0">
+                <a:solidFill>
+                  <a:srgbClr val="1F2A37"/>
+                </a:solidFill>
+                <a:latin typeface="Calibri" pitchFamily="34" charset="0"/>
+                <a:ea typeface="Calibri" pitchFamily="34" charset="-122"/>
+                <a:cs typeface="Calibri" pitchFamily="34" charset="-120"/>
+              </a:rPr>
+              <a:t>Data definida pela Coordenação.</a:t>
+            </a:r>
+            <a:endParaRPr lang="en-US" sz="1200" dirty="0"/>
+          </a:p>
+        </p:txBody>
+      </p:sp>
+      <p:sp>
+        <p:nvSpPr>
+          <p:cNvPr id="5" name="Text 3"/>
+          <p:cNvSpPr txBox="1"/>
+          <p:nvPr/>
+        </p:nvSpPr>
+        <p:spPr>
+          <a:xfrm>
+            <a:off x="4663440" y="1325880"/>
+            <a:ext cx="3794760" cy="2651760"/>
+          </a:xfrm>
+          <a:prstGeom prst="roundRect">
+            <a:avLst>
+              <a:gd name="adj" fmla="val 2069"/>
+            </a:avLst>
+          </a:prstGeom>
+          <a:solidFill>
+            <a:srgbClr val="E6F2F0"/>
+          </a:solidFill>
+          <a:ln/>
+        </p:spPr>
+        <p:txBody>
+          <a:bodyPr wrap="square" lIns="127000" tIns="127000" rIns="127000" bIns="127000" rtlCol="0" anchor="t"/>
+          <a:lstStyle/>
+          <a:p>
+            <a:pPr algn="l" indent="0" marL="0">
+              <a:lnSpc>
+                <a:spcPct val="100000"/>
+              </a:lnSpc>
+              <a:spcAft>
+                <a:spcPts val="400"/>
+              </a:spcAft>
+              <a:buNone/>
+            </a:pPr>
+            <a:r>
+              <a:rPr lang="en-US" sz="1200" b="1" dirty="0">
+                <a:solidFill>
+                  <a:srgbClr val="2A8C85"/>
+                </a:solidFill>
+                <a:latin typeface="Calibri" pitchFamily="34" charset="0"/>
+                <a:ea typeface="Calibri" pitchFamily="34" charset="-122"/>
+                <a:cs typeface="Calibri" pitchFamily="34" charset="-120"/>
+              </a:rPr>
+              <a:t>PROVA FINAL</a:t>
+            </a:r>
+            <a:endParaRPr lang="en-US" sz="1200" dirty="0"/>
+          </a:p>
+          <a:p>
+            <a:pPr algn="l" indent="0" marL="0">
+              <a:lnSpc>
+                <a:spcPct val="100000"/>
+              </a:lnSpc>
+              <a:spcAft>
+                <a:spcPts val="600"/>
+              </a:spcAft>
+              <a:buNone/>
+            </a:pPr>
+            <a:r>
+              <a:rPr lang="en-US" sz="1500" b="1" dirty="0">
+                <a:solidFill>
+                  <a:srgbClr val="13294B"/>
+                </a:solidFill>
+                <a:latin typeface="Calibri" pitchFamily="34" charset="0"/>
+                <a:ea typeface="Calibri" pitchFamily="34" charset="-122"/>
+                <a:cs typeface="Calibri" pitchFamily="34" charset="-120"/>
+              </a:rPr>
+              <a:t>Para quem não atingir a nota de aprovação, nas condições das normas vigentes.</a:t>
+            </a:r>
+            <a:endParaRPr lang="en-US" sz="1200" dirty="0"/>
+          </a:p>
+          <a:p>
+            <a:pPr algn="l" marL="177800" indent="-177800">
+              <a:lnSpc>
+                <a:spcPct val="100000"/>
+              </a:lnSpc>
+              <a:spcAft>
+                <a:spcPts val="300"/>
+              </a:spcAft>
+              <a:buSzPct val="100000"/>
+              <a:buChar char="•"/>
+            </a:pPr>
+            <a:r>
+              <a:rPr lang="en-US" sz="1300" dirty="0">
+                <a:solidFill>
+                  <a:srgbClr val="1F2A37"/>
+                </a:solidFill>
+                <a:latin typeface="Calibri" pitchFamily="34" charset="0"/>
+                <a:ea typeface="Calibri" pitchFamily="34" charset="-122"/>
+                <a:cs typeface="Calibri" pitchFamily="34" charset="-120"/>
+              </a:rPr>
+              <a:t>Todo o conteúdo da disciplina.</a:t>
+            </a:r>
+            <a:endParaRPr lang="en-US" sz="1200" dirty="0"/>
+          </a:p>
+          <a:p>
+            <a:pPr algn="l" marL="177800" indent="-177800">
+              <a:lnSpc>
+                <a:spcPct val="100000"/>
+              </a:lnSpc>
+              <a:spcAft>
+                <a:spcPts val="300"/>
+              </a:spcAft>
+              <a:buSzPct val="100000"/>
+              <a:buChar char="•"/>
+            </a:pPr>
+            <a:r>
+              <a:rPr lang="en-US" sz="1300" dirty="0">
+                <a:solidFill>
+                  <a:srgbClr val="1F2A37"/>
+                </a:solidFill>
+                <a:latin typeface="Calibri" pitchFamily="34" charset="0"/>
+                <a:ea typeface="Calibri" pitchFamily="34" charset="-122"/>
+                <a:cs typeface="Calibri" pitchFamily="34" charset="-120"/>
+              </a:rPr>
+              <a:t>Formato da A3: 10 objetivas + estudo de caso, a distância.</a:t>
+            </a:r>
+            <a:endParaRPr lang="en-US" sz="1200" dirty="0"/>
+          </a:p>
+          <a:p>
+            <a:pPr algn="l" marL="177800" indent="-177800">
+              <a:lnSpc>
+                <a:spcPct val="100000"/>
+              </a:lnSpc>
+              <a:buSzPct val="100000"/>
+              <a:buChar char="•"/>
+            </a:pPr>
+            <a:r>
+              <a:rPr lang="en-US" sz="1300" dirty="0">
+                <a:solidFill>
+                  <a:srgbClr val="1F2A37"/>
+                </a:solidFill>
+                <a:latin typeface="Calibri" pitchFamily="34" charset="0"/>
+                <a:ea typeface="Calibri" pitchFamily="34" charset="-122"/>
+                <a:cs typeface="Calibri" pitchFamily="34" charset="-120"/>
+              </a:rPr>
+              <a:t>Data definida pela Coordenação.</a:t>
+            </a:r>
+            <a:endParaRPr lang="en-US" sz="1200" dirty="0"/>
+          </a:p>
+        </p:txBody>
+      </p:sp>
+      <p:sp>
+        <p:nvSpPr>
+          <p:cNvPr id="6" name="Text 4"/>
+          <p:cNvSpPr txBox="1"/>
+          <p:nvPr/>
+        </p:nvSpPr>
+        <p:spPr>
+          <a:xfrm>
+            <a:off x="4206240" y="36576"/>
+            <a:ext cx="4800600" cy="219456"/>
+          </a:xfrm>
+          <a:prstGeom prst="rect">
+            <a:avLst/>
+          </a:prstGeom>
+          <a:noFill/>
+          <a:ln/>
+        </p:spPr>
+        <p:txBody>
+          <a:bodyPr wrap="square" lIns="0" tIns="0" rIns="0" bIns="0" rtlCol="0" anchor="ctr"/>
+          <a:lstStyle/>
+          <a:p>
+            <a:pPr algn="r" indent="0" marL="0">
+              <a:lnSpc>
+                <a:spcPct val="100000"/>
+              </a:lnSpc>
+              <a:buNone/>
+            </a:pPr>
+            <a:r>
+              <a:rPr lang="en-US" sz="950" dirty="0">
+                <a:solidFill>
+                  <a:srgbClr val="5B6770"/>
+                </a:solidFill>
+                <a:latin typeface="Calibri" pitchFamily="34" charset="0"/>
+                <a:ea typeface="Calibri" pitchFamily="34" charset="-122"/>
+                <a:cs typeface="Calibri" pitchFamily="34" charset="-120"/>
+              </a:rPr>
+              <a:t>Estado, Governo e Mercado · Apresentação da disciplina</a:t>
+            </a:r>
+            <a:endParaRPr lang="en-US" sz="950" dirty="0"/>
+          </a:p>
+        </p:txBody>
+      </p:sp>
+    </p:spTree>
+  </p:cSld>
+  <p:clrMapOvr>
+    <a:masterClrMapping/>
+  </p:clrMapOvr>
+</p:sld>
+</file>
+
+<file path=ppt/slides/slide12.xml><?xml version="1.0" encoding="utf-8"?>
+<p:sld xmlns:a="http://schemas.openxmlformats.org/drawingml/2006/main" xmlns:r="http://schemas.openxmlformats.org/officeDocument/2006/relationships" xmlns:p="http://schemas.openxmlformats.org/presentationml/2006/main">
+  <p:cSld name="Slide 12">
+    <p:bg>
+      <p:bgPr>
+        <a:blipFill dpi="0" rotWithShape="1">
+          <a:blip r:embed="rId1">
+            <a:lum/>
+          </a:blip>
+          <a:srcRect/>
+          <a:stretch>
+            <a:fillRect/>
+          </a:stretch>
+        </a:blipFill>
+        <a:effectLst/>
+      </p:bgPr>
+    </p:bg>
+    <p:spTree>
+      <p:nvGrpSpPr>
+        <p:cNvPr id="1" name=""/>
+        <p:cNvGrpSpPr/>
+        <p:nvPr/>
+      </p:nvGrpSpPr>
+      <p:grpSpPr>
+        <a:xfrm>
+          <a:off x="0" y="0"/>
+          <a:ext cx="0" cy="0"/>
+          <a:chOff x="0" y="0"/>
+          <a:chExt cx="0" cy="0"/>
+        </a:xfrm>
+      </p:grpSpPr>
+      <p:sp>
+        <p:nvSpPr>
+          <p:cNvPr id="2" name="Text 0"/>
+          <p:cNvSpPr txBox="1"/>
+          <p:nvPr/>
+        </p:nvSpPr>
+        <p:spPr>
+          <a:xfrm>
+            <a:off x="731520" y="256032"/>
+            <a:ext cx="7680960" cy="566928"/>
+          </a:xfrm>
+          <a:prstGeom prst="rect">
+            <a:avLst/>
+          </a:prstGeom>
+          <a:noFill/>
+          <a:ln/>
+        </p:spPr>
+        <p:txBody>
+          <a:bodyPr wrap="square" lIns="0" tIns="0" rIns="0" bIns="0" rtlCol="0" anchor="ctr"/>
+          <a:lstStyle/>
+          <a:p>
+            <a:pPr algn="ctr" indent="0" marL="0">
+              <a:lnSpc>
+                <a:spcPct val="100000"/>
+              </a:lnSpc>
+              <a:buNone/>
+            </a:pPr>
+            <a:r>
+              <a:rPr lang="en-US" sz="2600" b="1" dirty="0">
+                <a:solidFill>
+                  <a:srgbClr val="13294B"/>
+                </a:solidFill>
+                <a:latin typeface="Calibri" pitchFamily="34" charset="0"/>
+                <a:ea typeface="Calibri" pitchFamily="34" charset="-122"/>
+                <a:cs typeface="Calibri" pitchFamily="34" charset="-120"/>
+              </a:rPr>
+              <a:t>O mapa do 1º bloco: 09/10 a 15/11/2026</a:t>
+            </a:r>
+            <a:endParaRPr lang="en-US" sz="2600" dirty="0"/>
+          </a:p>
+        </p:txBody>
+      </p:sp>
+      <p:sp>
+        <p:nvSpPr>
+          <p:cNvPr id="3" name="Text 1"/>
+          <p:cNvSpPr txBox="1"/>
+          <p:nvPr/>
+        </p:nvSpPr>
+        <p:spPr>
+          <a:xfrm>
+            <a:off x="1005840" y="804672"/>
+            <a:ext cx="7132320" cy="329184"/>
+          </a:xfrm>
+          <a:prstGeom prst="rect">
+            <a:avLst/>
+          </a:prstGeom>
+          <a:noFill/>
+          <a:ln/>
+        </p:spPr>
+        <p:txBody>
+          <a:bodyPr wrap="square" lIns="0" tIns="0" rIns="0" bIns="0" rtlCol="0" anchor="ctr"/>
+          <a:lstStyle/>
+          <a:p>
+            <a:pPr algn="ctr" indent="0" marL="0">
+              <a:lnSpc>
+                <a:spcPct val="100000"/>
+              </a:lnSpc>
+              <a:buNone/>
+            </a:pPr>
+            <a:r>
+              <a:rPr lang="en-US" sz="1400" dirty="0">
+                <a:solidFill>
+                  <a:srgbClr val="5B6770"/>
+                </a:solidFill>
+                <a:latin typeface="Calibri" pitchFamily="34" charset="0"/>
+                <a:ea typeface="Calibri" pitchFamily="34" charset="-122"/>
+                <a:cs typeface="Calibri" pitchFamily="34" charset="-120"/>
+              </a:rPr>
               <a:t>Datas das unidades, do encontro síncrono e das avaliações</a:t>
             </a:r>
             <a:endParaRPr lang="en-US" sz="1400" dirty="0"/>
@@ -2770,7 +3358,7 @@
       </p:sp>
       <p:graphicFrame>
         <p:nvGraphicFramePr>
-          <p:cNvPr id="12" name="Table 0"/>
+          <p:cNvPr id="13" name="Table 0"/>
           <p:cNvGraphicFramePr>
             <a:graphicFrameLocks noGrp="1"/>
           </p:cNvGraphicFramePr>
@@ -3766,7 +4354,7 @@
       </p:graphicFrame>
       <p:graphicFrame>
         <p:nvGraphicFramePr>
-          <p:cNvPr id="23" name="Table 1"/>
+          <p:cNvPr id="25" name="Table 1"/>
           <p:cNvGraphicFramePr>
             <a:graphicFrameLocks noGrp="1"/>
           </p:cNvGraphicFramePr>
@@ -4810,9 +5398,9 @@
 </p:sld>
 </file>
 
-<file path=ppt/slides/slide12.xml><?xml version="1.0" encoding="utf-8"?>
+<file path=ppt/slides/slide13.xml><?xml version="1.0" encoding="utf-8"?>
 <p:sld xmlns:a="http://schemas.openxmlformats.org/drawingml/2006/main" xmlns:r="http://schemas.openxmlformats.org/officeDocument/2006/relationships" xmlns:p="http://schemas.openxmlformats.org/presentationml/2006/main">
-  <p:cSld name="Slide 12">
+  <p:cSld name="Slide 13">
     <p:bg>
       <p:bgPr>
         <a:blipFill dpi="0" rotWithShape="1">
@@ -5501,9 +6089,9 @@
 </p:sld>
 </file>
 
-<file path=ppt/slides/slide13.xml><?xml version="1.0" encoding="utf-8"?>
+<file path=ppt/slides/slide14.xml><?xml version="1.0" encoding="utf-8"?>
 <p:sld xmlns:a="http://schemas.openxmlformats.org/drawingml/2006/main" xmlns:r="http://schemas.openxmlformats.org/officeDocument/2006/relationships" xmlns:p="http://schemas.openxmlformats.org/presentationml/2006/main">
-  <p:cSld name="Slide 13">
+  <p:cSld name="Slide 14">
     <p:bg>
       <p:bgPr>
         <a:blipFill dpi="0" rotWithShape="1">
@@ -10130,7 +10718,7 @@
               <a:buNone/>
             </a:pPr>
             <a:r>
-              <a:rPr lang="en-US" sz="2300" b="1" dirty="0">
+              <a:rPr lang="en-US" sz="2800" b="1" dirty="0">
                 <a:solidFill>
                   <a:srgbClr val="13294B"/>
                 </a:solidFill>
@@ -10138,9 +10726,9 @@
                 <a:ea typeface="Calibri" pitchFamily="34" charset="-122"/>
                 <a:cs typeface="Calibri" pitchFamily="34" charset="-120"/>
               </a:rPr>
-              <a:t>A avaliação: três etapas, todas a distância</a:t>
-            </a:r>
-            <a:endParaRPr lang="en-US" sz="2300" dirty="0"/>
+              <a:t>Fóruns da disciplina</a:t>
+            </a:r>
+            <a:endParaRPr lang="en-US" sz="2800" dirty="0"/>
           </a:p>
         </p:txBody>
       </p:sp>
@@ -10180,349 +10768,1076 @@
                 <a:ea typeface="Calibri" pitchFamily="34" charset="-122"/>
                 <a:cs typeface="Calibri" pitchFamily="34" charset="-120"/>
               </a:rPr>
-              <a:t>Nota final = (((A1 + A2) / 2) × 0,4) + (A3 × 0,6)</a:t>
+              <a:t>Quatro fóruns na Turma Virtual do SIGAA, todos sem nota</a:t>
             </a:r>
             <a:endParaRPr lang="en-US" sz="1400" dirty="0"/>
           </a:p>
         </p:txBody>
       </p:sp>
-      <p:sp>
-        <p:nvSpPr>
-          <p:cNvPr id="4" name="Text 2"/>
-          <p:cNvSpPr txBox="1"/>
-          <p:nvPr/>
-        </p:nvSpPr>
-        <p:spPr>
-          <a:xfrm>
-            <a:off x="685800" y="1325880"/>
-            <a:ext cx="2456688" cy="2103120"/>
-          </a:xfrm>
-          <a:prstGeom prst="roundRect">
-            <a:avLst>
-              <a:gd name="adj" fmla="val 2609"/>
-            </a:avLst>
-          </a:prstGeom>
-          <a:solidFill>
-            <a:srgbClr val="FFFFFF"/>
-          </a:solidFill>
-          <a:ln w="12700">
-            <a:solidFill>
-              <a:srgbClr val="DCD5C1"/>
-            </a:solidFill>
-          </a:ln>
-        </p:spPr>
-        <p:txBody>
-          <a:bodyPr wrap="square" lIns="101600" tIns="101600" rIns="101600" bIns="101600" rtlCol="0" anchor="t"/>
-          <a:lstStyle/>
-          <a:p>
-            <a:pPr algn="l" indent="0" marL="0">
-              <a:lnSpc>
-                <a:spcPct val="100000"/>
-              </a:lnSpc>
-              <a:spcAft>
-                <a:spcPts val="200"/>
-              </a:spcAft>
-              <a:buNone/>
-            </a:pPr>
-            <a:r>
-              <a:rPr lang="en-US" sz="1100" b="1" dirty="0">
-                <a:solidFill>
-                  <a:srgbClr val="2A8C85"/>
-                </a:solidFill>
-                <a:latin typeface="Calibri" pitchFamily="34" charset="0"/>
-                <a:ea typeface="Calibri" pitchFamily="34" charset="-122"/>
-                <a:cs typeface="Calibri" pitchFamily="34" charset="-120"/>
-              </a:rPr>
-              <a:t>ATÉ 25/10 · 40% (COM A A2)</a:t>
-            </a:r>
-            <a:endParaRPr lang="en-US" sz="1100" dirty="0"/>
-          </a:p>
-          <a:p>
-            <a:pPr algn="l" indent="0" marL="0">
-              <a:lnSpc>
-                <a:spcPct val="100000"/>
-              </a:lnSpc>
-              <a:spcAft>
-                <a:spcPts val="300"/>
-              </a:spcAft>
-              <a:buNone/>
-            </a:pPr>
-            <a:r>
-              <a:rPr lang="en-US" sz="1600" b="1" dirty="0">
-                <a:solidFill>
-                  <a:srgbClr val="13294B"/>
-                </a:solidFill>
-                <a:latin typeface="Calibri" pitchFamily="34" charset="0"/>
-                <a:ea typeface="Calibri" pitchFamily="34" charset="-122"/>
-                <a:cs typeface="Calibri" pitchFamily="34" charset="-120"/>
-              </a:rPr>
-              <a:t>A1 · Questionário</a:t>
-            </a:r>
-            <a:endParaRPr lang="en-US" sz="1100" dirty="0"/>
-          </a:p>
-          <a:p>
-            <a:pPr algn="l" indent="0" marL="0">
-              <a:lnSpc>
-                <a:spcPct val="100000"/>
-              </a:lnSpc>
-              <a:buNone/>
-            </a:pPr>
-            <a:r>
-              <a:rPr lang="en-US" sz="1350" dirty="0">
-                <a:solidFill>
-                  <a:srgbClr val="1F2A37"/>
-                </a:solidFill>
-                <a:latin typeface="Calibri" pitchFamily="34" charset="0"/>
-                <a:ea typeface="Calibri" pitchFamily="34" charset="-122"/>
-                <a:cs typeface="Calibri" pitchFamily="34" charset="-120"/>
-              </a:rPr>
-              <a:t>10 questões objetivas no SIGAA sobre as Unidades 1 e 2. Uma tentativa de 60 minutos.</a:t>
-            </a:r>
-            <a:endParaRPr lang="en-US" sz="1100" dirty="0"/>
-          </a:p>
-        </p:txBody>
-      </p:sp>
-      <p:sp>
-        <p:nvSpPr>
-          <p:cNvPr id="5" name="Text 3"/>
-          <p:cNvSpPr txBox="1"/>
-          <p:nvPr/>
-        </p:nvSpPr>
-        <p:spPr>
-          <a:xfrm>
-            <a:off x="3343656" y="1325880"/>
-            <a:ext cx="2456688" cy="2103120"/>
-          </a:xfrm>
-          <a:prstGeom prst="roundRect">
-            <a:avLst>
-              <a:gd name="adj" fmla="val 2609"/>
-            </a:avLst>
-          </a:prstGeom>
-          <a:solidFill>
-            <a:srgbClr val="FFFFFF"/>
-          </a:solidFill>
-          <a:ln w="12700">
-            <a:solidFill>
-              <a:srgbClr val="DCD5C1"/>
-            </a:solidFill>
-          </a:ln>
-        </p:spPr>
-        <p:txBody>
-          <a:bodyPr wrap="square" lIns="101600" tIns="101600" rIns="101600" bIns="101600" rtlCol="0" anchor="t"/>
-          <a:lstStyle/>
-          <a:p>
-            <a:pPr algn="l" indent="0" marL="0">
-              <a:lnSpc>
-                <a:spcPct val="100000"/>
-              </a:lnSpc>
-              <a:spcAft>
-                <a:spcPts val="200"/>
-              </a:spcAft>
-              <a:buNone/>
-            </a:pPr>
-            <a:r>
-              <a:rPr lang="en-US" sz="1100" b="1" dirty="0">
-                <a:solidFill>
-                  <a:srgbClr val="2A8C85"/>
-                </a:solidFill>
-                <a:latin typeface="Calibri" pitchFamily="34" charset="0"/>
-                <a:ea typeface="Calibri" pitchFamily="34" charset="-122"/>
-                <a:cs typeface="Calibri" pitchFamily="34" charset="-120"/>
-              </a:rPr>
-              <a:t>ATÉ 08/11 · 40% (COM A A1)</a:t>
-            </a:r>
-            <a:endParaRPr lang="en-US" sz="1100" dirty="0"/>
-          </a:p>
-          <a:p>
-            <a:pPr algn="l" indent="0" marL="0">
-              <a:lnSpc>
-                <a:spcPct val="100000"/>
-              </a:lnSpc>
-              <a:spcAft>
-                <a:spcPts val="300"/>
-              </a:spcAft>
-              <a:buNone/>
-            </a:pPr>
-            <a:r>
-              <a:rPr lang="en-US" sz="1600" b="1" dirty="0">
-                <a:solidFill>
-                  <a:srgbClr val="13294B"/>
-                </a:solidFill>
-                <a:latin typeface="Calibri" pitchFamily="34" charset="0"/>
-                <a:ea typeface="Calibri" pitchFamily="34" charset="-122"/>
-                <a:cs typeface="Calibri" pitchFamily="34" charset="-120"/>
-              </a:rPr>
-              <a:t>A2 · Questionário</a:t>
-            </a:r>
-            <a:endParaRPr lang="en-US" sz="1100" dirty="0"/>
-          </a:p>
-          <a:p>
-            <a:pPr algn="l" indent="0" marL="0">
-              <a:lnSpc>
-                <a:spcPct val="100000"/>
-              </a:lnSpc>
-              <a:buNone/>
-            </a:pPr>
-            <a:r>
-              <a:rPr lang="en-US" sz="1350" dirty="0">
-                <a:solidFill>
-                  <a:srgbClr val="1F2A37"/>
-                </a:solidFill>
-                <a:latin typeface="Calibri" pitchFamily="34" charset="0"/>
-                <a:ea typeface="Calibri" pitchFamily="34" charset="-122"/>
-                <a:cs typeface="Calibri" pitchFamily="34" charset="-120"/>
-              </a:rPr>
-              <a:t>10 questões objetivas no SIGAA sobre as Unidades 3 e 4. Uma tentativa de 60 minutos.</a:t>
-            </a:r>
-            <a:endParaRPr lang="en-US" sz="1100" dirty="0"/>
-          </a:p>
-        </p:txBody>
-      </p:sp>
-      <p:sp>
-        <p:nvSpPr>
-          <p:cNvPr id="6" name="Text 4"/>
-          <p:cNvSpPr txBox="1"/>
-          <p:nvPr/>
-        </p:nvSpPr>
-        <p:spPr>
-          <a:xfrm>
-            <a:off x="6001512" y="1325880"/>
-            <a:ext cx="2456688" cy="2103120"/>
-          </a:xfrm>
-          <a:prstGeom prst="roundRect">
-            <a:avLst>
-              <a:gd name="adj" fmla="val 2609"/>
-            </a:avLst>
-          </a:prstGeom>
-          <a:solidFill>
-            <a:srgbClr val="FFFFFF"/>
-          </a:solidFill>
-          <a:ln w="12700">
-            <a:solidFill>
-              <a:srgbClr val="DCD5C1"/>
-            </a:solidFill>
-          </a:ln>
-        </p:spPr>
-        <p:txBody>
-          <a:bodyPr wrap="square" lIns="101600" tIns="101600" rIns="101600" bIns="101600" rtlCol="0" anchor="t"/>
-          <a:lstStyle/>
-          <a:p>
-            <a:pPr algn="l" indent="0" marL="0">
-              <a:lnSpc>
-                <a:spcPct val="100000"/>
-              </a:lnSpc>
-              <a:spcAft>
-                <a:spcPts val="200"/>
-              </a:spcAft>
-              <a:buNone/>
-            </a:pPr>
-            <a:r>
-              <a:rPr lang="en-US" sz="1100" b="1" dirty="0">
-                <a:solidFill>
-                  <a:srgbClr val="2A8C85"/>
-                </a:solidFill>
-                <a:latin typeface="Calibri" pitchFamily="34" charset="0"/>
-                <a:ea typeface="Calibri" pitchFamily="34" charset="-122"/>
-                <a:cs typeface="Calibri" pitchFamily="34" charset="-120"/>
-              </a:rPr>
-              <a:t>ATÉ 15/11 · 60%</a:t>
-            </a:r>
-            <a:endParaRPr lang="en-US" sz="1100" dirty="0"/>
-          </a:p>
-          <a:p>
-            <a:pPr algn="l" indent="0" marL="0">
-              <a:lnSpc>
-                <a:spcPct val="100000"/>
-              </a:lnSpc>
-              <a:spcAft>
-                <a:spcPts val="300"/>
-              </a:spcAft>
-              <a:buNone/>
-            </a:pPr>
-            <a:r>
-              <a:rPr lang="en-US" sz="1600" b="1" dirty="0">
-                <a:solidFill>
-                  <a:srgbClr val="13294B"/>
-                </a:solidFill>
-                <a:latin typeface="Calibri" pitchFamily="34" charset="0"/>
-                <a:ea typeface="Calibri" pitchFamily="34" charset="-122"/>
-                <a:cs typeface="Calibri" pitchFamily="34" charset="-120"/>
-              </a:rPr>
-              <a:t>A3 · Objetivas + caso</a:t>
-            </a:r>
-            <a:endParaRPr lang="en-US" sz="1100" dirty="0"/>
-          </a:p>
-          <a:p>
-            <a:pPr algn="l" indent="0" marL="0">
-              <a:lnSpc>
-                <a:spcPct val="100000"/>
-              </a:lnSpc>
-              <a:buNone/>
-            </a:pPr>
-            <a:r>
-              <a:rPr lang="en-US" sz="1350" dirty="0">
-                <a:solidFill>
-                  <a:srgbClr val="1F2A37"/>
-                </a:solidFill>
-                <a:latin typeface="Calibri" pitchFamily="34" charset="0"/>
-                <a:ea typeface="Calibri" pitchFamily="34" charset="-122"/>
-                <a:cs typeface="Calibri" pitchFamily="34" charset="-120"/>
-              </a:rPr>
-              <a:t>10 questões objetivas e um estudo de caso discursivo sobre todo o conteúdo, enviado em arquivo.</a:t>
-            </a:r>
-            <a:endParaRPr lang="en-US" sz="1100" dirty="0"/>
-          </a:p>
-        </p:txBody>
-      </p:sp>
-      <p:sp>
-        <p:nvSpPr>
-          <p:cNvPr id="7" name="Text 5"/>
-          <p:cNvSpPr txBox="1"/>
-          <p:nvPr/>
-        </p:nvSpPr>
-        <p:spPr>
-          <a:xfrm>
-            <a:off x="685800" y="3657600"/>
-            <a:ext cx="7772400" cy="658368"/>
-          </a:xfrm>
-          <a:prstGeom prst="roundRect">
-            <a:avLst>
-              <a:gd name="adj" fmla="val 11111"/>
-            </a:avLst>
-          </a:prstGeom>
-          <a:solidFill>
-            <a:srgbClr val="E6F2F0"/>
-          </a:solidFill>
-          <a:ln/>
-        </p:spPr>
-        <p:txBody>
-          <a:bodyPr wrap="square" lIns="127000" tIns="127000" rIns="127000" bIns="127000" rtlCol="0" anchor="ctr"/>
-          <a:lstStyle/>
-          <a:p>
-            <a:pPr algn="ctr" indent="0" marL="0">
-              <a:lnSpc>
-                <a:spcPct val="100000"/>
-              </a:lnSpc>
-              <a:buNone/>
-            </a:pPr>
-            <a:r>
-              <a:rPr lang="en-US" sz="1350" dirty="0">
-                <a:solidFill>
-                  <a:srgbClr val="13294B"/>
-                </a:solidFill>
-                <a:latin typeface="Calibri" pitchFamily="34" charset="0"/>
-                <a:ea typeface="Calibri" pitchFamily="34" charset="-122"/>
-                <a:cs typeface="Calibri" pitchFamily="34" charset="-120"/>
-              </a:rPr>
-              <a:t>Aprovação: nota final igual ou superior a 7,0 e 75% de frequência. Exercícios de fixação (sem nota) ajudam a preparar cada avaliação.</a:t>
-            </a:r>
-            <a:endParaRPr lang="en-US" sz="1350" dirty="0"/>
-          </a:p>
-        </p:txBody>
-      </p:sp>
-      <p:sp>
-        <p:nvSpPr>
-          <p:cNvPr id="8" name="Text 6"/>
+      <p:graphicFrame>
+        <p:nvGraphicFramePr>
+          <p:cNvPr id="10" name="Table 0"/>
+          <p:cNvGraphicFramePr>
+            <a:graphicFrameLocks noGrp="1"/>
+          </p:cNvGraphicFramePr>
+          <p:nvPr>
+            <p:extLst>
+              <p:ext uri="{D42A27DB-BD31-4B8C-83A1-F6EECF244321}">
+                <p14:modId xmlns:p14="http://schemas.microsoft.com/office/powerpoint/2010/main" val="1579011935"/>
+              </p:ext>
+            </p:extLst>
+          </p:nvPr>
+        </p:nvGraphicFramePr>
+        <p:xfrm>
+          <a:off x="685800" y="1261872"/>
+          <a:ext cx="7772400" cy="914400"/>
+        </p:xfrm>
+        <a:graphic>
+          <a:graphicData uri="http://schemas.openxmlformats.org/drawingml/2006/table">
+            <a:tbl>
+              <a:tblPr/>
+              <a:tblGrid>
+                <a:gridCol w="1600200"/>
+                <a:gridCol w="1280160"/>
+                <a:gridCol w="4892040"/>
+              </a:tblGrid>
+              <a:tr h="0">
+                <a:tc>
+                  <a:txBody>
+                    <a:bodyPr/>
+                    <a:lstStyle/>
+                    <a:p>
+                      <a:pPr indent="0" marL="0">
+                        <a:buNone/>
+                      </a:pPr>
+                      <a:r>
+                        <a:rPr lang="en-US" sz="1150" b="1" dirty="0">
+                          <a:solidFill>
+                            <a:srgbClr val="FFFFFF"/>
+                          </a:solidFill>
+                          <a:latin typeface="Calibri" pitchFamily="34" charset="0"/>
+                          <a:ea typeface="Calibri" pitchFamily="34" charset="-122"/>
+                          <a:cs typeface="Calibri" pitchFamily="34" charset="-120"/>
+                        </a:rPr>
+                        <a:t>Fórum</a:t>
+                      </a:r>
+                      <a:endParaRPr lang="en-US" sz="1150" dirty="0">
+                        <a:latin typeface="Calibri" charset="0"/>
+                        <a:ea typeface="Calibri" charset="0"/>
+                        <a:cs typeface="Calibri" charset="0"/>
+                      </a:endParaRPr>
+                    </a:p>
+                  </a:txBody>
+                  <a:tcPr marL="50800" marR="50800" marT="50800" marB="50800" anchor="ctr">
+                    <a:lnL w="9525" cap="flat" cmpd="sng" algn="ctr">
+                      <a:solidFill>
+                        <a:srgbClr val="DCD5C1"/>
+                      </a:solidFill>
+                      <a:prstDash val="solid"/>
+                      <a:round/>
+                      <a:headEnd type="none" w="med" len="med"/>
+                      <a:tailEnd type="none" w="med" len="med"/>
+                    </a:lnL>
+                    <a:lnR w="9525" cap="flat" cmpd="sng" algn="ctr">
+                      <a:solidFill>
+                        <a:srgbClr val="DCD5C1"/>
+                      </a:solidFill>
+                      <a:prstDash val="solid"/>
+                      <a:round/>
+                      <a:headEnd type="none" w="med" len="med"/>
+                      <a:tailEnd type="none" w="med" len="med"/>
+                    </a:lnR>
+                    <a:lnT w="9525" cap="flat" cmpd="sng" algn="ctr">
+                      <a:solidFill>
+                        <a:srgbClr val="DCD5C1"/>
+                      </a:solidFill>
+                      <a:prstDash val="solid"/>
+                      <a:round/>
+                      <a:headEnd type="none" w="med" len="med"/>
+                      <a:tailEnd type="none" w="med" len="med"/>
+                    </a:lnT>
+                    <a:lnB w="9525" cap="flat" cmpd="sng" algn="ctr">
+                      <a:solidFill>
+                        <a:srgbClr val="DCD5C1"/>
+                      </a:solidFill>
+                      <a:prstDash val="solid"/>
+                      <a:round/>
+                      <a:headEnd type="none" w="med" len="med"/>
+                      <a:tailEnd type="none" w="med" len="med"/>
+                    </a:lnB>
+                    <a:solidFill>
+                      <a:srgbClr val="13294B"/>
+                    </a:solidFill>
+                  </a:tcPr>
+                </a:tc>
+                <a:tc>
+                  <a:txBody>
+                    <a:bodyPr/>
+                    <a:lstStyle/>
+                    <a:p>
+                      <a:pPr indent="0" marL="0">
+                        <a:buNone/>
+                      </a:pPr>
+                      <a:r>
+                        <a:rPr lang="en-US" sz="1150" b="1" dirty="0">
+                          <a:solidFill>
+                            <a:srgbClr val="FFFFFF"/>
+                          </a:solidFill>
+                          <a:latin typeface="Calibri" pitchFamily="34" charset="0"/>
+                          <a:ea typeface="Calibri" pitchFamily="34" charset="-122"/>
+                          <a:cs typeface="Calibri" pitchFamily="34" charset="-120"/>
+                        </a:rPr>
+                        <a:t>Período</a:t>
+                      </a:r>
+                      <a:endParaRPr lang="en-US" sz="1150" dirty="0">
+                        <a:latin typeface="Calibri" charset="0"/>
+                        <a:ea typeface="Calibri" charset="0"/>
+                        <a:cs typeface="Calibri" charset="0"/>
+                      </a:endParaRPr>
+                    </a:p>
+                  </a:txBody>
+                  <a:tcPr marL="50800" marR="50800" marT="50800" marB="50800" anchor="ctr">
+                    <a:lnL w="9525" cap="flat" cmpd="sng" algn="ctr">
+                      <a:solidFill>
+                        <a:srgbClr val="DCD5C1"/>
+                      </a:solidFill>
+                      <a:prstDash val="solid"/>
+                      <a:round/>
+                      <a:headEnd type="none" w="med" len="med"/>
+                      <a:tailEnd type="none" w="med" len="med"/>
+                    </a:lnL>
+                    <a:lnR w="9525" cap="flat" cmpd="sng" algn="ctr">
+                      <a:solidFill>
+                        <a:srgbClr val="DCD5C1"/>
+                      </a:solidFill>
+                      <a:prstDash val="solid"/>
+                      <a:round/>
+                      <a:headEnd type="none" w="med" len="med"/>
+                      <a:tailEnd type="none" w="med" len="med"/>
+                    </a:lnR>
+                    <a:lnT w="9525" cap="flat" cmpd="sng" algn="ctr">
+                      <a:solidFill>
+                        <a:srgbClr val="DCD5C1"/>
+                      </a:solidFill>
+                      <a:prstDash val="solid"/>
+                      <a:round/>
+                      <a:headEnd type="none" w="med" len="med"/>
+                      <a:tailEnd type="none" w="med" len="med"/>
+                    </a:lnT>
+                    <a:lnB w="9525" cap="flat" cmpd="sng" algn="ctr">
+                      <a:solidFill>
+                        <a:srgbClr val="DCD5C1"/>
+                      </a:solidFill>
+                      <a:prstDash val="solid"/>
+                      <a:round/>
+                      <a:headEnd type="none" w="med" len="med"/>
+                      <a:tailEnd type="none" w="med" len="med"/>
+                    </a:lnB>
+                    <a:solidFill>
+                      <a:srgbClr val="13294B"/>
+                    </a:solidFill>
+                  </a:tcPr>
+                </a:tc>
+                <a:tc>
+                  <a:txBody>
+                    <a:bodyPr/>
+                    <a:lstStyle/>
+                    <a:p>
+                      <a:pPr indent="0" marL="0">
+                        <a:buNone/>
+                      </a:pPr>
+                      <a:r>
+                        <a:rPr lang="en-US" sz="1150" b="1" dirty="0">
+                          <a:solidFill>
+                            <a:srgbClr val="FFFFFF"/>
+                          </a:solidFill>
+                          <a:latin typeface="Calibri" pitchFamily="34" charset="0"/>
+                          <a:ea typeface="Calibri" pitchFamily="34" charset="-122"/>
+                          <a:cs typeface="Calibri" pitchFamily="34" charset="-120"/>
+                        </a:rPr>
+                        <a:t>O que o aluno faz</a:t>
+                      </a:r>
+                      <a:endParaRPr lang="en-US" sz="1150" dirty="0">
+                        <a:latin typeface="Calibri" charset="0"/>
+                        <a:ea typeface="Calibri" charset="0"/>
+                        <a:cs typeface="Calibri" charset="0"/>
+                      </a:endParaRPr>
+                    </a:p>
+                  </a:txBody>
+                  <a:tcPr marL="50800" marR="50800" marT="50800" marB="50800" anchor="ctr">
+                    <a:lnL w="9525" cap="flat" cmpd="sng" algn="ctr">
+                      <a:solidFill>
+                        <a:srgbClr val="DCD5C1"/>
+                      </a:solidFill>
+                      <a:prstDash val="solid"/>
+                      <a:round/>
+                      <a:headEnd type="none" w="med" len="med"/>
+                      <a:tailEnd type="none" w="med" len="med"/>
+                    </a:lnL>
+                    <a:lnR w="9525" cap="flat" cmpd="sng" algn="ctr">
+                      <a:solidFill>
+                        <a:srgbClr val="DCD5C1"/>
+                      </a:solidFill>
+                      <a:prstDash val="solid"/>
+                      <a:round/>
+                      <a:headEnd type="none" w="med" len="med"/>
+                      <a:tailEnd type="none" w="med" len="med"/>
+                    </a:lnR>
+                    <a:lnT w="9525" cap="flat" cmpd="sng" algn="ctr">
+                      <a:solidFill>
+                        <a:srgbClr val="DCD5C1"/>
+                      </a:solidFill>
+                      <a:prstDash val="solid"/>
+                      <a:round/>
+                      <a:headEnd type="none" w="med" len="med"/>
+                      <a:tailEnd type="none" w="med" len="med"/>
+                    </a:lnT>
+                    <a:lnB w="9525" cap="flat" cmpd="sng" algn="ctr">
+                      <a:solidFill>
+                        <a:srgbClr val="DCD5C1"/>
+                      </a:solidFill>
+                      <a:prstDash val="solid"/>
+                      <a:round/>
+                      <a:headEnd type="none" w="med" len="med"/>
+                      <a:tailEnd type="none" w="med" len="med"/>
+                    </a:lnB>
+                    <a:solidFill>
+                      <a:srgbClr val="13294B"/>
+                    </a:solidFill>
+                  </a:tcPr>
+                </a:tc>
+              </a:tr>
+              <a:tr h="0">
+                <a:tc>
+                  <a:txBody>
+                    <a:bodyPr/>
+                    <a:lstStyle/>
+                    <a:p>
+                      <a:pPr indent="0" marL="0">
+                        <a:buNone/>
+                      </a:pPr>
+                      <a:r>
+                        <a:rPr lang="en-US" sz="1150" b="1" dirty="0">
+                          <a:solidFill>
+                            <a:srgbClr val="1F2A37"/>
+                          </a:solidFill>
+                          <a:latin typeface="Calibri" pitchFamily="34" charset="0"/>
+                          <a:ea typeface="Calibri" pitchFamily="34" charset="-122"/>
+                          <a:cs typeface="Calibri" pitchFamily="34" charset="-120"/>
+                        </a:rPr>
+                        <a:t>Fórum de apresentação</a:t>
+                      </a:r>
+                      <a:endParaRPr lang="en-US" sz="1150" dirty="0">
+                        <a:latin typeface="Calibri" charset="0"/>
+                        <a:ea typeface="Calibri" charset="0"/>
+                        <a:cs typeface="Calibri" charset="0"/>
+                      </a:endParaRPr>
+                    </a:p>
+                  </a:txBody>
+                  <a:tcPr marL="50800" marR="50800" marT="50800" marB="50800" anchor="ctr">
+                    <a:lnL w="9525" cap="flat" cmpd="sng" algn="ctr">
+                      <a:solidFill>
+                        <a:srgbClr val="DCD5C1"/>
+                      </a:solidFill>
+                      <a:prstDash val="solid"/>
+                      <a:round/>
+                      <a:headEnd type="none" w="med" len="med"/>
+                      <a:tailEnd type="none" w="med" len="med"/>
+                    </a:lnL>
+                    <a:lnR w="9525" cap="flat" cmpd="sng" algn="ctr">
+                      <a:solidFill>
+                        <a:srgbClr val="DCD5C1"/>
+                      </a:solidFill>
+                      <a:prstDash val="solid"/>
+                      <a:round/>
+                      <a:headEnd type="none" w="med" len="med"/>
+                      <a:tailEnd type="none" w="med" len="med"/>
+                    </a:lnR>
+                    <a:lnT w="9525" cap="flat" cmpd="sng" algn="ctr">
+                      <a:solidFill>
+                        <a:srgbClr val="DCD5C1"/>
+                      </a:solidFill>
+                      <a:prstDash val="solid"/>
+                      <a:round/>
+                      <a:headEnd type="none" w="med" len="med"/>
+                      <a:tailEnd type="none" w="med" len="med"/>
+                    </a:lnT>
+                    <a:lnB w="9525" cap="flat" cmpd="sng" algn="ctr">
+                      <a:solidFill>
+                        <a:srgbClr val="DCD5C1"/>
+                      </a:solidFill>
+                      <a:prstDash val="solid"/>
+                      <a:round/>
+                      <a:headEnd type="none" w="med" len="med"/>
+                      <a:tailEnd type="none" w="med" len="med"/>
+                    </a:lnB>
+                    <a:solidFill>
+                      <a:srgbClr val="FFFFFF"/>
+                    </a:solidFill>
+                  </a:tcPr>
+                </a:tc>
+                <a:tc>
+                  <a:txBody>
+                    <a:bodyPr/>
+                    <a:lstStyle/>
+                    <a:p>
+                      <a:pPr indent="0" marL="0">
+                        <a:buNone/>
+                      </a:pPr>
+                      <a:r>
+                        <a:rPr lang="en-US" sz="1150" dirty="0">
+                          <a:solidFill>
+                            <a:srgbClr val="1F2A37"/>
+                          </a:solidFill>
+                          <a:latin typeface="Calibri" pitchFamily="34" charset="0"/>
+                          <a:ea typeface="Calibri" pitchFamily="34" charset="-122"/>
+                          <a:cs typeface="Calibri" pitchFamily="34" charset="-120"/>
+                        </a:rPr>
+                        <a:t>09/10 a 18/10</a:t>
+                      </a:r>
+                      <a:endParaRPr lang="en-US" sz="1150" dirty="0">
+                        <a:latin typeface="Calibri" charset="0"/>
+                        <a:ea typeface="Calibri" charset="0"/>
+                        <a:cs typeface="Calibri" charset="0"/>
+                      </a:endParaRPr>
+                    </a:p>
+                  </a:txBody>
+                  <a:tcPr marL="50800" marR="50800" marT="50800" marB="50800" anchor="ctr">
+                    <a:lnL w="9525" cap="flat" cmpd="sng" algn="ctr">
+                      <a:solidFill>
+                        <a:srgbClr val="DCD5C1"/>
+                      </a:solidFill>
+                      <a:prstDash val="solid"/>
+                      <a:round/>
+                      <a:headEnd type="none" w="med" len="med"/>
+                      <a:tailEnd type="none" w="med" len="med"/>
+                    </a:lnL>
+                    <a:lnR w="9525" cap="flat" cmpd="sng" algn="ctr">
+                      <a:solidFill>
+                        <a:srgbClr val="DCD5C1"/>
+                      </a:solidFill>
+                      <a:prstDash val="solid"/>
+                      <a:round/>
+                      <a:headEnd type="none" w="med" len="med"/>
+                      <a:tailEnd type="none" w="med" len="med"/>
+                    </a:lnR>
+                    <a:lnT w="9525" cap="flat" cmpd="sng" algn="ctr">
+                      <a:solidFill>
+                        <a:srgbClr val="DCD5C1"/>
+                      </a:solidFill>
+                      <a:prstDash val="solid"/>
+                      <a:round/>
+                      <a:headEnd type="none" w="med" len="med"/>
+                      <a:tailEnd type="none" w="med" len="med"/>
+                    </a:lnT>
+                    <a:lnB w="9525" cap="flat" cmpd="sng" algn="ctr">
+                      <a:solidFill>
+                        <a:srgbClr val="DCD5C1"/>
+                      </a:solidFill>
+                      <a:prstDash val="solid"/>
+                      <a:round/>
+                      <a:headEnd type="none" w="med" len="med"/>
+                      <a:tailEnd type="none" w="med" len="med"/>
+                    </a:lnB>
+                    <a:solidFill>
+                      <a:srgbClr val="FFFFFF"/>
+                    </a:solidFill>
+                  </a:tcPr>
+                </a:tc>
+                <a:tc>
+                  <a:txBody>
+                    <a:bodyPr/>
+                    <a:lstStyle/>
+                    <a:p>
+                      <a:pPr indent="0" marL="0">
+                        <a:buNone/>
+                      </a:pPr>
+                      <a:r>
+                        <a:rPr lang="en-US" sz="1150" dirty="0">
+                          <a:solidFill>
+                            <a:srgbClr val="1F2A37"/>
+                          </a:solidFill>
+                          <a:latin typeface="Calibri" pitchFamily="34" charset="0"/>
+                          <a:ea typeface="Calibri" pitchFamily="34" charset="-122"/>
+                          <a:cs typeface="Calibri" pitchFamily="34" charset="-120"/>
+                        </a:rPr>
+                        <a:t>Posta de 5 a 10 linhas: nome, cidade e polo, onde trabalha e o que entende hoje por “papel do Estado na economia”. Comenta a apresentação de pelo menos um colega.</a:t>
+                      </a:r>
+                      <a:endParaRPr lang="en-US" sz="1150" dirty="0">
+                        <a:latin typeface="Calibri" charset="0"/>
+                        <a:ea typeface="Calibri" charset="0"/>
+                        <a:cs typeface="Calibri" charset="0"/>
+                      </a:endParaRPr>
+                    </a:p>
+                  </a:txBody>
+                  <a:tcPr marL="50800" marR="50800" marT="50800" marB="50800" anchor="ctr">
+                    <a:lnL w="9525" cap="flat" cmpd="sng" algn="ctr">
+                      <a:solidFill>
+                        <a:srgbClr val="DCD5C1"/>
+                      </a:solidFill>
+                      <a:prstDash val="solid"/>
+                      <a:round/>
+                      <a:headEnd type="none" w="med" len="med"/>
+                      <a:tailEnd type="none" w="med" len="med"/>
+                    </a:lnL>
+                    <a:lnR w="9525" cap="flat" cmpd="sng" algn="ctr">
+                      <a:solidFill>
+                        <a:srgbClr val="DCD5C1"/>
+                      </a:solidFill>
+                      <a:prstDash val="solid"/>
+                      <a:round/>
+                      <a:headEnd type="none" w="med" len="med"/>
+                      <a:tailEnd type="none" w="med" len="med"/>
+                    </a:lnR>
+                    <a:lnT w="9525" cap="flat" cmpd="sng" algn="ctr">
+                      <a:solidFill>
+                        <a:srgbClr val="DCD5C1"/>
+                      </a:solidFill>
+                      <a:prstDash val="solid"/>
+                      <a:round/>
+                      <a:headEnd type="none" w="med" len="med"/>
+                      <a:tailEnd type="none" w="med" len="med"/>
+                    </a:lnT>
+                    <a:lnB w="9525" cap="flat" cmpd="sng" algn="ctr">
+                      <a:solidFill>
+                        <a:srgbClr val="DCD5C1"/>
+                      </a:solidFill>
+                      <a:prstDash val="solid"/>
+                      <a:round/>
+                      <a:headEnd type="none" w="med" len="med"/>
+                      <a:tailEnd type="none" w="med" len="med"/>
+                    </a:lnB>
+                    <a:solidFill>
+                      <a:srgbClr val="FFFFFF"/>
+                    </a:solidFill>
+                  </a:tcPr>
+                </a:tc>
+              </a:tr>
+              <a:tr h="0">
+                <a:tc>
+                  <a:txBody>
+                    <a:bodyPr/>
+                    <a:lstStyle/>
+                    <a:p>
+                      <a:pPr indent="0" marL="0">
+                        <a:buNone/>
+                      </a:pPr>
+                      <a:r>
+                        <a:rPr lang="en-US" sz="1150" b="1" dirty="0">
+                          <a:solidFill>
+                            <a:srgbClr val="1F2A37"/>
+                          </a:solidFill>
+                          <a:latin typeface="Calibri" pitchFamily="34" charset="0"/>
+                          <a:ea typeface="Calibri" pitchFamily="34" charset="-122"/>
+                          <a:cs typeface="Calibri" pitchFamily="34" charset="-120"/>
+                        </a:rPr>
+                        <a:t>Fórum de dúvidas</a:t>
+                      </a:r>
+                      <a:endParaRPr lang="en-US" sz="1150" dirty="0">
+                        <a:latin typeface="Calibri" charset="0"/>
+                        <a:ea typeface="Calibri" charset="0"/>
+                        <a:cs typeface="Calibri" charset="0"/>
+                      </a:endParaRPr>
+                    </a:p>
+                  </a:txBody>
+                  <a:tcPr marL="50800" marR="50800" marT="50800" marB="50800" anchor="ctr">
+                    <a:lnL w="9525" cap="flat" cmpd="sng" algn="ctr">
+                      <a:solidFill>
+                        <a:srgbClr val="DCD5C1"/>
+                      </a:solidFill>
+                      <a:prstDash val="solid"/>
+                      <a:round/>
+                      <a:headEnd type="none" w="med" len="med"/>
+                      <a:tailEnd type="none" w="med" len="med"/>
+                    </a:lnL>
+                    <a:lnR w="9525" cap="flat" cmpd="sng" algn="ctr">
+                      <a:solidFill>
+                        <a:srgbClr val="DCD5C1"/>
+                      </a:solidFill>
+                      <a:prstDash val="solid"/>
+                      <a:round/>
+                      <a:headEnd type="none" w="med" len="med"/>
+                      <a:tailEnd type="none" w="med" len="med"/>
+                    </a:lnR>
+                    <a:lnT w="9525" cap="flat" cmpd="sng" algn="ctr">
+                      <a:solidFill>
+                        <a:srgbClr val="DCD5C1"/>
+                      </a:solidFill>
+                      <a:prstDash val="solid"/>
+                      <a:round/>
+                      <a:headEnd type="none" w="med" len="med"/>
+                      <a:tailEnd type="none" w="med" len="med"/>
+                    </a:lnT>
+                    <a:lnB w="9525" cap="flat" cmpd="sng" algn="ctr">
+                      <a:solidFill>
+                        <a:srgbClr val="DCD5C1"/>
+                      </a:solidFill>
+                      <a:prstDash val="solid"/>
+                      <a:round/>
+                      <a:headEnd type="none" w="med" len="med"/>
+                      <a:tailEnd type="none" w="med" len="med"/>
+                    </a:lnB>
+                    <a:solidFill>
+                      <a:srgbClr val="F4F7F8"/>
+                    </a:solidFill>
+                  </a:tcPr>
+                </a:tc>
+                <a:tc>
+                  <a:txBody>
+                    <a:bodyPr/>
+                    <a:lstStyle/>
+                    <a:p>
+                      <a:pPr indent="0" marL="0">
+                        <a:buNone/>
+                      </a:pPr>
+                      <a:r>
+                        <a:rPr lang="en-US" sz="1150" dirty="0">
+                          <a:solidFill>
+                            <a:srgbClr val="1F2A37"/>
+                          </a:solidFill>
+                          <a:latin typeface="Calibri" pitchFamily="34" charset="0"/>
+                          <a:ea typeface="Calibri" pitchFamily="34" charset="-122"/>
+                          <a:cs typeface="Calibri" pitchFamily="34" charset="-120"/>
+                        </a:rPr>
+                        <a:t>a disciplina toda</a:t>
+                      </a:r>
+                      <a:endParaRPr lang="en-US" sz="1150" dirty="0">
+                        <a:latin typeface="Calibri" charset="0"/>
+                        <a:ea typeface="Calibri" charset="0"/>
+                        <a:cs typeface="Calibri" charset="0"/>
+                      </a:endParaRPr>
+                    </a:p>
+                  </a:txBody>
+                  <a:tcPr marL="50800" marR="50800" marT="50800" marB="50800" anchor="ctr">
+                    <a:lnL w="9525" cap="flat" cmpd="sng" algn="ctr">
+                      <a:solidFill>
+                        <a:srgbClr val="DCD5C1"/>
+                      </a:solidFill>
+                      <a:prstDash val="solid"/>
+                      <a:round/>
+                      <a:headEnd type="none" w="med" len="med"/>
+                      <a:tailEnd type="none" w="med" len="med"/>
+                    </a:lnL>
+                    <a:lnR w="9525" cap="flat" cmpd="sng" algn="ctr">
+                      <a:solidFill>
+                        <a:srgbClr val="DCD5C1"/>
+                      </a:solidFill>
+                      <a:prstDash val="solid"/>
+                      <a:round/>
+                      <a:headEnd type="none" w="med" len="med"/>
+                      <a:tailEnd type="none" w="med" len="med"/>
+                    </a:lnR>
+                    <a:lnT w="9525" cap="flat" cmpd="sng" algn="ctr">
+                      <a:solidFill>
+                        <a:srgbClr val="DCD5C1"/>
+                      </a:solidFill>
+                      <a:prstDash val="solid"/>
+                      <a:round/>
+                      <a:headEnd type="none" w="med" len="med"/>
+                      <a:tailEnd type="none" w="med" len="med"/>
+                    </a:lnT>
+                    <a:lnB w="9525" cap="flat" cmpd="sng" algn="ctr">
+                      <a:solidFill>
+                        <a:srgbClr val="DCD5C1"/>
+                      </a:solidFill>
+                      <a:prstDash val="solid"/>
+                      <a:round/>
+                      <a:headEnd type="none" w="med" len="med"/>
+                      <a:tailEnd type="none" w="med" len="med"/>
+                    </a:lnB>
+                    <a:solidFill>
+                      <a:srgbClr val="F4F7F8"/>
+                    </a:solidFill>
+                  </a:tcPr>
+                </a:tc>
+                <a:tc>
+                  <a:txBody>
+                    <a:bodyPr/>
+                    <a:lstStyle/>
+                    <a:p>
+                      <a:pPr indent="0" marL="0">
+                        <a:buNone/>
+                      </a:pPr>
+                      <a:r>
+                        <a:rPr lang="en-US" sz="1150" dirty="0">
+                          <a:solidFill>
+                            <a:srgbClr val="1F2A37"/>
+                          </a:solidFill>
+                          <a:latin typeface="Calibri" pitchFamily="34" charset="0"/>
+                          <a:ea typeface="Calibri" pitchFamily="34" charset="-122"/>
+                          <a:cs typeface="Calibri" pitchFamily="34" charset="-120"/>
+                        </a:rPr>
+                        <a:t>Tira dúvidas de conteúdo e de organização, indicando a unidade e o slide ou a página. O mediador responde em até 48 horas úteis.</a:t>
+                      </a:r>
+                      <a:endParaRPr lang="en-US" sz="1150" dirty="0">
+                        <a:latin typeface="Calibri" charset="0"/>
+                        <a:ea typeface="Calibri" charset="0"/>
+                        <a:cs typeface="Calibri" charset="0"/>
+                      </a:endParaRPr>
+                    </a:p>
+                  </a:txBody>
+                  <a:tcPr marL="50800" marR="50800" marT="50800" marB="50800" anchor="ctr">
+                    <a:lnL w="9525" cap="flat" cmpd="sng" algn="ctr">
+                      <a:solidFill>
+                        <a:srgbClr val="DCD5C1"/>
+                      </a:solidFill>
+                      <a:prstDash val="solid"/>
+                      <a:round/>
+                      <a:headEnd type="none" w="med" len="med"/>
+                      <a:tailEnd type="none" w="med" len="med"/>
+                    </a:lnL>
+                    <a:lnR w="9525" cap="flat" cmpd="sng" algn="ctr">
+                      <a:solidFill>
+                        <a:srgbClr val="DCD5C1"/>
+                      </a:solidFill>
+                      <a:prstDash val="solid"/>
+                      <a:round/>
+                      <a:headEnd type="none" w="med" len="med"/>
+                      <a:tailEnd type="none" w="med" len="med"/>
+                    </a:lnR>
+                    <a:lnT w="9525" cap="flat" cmpd="sng" algn="ctr">
+                      <a:solidFill>
+                        <a:srgbClr val="DCD5C1"/>
+                      </a:solidFill>
+                      <a:prstDash val="solid"/>
+                      <a:round/>
+                      <a:headEnd type="none" w="med" len="med"/>
+                      <a:tailEnd type="none" w="med" len="med"/>
+                    </a:lnT>
+                    <a:lnB w="9525" cap="flat" cmpd="sng" algn="ctr">
+                      <a:solidFill>
+                        <a:srgbClr val="DCD5C1"/>
+                      </a:solidFill>
+                      <a:prstDash val="solid"/>
+                      <a:round/>
+                      <a:headEnd type="none" w="med" len="med"/>
+                      <a:tailEnd type="none" w="med" len="med"/>
+                    </a:lnB>
+                    <a:solidFill>
+                      <a:srgbClr val="F4F7F8"/>
+                    </a:solidFill>
+                  </a:tcPr>
+                </a:tc>
+              </a:tr>
+              <a:tr h="0">
+                <a:tc>
+                  <a:txBody>
+                    <a:bodyPr/>
+                    <a:lstStyle/>
+                    <a:p>
+                      <a:pPr indent="0" marL="0">
+                        <a:buNone/>
+                      </a:pPr>
+                      <a:r>
+                        <a:rPr lang="en-US" sz="1150" b="1" dirty="0">
+                          <a:solidFill>
+                            <a:srgbClr val="1F2A37"/>
+                          </a:solidFill>
+                          <a:latin typeface="Calibri" pitchFamily="34" charset="0"/>
+                          <a:ea typeface="Calibri" pitchFamily="34" charset="-122"/>
+                          <a:cs typeface="Calibri" pitchFamily="34" charset="-120"/>
+                        </a:rPr>
+                        <a:t>Fórum temático 1</a:t>
+                      </a:r>
+                      <a:endParaRPr lang="en-US" sz="1150" dirty="0">
+                        <a:latin typeface="Calibri" charset="0"/>
+                        <a:ea typeface="Calibri" charset="0"/>
+                        <a:cs typeface="Calibri" charset="0"/>
+                      </a:endParaRPr>
+                    </a:p>
+                  </a:txBody>
+                  <a:tcPr marL="50800" marR="50800" marT="50800" marB="50800" anchor="ctr">
+                    <a:lnL w="9525" cap="flat" cmpd="sng" algn="ctr">
+                      <a:solidFill>
+                        <a:srgbClr val="DCD5C1"/>
+                      </a:solidFill>
+                      <a:prstDash val="solid"/>
+                      <a:round/>
+                      <a:headEnd type="none" w="med" len="med"/>
+                      <a:tailEnd type="none" w="med" len="med"/>
+                    </a:lnL>
+                    <a:lnR w="9525" cap="flat" cmpd="sng" algn="ctr">
+                      <a:solidFill>
+                        <a:srgbClr val="DCD5C1"/>
+                      </a:solidFill>
+                      <a:prstDash val="solid"/>
+                      <a:round/>
+                      <a:headEnd type="none" w="med" len="med"/>
+                      <a:tailEnd type="none" w="med" len="med"/>
+                    </a:lnR>
+                    <a:lnT w="9525" cap="flat" cmpd="sng" algn="ctr">
+                      <a:solidFill>
+                        <a:srgbClr val="DCD5C1"/>
+                      </a:solidFill>
+                      <a:prstDash val="solid"/>
+                      <a:round/>
+                      <a:headEnd type="none" w="med" len="med"/>
+                      <a:tailEnd type="none" w="med" len="med"/>
+                    </a:lnT>
+                    <a:lnB w="9525" cap="flat" cmpd="sng" algn="ctr">
+                      <a:solidFill>
+                        <a:srgbClr val="DCD5C1"/>
+                      </a:solidFill>
+                      <a:prstDash val="solid"/>
+                      <a:round/>
+                      <a:headEnd type="none" w="med" len="med"/>
+                      <a:tailEnd type="none" w="med" len="med"/>
+                    </a:lnB>
+                    <a:solidFill>
+                      <a:srgbClr val="FFFFFF"/>
+                    </a:solidFill>
+                  </a:tcPr>
+                </a:tc>
+                <a:tc>
+                  <a:txBody>
+                    <a:bodyPr/>
+                    <a:lstStyle/>
+                    <a:p>
+                      <a:pPr indent="0" marL="0">
+                        <a:buNone/>
+                      </a:pPr>
+                      <a:r>
+                        <a:rPr lang="en-US" sz="1150" dirty="0">
+                          <a:solidFill>
+                            <a:srgbClr val="1F2A37"/>
+                          </a:solidFill>
+                          <a:latin typeface="Calibri" pitchFamily="34" charset="0"/>
+                          <a:ea typeface="Calibri" pitchFamily="34" charset="-122"/>
+                          <a:cs typeface="Calibri" pitchFamily="34" charset="-120"/>
+                        </a:rPr>
+                        <a:t>09/10 a 18/10</a:t>
+                      </a:r>
+                      <a:endParaRPr lang="en-US" sz="1150" dirty="0">
+                        <a:latin typeface="Calibri" charset="0"/>
+                        <a:ea typeface="Calibri" charset="0"/>
+                        <a:cs typeface="Calibri" charset="0"/>
+                      </a:endParaRPr>
+                    </a:p>
+                  </a:txBody>
+                  <a:tcPr marL="50800" marR="50800" marT="50800" marB="50800" anchor="ctr">
+                    <a:lnL w="9525" cap="flat" cmpd="sng" algn="ctr">
+                      <a:solidFill>
+                        <a:srgbClr val="DCD5C1"/>
+                      </a:solidFill>
+                      <a:prstDash val="solid"/>
+                      <a:round/>
+                      <a:headEnd type="none" w="med" len="med"/>
+                      <a:tailEnd type="none" w="med" len="med"/>
+                    </a:lnL>
+                    <a:lnR w="9525" cap="flat" cmpd="sng" algn="ctr">
+                      <a:solidFill>
+                        <a:srgbClr val="DCD5C1"/>
+                      </a:solidFill>
+                      <a:prstDash val="solid"/>
+                      <a:round/>
+                      <a:headEnd type="none" w="med" len="med"/>
+                      <a:tailEnd type="none" w="med" len="med"/>
+                    </a:lnR>
+                    <a:lnT w="9525" cap="flat" cmpd="sng" algn="ctr">
+                      <a:solidFill>
+                        <a:srgbClr val="DCD5C1"/>
+                      </a:solidFill>
+                      <a:prstDash val="solid"/>
+                      <a:round/>
+                      <a:headEnd type="none" w="med" len="med"/>
+                      <a:tailEnd type="none" w="med" len="med"/>
+                    </a:lnT>
+                    <a:lnB w="9525" cap="flat" cmpd="sng" algn="ctr">
+                      <a:solidFill>
+                        <a:srgbClr val="DCD5C1"/>
+                      </a:solidFill>
+                      <a:prstDash val="solid"/>
+                      <a:round/>
+                      <a:headEnd type="none" w="med" len="med"/>
+                      <a:tailEnd type="none" w="med" len="med"/>
+                    </a:lnB>
+                    <a:solidFill>
+                      <a:srgbClr val="FFFFFF"/>
+                    </a:solidFill>
+                  </a:tcPr>
+                </a:tc>
+                <a:tc>
+                  <a:txBody>
+                    <a:bodyPr/>
+                    <a:lstStyle/>
+                    <a:p>
+                      <a:pPr indent="0" marL="0">
+                        <a:buNone/>
+                      </a:pPr>
+                      <a:r>
+                        <a:rPr lang="en-US" sz="1150" dirty="0">
+                          <a:solidFill>
+                            <a:srgbClr val="1F2A37"/>
+                          </a:solidFill>
+                          <a:latin typeface="Calibri" pitchFamily="34" charset="0"/>
+                          <a:ea typeface="Calibri" pitchFamily="34" charset="-122"/>
+                          <a:cs typeface="Calibri" pitchFamily="34" charset="-120"/>
+                        </a:rPr>
+                        <a:t>“Que falha de mercado uma política pública do seu município procura corrigir? Qual função do Estado (alocativa, distributiva ou estabilizadora) ela cumpre?” Postagem de 10 a 20 linhas e comentários em pelo menos 2 colegas.</a:t>
+                      </a:r>
+                      <a:endParaRPr lang="en-US" sz="1150" dirty="0">
+                        <a:latin typeface="Calibri" charset="0"/>
+                        <a:ea typeface="Calibri" charset="0"/>
+                        <a:cs typeface="Calibri" charset="0"/>
+                      </a:endParaRPr>
+                    </a:p>
+                  </a:txBody>
+                  <a:tcPr marL="50800" marR="50800" marT="50800" marB="50800" anchor="ctr">
+                    <a:lnL w="9525" cap="flat" cmpd="sng" algn="ctr">
+                      <a:solidFill>
+                        <a:srgbClr val="DCD5C1"/>
+                      </a:solidFill>
+                      <a:prstDash val="solid"/>
+                      <a:round/>
+                      <a:headEnd type="none" w="med" len="med"/>
+                      <a:tailEnd type="none" w="med" len="med"/>
+                    </a:lnL>
+                    <a:lnR w="9525" cap="flat" cmpd="sng" algn="ctr">
+                      <a:solidFill>
+                        <a:srgbClr val="DCD5C1"/>
+                      </a:solidFill>
+                      <a:prstDash val="solid"/>
+                      <a:round/>
+                      <a:headEnd type="none" w="med" len="med"/>
+                      <a:tailEnd type="none" w="med" len="med"/>
+                    </a:lnR>
+                    <a:lnT w="9525" cap="flat" cmpd="sng" algn="ctr">
+                      <a:solidFill>
+                        <a:srgbClr val="DCD5C1"/>
+                      </a:solidFill>
+                      <a:prstDash val="solid"/>
+                      <a:round/>
+                      <a:headEnd type="none" w="med" len="med"/>
+                      <a:tailEnd type="none" w="med" len="med"/>
+                    </a:lnT>
+                    <a:lnB w="9525" cap="flat" cmpd="sng" algn="ctr">
+                      <a:solidFill>
+                        <a:srgbClr val="DCD5C1"/>
+                      </a:solidFill>
+                      <a:prstDash val="solid"/>
+                      <a:round/>
+                      <a:headEnd type="none" w="med" len="med"/>
+                      <a:tailEnd type="none" w="med" len="med"/>
+                    </a:lnB>
+                    <a:solidFill>
+                      <a:srgbClr val="FFFFFF"/>
+                    </a:solidFill>
+                  </a:tcPr>
+                </a:tc>
+              </a:tr>
+              <a:tr h="0">
+                <a:tc>
+                  <a:txBody>
+                    <a:bodyPr/>
+                    <a:lstStyle/>
+                    <a:p>
+                      <a:pPr indent="0" marL="0">
+                        <a:buNone/>
+                      </a:pPr>
+                      <a:r>
+                        <a:rPr lang="en-US" sz="1150" b="1" dirty="0">
+                          <a:solidFill>
+                            <a:srgbClr val="1F2A37"/>
+                          </a:solidFill>
+                          <a:latin typeface="Calibri" pitchFamily="34" charset="0"/>
+                          <a:ea typeface="Calibri" pitchFamily="34" charset="-122"/>
+                          <a:cs typeface="Calibri" pitchFamily="34" charset="-120"/>
+                        </a:rPr>
+                        <a:t>Fórum temático 2</a:t>
+                      </a:r>
+                      <a:endParaRPr lang="en-US" sz="1150" dirty="0">
+                        <a:latin typeface="Calibri" charset="0"/>
+                        <a:ea typeface="Calibri" charset="0"/>
+                        <a:cs typeface="Calibri" charset="0"/>
+                      </a:endParaRPr>
+                    </a:p>
+                  </a:txBody>
+                  <a:tcPr marL="50800" marR="50800" marT="50800" marB="50800" anchor="ctr">
+                    <a:lnL w="9525" cap="flat" cmpd="sng" algn="ctr">
+                      <a:solidFill>
+                        <a:srgbClr val="DCD5C1"/>
+                      </a:solidFill>
+                      <a:prstDash val="solid"/>
+                      <a:round/>
+                      <a:headEnd type="none" w="med" len="med"/>
+                      <a:tailEnd type="none" w="med" len="med"/>
+                    </a:lnL>
+                    <a:lnR w="9525" cap="flat" cmpd="sng" algn="ctr">
+                      <a:solidFill>
+                        <a:srgbClr val="DCD5C1"/>
+                      </a:solidFill>
+                      <a:prstDash val="solid"/>
+                      <a:round/>
+                      <a:headEnd type="none" w="med" len="med"/>
+                      <a:tailEnd type="none" w="med" len="med"/>
+                    </a:lnR>
+                    <a:lnT w="9525" cap="flat" cmpd="sng" algn="ctr">
+                      <a:solidFill>
+                        <a:srgbClr val="DCD5C1"/>
+                      </a:solidFill>
+                      <a:prstDash val="solid"/>
+                      <a:round/>
+                      <a:headEnd type="none" w="med" len="med"/>
+                      <a:tailEnd type="none" w="med" len="med"/>
+                    </a:lnT>
+                    <a:lnB w="9525" cap="flat" cmpd="sng" algn="ctr">
+                      <a:solidFill>
+                        <a:srgbClr val="DCD5C1"/>
+                      </a:solidFill>
+                      <a:prstDash val="solid"/>
+                      <a:round/>
+                      <a:headEnd type="none" w="med" len="med"/>
+                      <a:tailEnd type="none" w="med" len="med"/>
+                    </a:lnB>
+                    <a:solidFill>
+                      <a:srgbClr val="F4F7F8"/>
+                    </a:solidFill>
+                  </a:tcPr>
+                </a:tc>
+                <a:tc>
+                  <a:txBody>
+                    <a:bodyPr/>
+                    <a:lstStyle/>
+                    <a:p>
+                      <a:pPr indent="0" marL="0">
+                        <a:buNone/>
+                      </a:pPr>
+                      <a:r>
+                        <a:rPr lang="en-US" sz="1150" dirty="0">
+                          <a:solidFill>
+                            <a:srgbClr val="1F2A37"/>
+                          </a:solidFill>
+                          <a:latin typeface="Calibri" pitchFamily="34" charset="0"/>
+                          <a:ea typeface="Calibri" pitchFamily="34" charset="-122"/>
+                          <a:cs typeface="Calibri" pitchFamily="34" charset="-120"/>
+                        </a:rPr>
+                        <a:t>26/10 a 01/11</a:t>
+                      </a:r>
+                      <a:endParaRPr lang="en-US" sz="1150" dirty="0">
+                        <a:latin typeface="Calibri" charset="0"/>
+                        <a:ea typeface="Calibri" charset="0"/>
+                        <a:cs typeface="Calibri" charset="0"/>
+                      </a:endParaRPr>
+                    </a:p>
+                  </a:txBody>
+                  <a:tcPr marL="50800" marR="50800" marT="50800" marB="50800" anchor="ctr">
+                    <a:lnL w="9525" cap="flat" cmpd="sng" algn="ctr">
+                      <a:solidFill>
+                        <a:srgbClr val="DCD5C1"/>
+                      </a:solidFill>
+                      <a:prstDash val="solid"/>
+                      <a:round/>
+                      <a:headEnd type="none" w="med" len="med"/>
+                      <a:tailEnd type="none" w="med" len="med"/>
+                    </a:lnL>
+                    <a:lnR w="9525" cap="flat" cmpd="sng" algn="ctr">
+                      <a:solidFill>
+                        <a:srgbClr val="DCD5C1"/>
+                      </a:solidFill>
+                      <a:prstDash val="solid"/>
+                      <a:round/>
+                      <a:headEnd type="none" w="med" len="med"/>
+                      <a:tailEnd type="none" w="med" len="med"/>
+                    </a:lnR>
+                    <a:lnT w="9525" cap="flat" cmpd="sng" algn="ctr">
+                      <a:solidFill>
+                        <a:srgbClr val="DCD5C1"/>
+                      </a:solidFill>
+                      <a:prstDash val="solid"/>
+                      <a:round/>
+                      <a:headEnd type="none" w="med" len="med"/>
+                      <a:tailEnd type="none" w="med" len="med"/>
+                    </a:lnT>
+                    <a:lnB w="9525" cap="flat" cmpd="sng" algn="ctr">
+                      <a:solidFill>
+                        <a:srgbClr val="DCD5C1"/>
+                      </a:solidFill>
+                      <a:prstDash val="solid"/>
+                      <a:round/>
+                      <a:headEnd type="none" w="med" len="med"/>
+                      <a:tailEnd type="none" w="med" len="med"/>
+                    </a:lnB>
+                    <a:solidFill>
+                      <a:srgbClr val="F4F7F8"/>
+                    </a:solidFill>
+                  </a:tcPr>
+                </a:tc>
+                <a:tc>
+                  <a:txBody>
+                    <a:bodyPr/>
+                    <a:lstStyle/>
+                    <a:p>
+                      <a:pPr indent="0" marL="0">
+                        <a:buNone/>
+                      </a:pPr>
+                      <a:r>
+                        <a:rPr lang="en-US" sz="1150" dirty="0">
+                          <a:solidFill>
+                            <a:srgbClr val="1F2A37"/>
+                          </a:solidFill>
+                          <a:latin typeface="Calibri" pitchFamily="34" charset="0"/>
+                          <a:ea typeface="Calibri" pitchFamily="34" charset="-122"/>
+                          <a:cs typeface="Calibri" pitchFamily="34" charset="-120"/>
+                        </a:rPr>
+                        <a:t>“Escolha uma política pública e explique como um liberal e um marxista a avaliariam.” Postagem de 15 a 25 linhas e comentários em 2 colegas. Serve de treino para o estudo de caso da A3.</a:t>
+                      </a:r>
+                      <a:endParaRPr lang="en-US" sz="1150" dirty="0">
+                        <a:latin typeface="Calibri" charset="0"/>
+                        <a:ea typeface="Calibri" charset="0"/>
+                        <a:cs typeface="Calibri" charset="0"/>
+                      </a:endParaRPr>
+                    </a:p>
+                  </a:txBody>
+                  <a:tcPr marL="50800" marR="50800" marT="50800" marB="50800" anchor="ctr">
+                    <a:lnL w="9525" cap="flat" cmpd="sng" algn="ctr">
+                      <a:solidFill>
+                        <a:srgbClr val="DCD5C1"/>
+                      </a:solidFill>
+                      <a:prstDash val="solid"/>
+                      <a:round/>
+                      <a:headEnd type="none" w="med" len="med"/>
+                      <a:tailEnd type="none" w="med" len="med"/>
+                    </a:lnL>
+                    <a:lnR w="9525" cap="flat" cmpd="sng" algn="ctr">
+                      <a:solidFill>
+                        <a:srgbClr val="DCD5C1"/>
+                      </a:solidFill>
+                      <a:prstDash val="solid"/>
+                      <a:round/>
+                      <a:headEnd type="none" w="med" len="med"/>
+                      <a:tailEnd type="none" w="med" len="med"/>
+                    </a:lnR>
+                    <a:lnT w="9525" cap="flat" cmpd="sng" algn="ctr">
+                      <a:solidFill>
+                        <a:srgbClr val="DCD5C1"/>
+                      </a:solidFill>
+                      <a:prstDash val="solid"/>
+                      <a:round/>
+                      <a:headEnd type="none" w="med" len="med"/>
+                      <a:tailEnd type="none" w="med" len="med"/>
+                    </a:lnT>
+                    <a:lnB w="9525" cap="flat" cmpd="sng" algn="ctr">
+                      <a:solidFill>
+                        <a:srgbClr val="DCD5C1"/>
+                      </a:solidFill>
+                      <a:prstDash val="solid"/>
+                      <a:round/>
+                      <a:headEnd type="none" w="med" len="med"/>
+                      <a:tailEnd type="none" w="med" len="med"/>
+                    </a:lnB>
+                    <a:solidFill>
+                      <a:srgbClr val="F4F7F8"/>
+                    </a:solidFill>
+                  </a:tcPr>
+                </a:tc>
+              </a:tr>
+            </a:tbl>
+          </a:graphicData>
+        </a:graphic>
+      </p:graphicFrame>
+      <p:sp>
+        <p:nvSpPr>
+          <p:cNvPr id="5" name="Text 2"/>
           <p:cNvSpPr txBox="1"/>
           <p:nvPr/>
         </p:nvSpPr>

</xml_diff>

<commit_message>
EGM: encontro síncrono único em 26/10 (segunda-feira), 19h às 20h30
Co-Authored-By: Claude Opus 5.5 <noreply@anthropic.com>
Claude-Session: https://claude.ai/code/session_01PyQDDPKwUxu1Vg7o8uyr7W
</commit_message>
<xml_diff>
--- a/disciplina-01-estado-governo-mercado/materiais/00_Videoaula_de_Apresentacao.pptx
+++ b/disciplina-01-estado-governo-mercado/materiais/00_Videoaula_de_Apresentacao.pptx
@@ -779,7 +779,7 @@
           <a:p>
             <a:r>
               <a:rPr lang="en-US" dirty="0"/>
-              <a:t>Este é o mapa do bloco. Anote as datas: o encontro síncrono é no dia 28 de outubro, às 19h; A1 até 25 de outubro; A2 até 8 de novembro; A3 até 15 de novembro, quando a disciplina se encerra. Todas as entregas até 23h55.</a:t>
+              <a:t>Este é o mapa do bloco. Anote as datas: o único encontro síncrono é na segunda-feira, 26 de outubro, às 19h; A1 até 25 de outubro; A2 até 8 de novembro; A3 até 15 de novembro, quando a disciplina se encerra. Todas as entregas até 23h55.</a:t>
             </a:r>
             <a:endParaRPr lang="en-US" dirty="0"/>
           </a:p>
@@ -955,7 +955,7 @@
           <a:p>
             <a:r>
               <a:rPr lang="en-US" dirty="0"/>
-              <a:t>Para começar: acesse o SIGAA, apresente-se no fórum até 18 de outubro e anote na agenda o nosso encontro síncrono, em 28 de outubro, às 19h. Bons estudos!</a:t>
+              <a:t>Para começar: acesse o SIGAA, apresente-se no fórum até 18 de outubro e anote na agenda o nosso encontro síncrono, na segunda-feira, 26 de outubro, às 19h. Bons estudos!</a:t>
             </a:r>
             <a:endParaRPr lang="en-US" dirty="0"/>
           </a:p>
@@ -1571,7 +1571,7 @@
           <a:p>
             <a:r>
               <a:rPr lang="en-US" dirty="0"/>
-              <a:t>São 30 horas: 28 horas e meia de estudo assíncrono no SIGAA e um encontro síncrono de 1h30 pelo Google Meet, na quarta-feira, 28 de outubro, das 19h às 20h30. A presença nesse encontro é obrigatória, porque o PPC exige 75% de frequência nas atividades síncronas. O encontro fica gravado no SIGAA.</a:t>
+              <a:t>São 30 horas: 28 horas e meia de estudo assíncrono no SIGAA e um único encontro síncrono de 1h30 pelo Google Meet, na segunda-feira, 26 de outubro, das 19h às 20h30. A presença nesse encontro é obrigatória, porque o PPC exige 75% de frequência nas atividades síncronas. O encontro fica gravado no SIGAA.</a:t>
             </a:r>
             <a:endParaRPr lang="en-US" dirty="0"/>
           </a:p>
@@ -4150,7 +4150,7 @@
                         <a:buNone/>
                       </a:pPr>
                       <a:r>
-                        <a:rPr lang="en-US" sz="1200" dirty="0">
+                        <a:rPr lang="en-US" sz="1200" b="1" dirty="0">
                           <a:solidFill>
                             <a:srgbClr val="1F2A37"/>
                           </a:solidFill>
@@ -4158,7 +4158,7 @@
                           <a:ea typeface="Calibri" pitchFamily="34" charset="-122"/>
                           <a:cs typeface="Calibri" pitchFamily="34" charset="-120"/>
                         </a:rPr>
-                        <a:t>Início da Unidade 3</a:t>
+                        <a:t>Início da Unidade 3 · encontro síncrono, 19h–20h30</a:t>
                       </a:r>
                       <a:endParaRPr lang="en-US" sz="1200" dirty="0">
                         <a:latin typeface="Calibri" charset="0"/>
@@ -4206,144 +4206,6 @@
                     </a:lnB>
                     <a:solidFill>
                       <a:srgbClr val="FFFFFF"/>
-                    </a:solidFill>
-                  </a:tcPr>
-                </a:tc>
-              </a:tr>
-              <a:tr h="0">
-                <a:tc>
-                  <a:txBody>
-                    <a:bodyPr/>
-                    <a:lstStyle/>
-                    <a:p>
-                      <a:pPr indent="0" marL="0">
-                        <a:buNone/>
-                      </a:pPr>
-                      <a:r>
-                        <a:rPr lang="en-US" sz="1200" dirty="0">
-                          <a:solidFill>
-                            <a:srgbClr val="1F2A37"/>
-                          </a:solidFill>
-                          <a:latin typeface="Calibri" pitchFamily="34" charset="0"/>
-                          <a:ea typeface="Calibri" pitchFamily="34" charset="-122"/>
-                          <a:cs typeface="Calibri" pitchFamily="34" charset="-120"/>
-                        </a:rPr>
-                        <a:t>28/10 (qua)</a:t>
-                      </a:r>
-                      <a:endParaRPr lang="en-US" sz="1200" dirty="0">
-                        <a:latin typeface="Calibri" charset="0"/>
-                        <a:ea typeface="Calibri" charset="0"/>
-                        <a:cs typeface="Calibri" charset="0"/>
-                      </a:endParaRPr>
-                    </a:p>
-                  </a:txBody>
-                  <a:tcPr marL="50800" marR="50800" marT="50800" marB="50800" anchor="ctr">
-                    <a:lnL w="9525" cap="flat" cmpd="sng" algn="ctr">
-                      <a:solidFill>
-                        <a:srgbClr val="DCD5C1"/>
-                      </a:solidFill>
-                      <a:prstDash val="solid"/>
-                      <a:round/>
-                      <a:headEnd type="none" w="med" len="med"/>
-                      <a:tailEnd type="none" w="med" len="med"/>
-                    </a:lnL>
-                    <a:lnR w="9525" cap="flat" cmpd="sng" algn="ctr">
-                      <a:solidFill>
-                        <a:srgbClr val="DCD5C1"/>
-                      </a:solidFill>
-                      <a:prstDash val="solid"/>
-                      <a:round/>
-                      <a:headEnd type="none" w="med" len="med"/>
-                      <a:tailEnd type="none" w="med" len="med"/>
-                    </a:lnR>
-                    <a:lnT w="9525" cap="flat" cmpd="sng" algn="ctr">
-                      <a:solidFill>
-                        <a:srgbClr val="DCD5C1"/>
-                      </a:solidFill>
-                      <a:prstDash val="solid"/>
-                      <a:round/>
-                      <a:headEnd type="none" w="med" len="med"/>
-                      <a:tailEnd type="none" w="med" len="med"/>
-                    </a:lnT>
-                    <a:lnB w="9525" cap="flat" cmpd="sng" algn="ctr">
-                      <a:solidFill>
-                        <a:srgbClr val="DCD5C1"/>
-                      </a:solidFill>
-                      <a:prstDash val="solid"/>
-                      <a:round/>
-                      <a:headEnd type="none" w="med" len="med"/>
-                      <a:tailEnd type="none" w="med" len="med"/>
-                    </a:lnB>
-                    <a:solidFill>
-                      <a:srgbClr val="F4F7F8"/>
-                    </a:solidFill>
-                  </a:tcPr>
-                </a:tc>
-                <a:tc>
-                  <a:txBody>
-                    <a:bodyPr/>
-                    <a:lstStyle/>
-                    <a:p>
-                      <a:pPr indent="0" marL="0">
-                        <a:buNone/>
-                      </a:pPr>
-                      <a:r>
-                        <a:rPr lang="en-US" sz="1200" b="1" dirty="0">
-                          <a:solidFill>
-                            <a:srgbClr val="1F2A37"/>
-                          </a:solidFill>
-                          <a:latin typeface="Calibri" pitchFamily="34" charset="0"/>
-                          <a:ea typeface="Calibri" pitchFamily="34" charset="-122"/>
-                          <a:cs typeface="Calibri" pitchFamily="34" charset="-120"/>
-                        </a:rPr>
-                        <a:t>Encontro síncrono, 19h–20h30</a:t>
-                      </a:r>
-                      <a:endParaRPr lang="en-US" sz="1200" dirty="0">
-                        <a:latin typeface="Calibri" charset="0"/>
-                        <a:ea typeface="Calibri" charset="0"/>
-                        <a:cs typeface="Calibri" charset="0"/>
-                      </a:endParaRPr>
-                    </a:p>
-                  </a:txBody>
-                  <a:tcPr marL="50800" marR="50800" marT="50800" marB="50800" anchor="ctr">
-                    <a:lnL w="9525" cap="flat" cmpd="sng" algn="ctr">
-                      <a:solidFill>
-                        <a:srgbClr val="DCD5C1"/>
-                      </a:solidFill>
-                      <a:prstDash val="solid"/>
-                      <a:round/>
-                      <a:headEnd type="none" w="med" len="med"/>
-                      <a:tailEnd type="none" w="med" len="med"/>
-                    </a:lnL>
-                    <a:lnR w="9525" cap="flat" cmpd="sng" algn="ctr">
-                      <a:solidFill>
-                        <a:srgbClr val="DCD5C1"/>
-                      </a:solidFill>
-                      <a:prstDash val="solid"/>
-                      <a:round/>
-                      <a:headEnd type="none" w="med" len="med"/>
-                      <a:tailEnd type="none" w="med" len="med"/>
-                    </a:lnR>
-                    <a:lnT w="9525" cap="flat" cmpd="sng" algn="ctr">
-                      <a:solidFill>
-                        <a:srgbClr val="DCD5C1"/>
-                      </a:solidFill>
-                      <a:prstDash val="solid"/>
-                      <a:round/>
-                      <a:headEnd type="none" w="med" len="med"/>
-                      <a:tailEnd type="none" w="med" len="med"/>
-                    </a:lnT>
-                    <a:lnB w="9525" cap="flat" cmpd="sng" algn="ctr">
-                      <a:solidFill>
-                        <a:srgbClr val="DCD5C1"/>
-                      </a:solidFill>
-                      <a:prstDash val="solid"/>
-                      <a:round/>
-                      <a:headEnd type="none" w="med" len="med"/>
-                      <a:tailEnd type="none" w="med" len="med"/>
-                    </a:lnB>
-                    <a:solidFill>
-                      <a:srgbClr val="F4F7F8"/>
                     </a:solidFill>
                   </a:tcPr>
                 </a:tc>
@@ -5891,7 +5753,7 @@
                 <a:ea typeface="Calibri" pitchFamily="34" charset="-122"/>
                 <a:cs typeface="Calibri" pitchFamily="34" charset="-120"/>
               </a:rPr>
-              <a:t>dos fóruns e do encontro síncrono (28/10).</a:t>
+              <a:t>dos fóruns e do encontro síncrono (26/10).</a:t>
             </a:r>
             <a:endParaRPr lang="en-US" sz="3000" dirty="0"/>
           </a:p>
@@ -6570,7 +6432,7 @@
                 <a:ea typeface="Calibri" pitchFamily="34" charset="-122"/>
                 <a:cs typeface="Calibri" pitchFamily="34" charset="-120"/>
               </a:rPr>
-              <a:t>Encontro síncrono em 28/10, quarta-feira, às 19h.</a:t>
+              <a:t>Encontro síncrono em 26/10, segunda-feira, às 19h.</a:t>
             </a:r>
             <a:endParaRPr lang="en-US" sz="1600" dirty="0"/>
           </a:p>
@@ -7408,7 +7270,7 @@
                 <a:ea typeface="Calibri" pitchFamily="34" charset="-122"/>
                 <a:cs typeface="Calibri" pitchFamily="34" charset="-120"/>
               </a:rPr>
-              <a:t>28,5 h assíncronas no SIGAA · 1,5 h síncrona (encontro virtual em 28/10, 19h)</a:t>
+              <a:t>28,5 h assíncronas no SIGAA · 1,5 h síncrona (encontro virtual em 26/10, 19h)</a:t>
             </a:r>
             <a:endParaRPr lang="en-US" sz="1500" dirty="0"/>
           </a:p>
@@ -9434,7 +9296,7 @@
                 <a:ea typeface="Calibri" pitchFamily="34" charset="-122"/>
                 <a:cs typeface="Calibri" pitchFamily="34" charset="-120"/>
               </a:rPr>
-              <a:t>Encontro síncrono único: 28/10, às 19h. De 09/11 a 15/11: revisão e Avaliação A3.</a:t>
+              <a:t>Encontro síncrono único: segunda-feira, 26/10, às 19h. De 09/11 a 15/11: revisão e Avaliação A3.</a:t>
             </a:r>
             <a:endParaRPr lang="en-US" sz="1400" dirty="0"/>
           </a:p>
@@ -10396,7 +10258,7 @@
                 <a:ea typeface="Calibri" pitchFamily="34" charset="-122"/>
                 <a:cs typeface="Calibri" pitchFamily="34" charset="-120"/>
               </a:rPr>
-              <a:t>Um encontro virtual no Google Meet: quarta-feira, 28/10, das 19h às 20h30. Revisão das Unidades 1 a 3 e orientações para A2 e A3.</a:t>
+              <a:t>Único, no Google Meet: segunda-feira, 26/10, 19h às 20h30. Revisão das Unidades 1 e 2, abertura da Unidade 3 e orientações para A2 e A3.</a:t>
             </a:r>
             <a:endParaRPr lang="en-US" sz="1100" dirty="0"/>
           </a:p>

</xml_diff>

<commit_message>
EGM: data do encontro síncrono (26/10) em destaque e link do site em Onde buscar
Co-Authored-By: Claude Opus 5.5 <noreply@anthropic.com>
Claude-Session: https://claude.ai/code/session_01PyQDDPKwUxu1Vg7o8uyr7W
</commit_message>
<xml_diff>
--- a/disciplina-01-estado-governo-mercado/materiais/00_Videoaula_de_Apresentacao.pptx
+++ b/disciplina-01-estado-governo-mercado/materiais/00_Videoaula_de_Apresentacao.pptx
@@ -1483,7 +1483,7 @@
           <a:p>
             <a:r>
               <a:rPr lang="en-US" dirty="0"/>
-              <a:t>O livro-texto base é o de Ricardo Corrêa Coelho, Estado, governo e mercado, disponível no EduCAPES. Há também leituras complementares. Use sempre fontes autorizadas: EduCAPES, Biblioteca Virtual da UNEMAT, BDTD e fontes oficiais.</a:t>
+              <a:t>O livro-texto base é o de Ricardo Corrêa Coelho, Estado, governo e mercado, disponível no EduCAPES. Há também leituras complementares. Os conteúdos, os slides, os estudos de caso e os exercícios estão na página da disciplina: cleitonfranco74.github.io/gestao_publica. Use sempre fontes autorizadas: EduCAPES, Biblioteca Virtual da UNEMAT, BDTD e fontes oficiais.</a:t>
             </a:r>
             <a:endParaRPr lang="en-US" dirty="0"/>
           </a:p>
@@ -9591,11 +9591,11 @@
         <p:spPr>
           <a:xfrm>
             <a:off x="4572000" y="1298448"/>
-            <a:ext cx="3886200" cy="1874520"/>
+            <a:ext cx="3886200" cy="1572768"/>
           </a:xfrm>
           <a:prstGeom prst="roundRect">
             <a:avLst>
-              <a:gd name="adj" fmla="val 2927"/>
+              <a:gd name="adj" fmla="val 3488"/>
             </a:avLst>
           </a:prstGeom>
           <a:solidFill>
@@ -9616,7 +9616,7 @@
                 <a:spcPct val="100000"/>
               </a:lnSpc>
               <a:spcAft>
-                <a:spcPts val="400"/>
+                <a:spcPts val="300"/>
               </a:spcAft>
               <a:buNone/>
             </a:pPr>
@@ -9639,13 +9639,13 @@
                 <a:spcPct val="100000"/>
               </a:lnSpc>
               <a:spcAft>
-                <a:spcPts val="200"/>
+                <a:spcPts val="100"/>
               </a:spcAft>
               <a:buSzPct val="100000"/>
               <a:buChar char="•"/>
             </a:pPr>
             <a:r>
-              <a:rPr lang="en-US" sz="1250" dirty="0">
+              <a:rPr lang="en-US" sz="1200" dirty="0">
                 <a:solidFill>
                   <a:srgbClr val="1F2A37"/>
                 </a:solidFill>
@@ -9663,13 +9663,13 @@
                 <a:spcPct val="100000"/>
               </a:lnSpc>
               <a:spcAft>
-                <a:spcPts val="200"/>
+                <a:spcPts val="100"/>
               </a:spcAft>
               <a:buSzPct val="100000"/>
               <a:buChar char="•"/>
             </a:pPr>
             <a:r>
-              <a:rPr lang="en-US" sz="1250" dirty="0">
+              <a:rPr lang="en-US" sz="1200" dirty="0">
                 <a:solidFill>
                   <a:srgbClr val="1F2A37"/>
                 </a:solidFill>
@@ -9690,7 +9690,7 @@
               <a:buChar char="•"/>
             </a:pPr>
             <a:r>
-              <a:rPr lang="en-US" sz="1250" dirty="0">
+              <a:rPr lang="en-US" sz="1200" dirty="0">
                 <a:solidFill>
                   <a:srgbClr val="1F2A37"/>
                 </a:solidFill>
@@ -9712,12 +9712,12 @@
         </p:nvSpPr>
         <p:spPr>
           <a:xfrm>
-            <a:off x="4572000" y="3310128"/>
-            <a:ext cx="3886200" cy="1051560"/>
+            <a:off x="4572000" y="3017520"/>
+            <a:ext cx="3886200" cy="1344168"/>
           </a:xfrm>
           <a:prstGeom prst="roundRect">
             <a:avLst>
-              <a:gd name="adj" fmla="val 5217"/>
+              <a:gd name="adj" fmla="val 4082"/>
             </a:avLst>
           </a:prstGeom>
           <a:solidFill>
@@ -9763,7 +9763,50 @@
               <a:buNone/>
             </a:pPr>
             <a:r>
-              <a:rPr lang="en-US" sz="1250" dirty="0">
+              <a:rPr lang="en-US" sz="1200" b="1" dirty="0">
+                <a:solidFill>
+                  <a:srgbClr val="1F2A37"/>
+                </a:solidFill>
+                <a:latin typeface="Calibri" pitchFamily="34" charset="0"/>
+                <a:ea typeface="Calibri" pitchFamily="34" charset="-122"/>
+                <a:cs typeface="Calibri" pitchFamily="34" charset="-120"/>
+              </a:rPr>
+              <a:t>Página da disciplina: </a:t>
+            </a:r>
+            <a:endParaRPr lang="en-US" sz="1500" dirty="0"/>
+          </a:p>
+          <a:p>
+            <a:pPr algn="l" indent="0" marL="0">
+              <a:lnSpc>
+                <a:spcPct val="100000"/>
+              </a:lnSpc>
+              <a:spcAft>
+                <a:spcPts val="300"/>
+              </a:spcAft>
+              <a:buNone/>
+            </a:pPr>
+            <a:r>
+              <a:rPr lang="en-US" sz="1250" b="1" dirty="0">
+                <a:solidFill>
+                  <a:srgbClr val="2A8C85"/>
+                </a:solidFill>
+                <a:latin typeface="Calibri" pitchFamily="34" charset="0"/>
+                <a:ea typeface="Calibri" pitchFamily="34" charset="-122"/>
+                <a:cs typeface="Calibri" pitchFamily="34" charset="-120"/>
+              </a:rPr>
+              <a:t>cleitonfranco74.github.io/gestao_publica</a:t>
+            </a:r>
+            <a:endParaRPr lang="en-US" sz="1500" dirty="0"/>
+          </a:p>
+          <a:p>
+            <a:pPr algn="l" indent="0" marL="0">
+              <a:lnSpc>
+                <a:spcPct val="100000"/>
+              </a:lnSpc>
+              <a:buNone/>
+            </a:pPr>
+            <a:r>
+              <a:rPr lang="en-US" sz="1200" dirty="0">
                 <a:solidFill>
                   <a:srgbClr val="1F2A37"/>
                 </a:solidFill>

</xml_diff>

<commit_message>
EGM: nova pergunta central da disciplina na apresentação e no plano de ensino
Co-Authored-By: Claude Opus 5.5 <noreply@anthropic.com>
Claude-Session: https://claude.ai/code/session_01PyQDDPKwUxu1Vg7o8uyr7W
</commit_message>
<xml_diff>
--- a/disciplina-01-estado-governo-mercado/materiais/00_Videoaula_de_Apresentacao.pptx
+++ b/disciplina-01-estado-governo-mercado/materiais/00_Videoaula_de_Apresentacao.pptx
@@ -1219,7 +1219,7 @@
           <a:p>
             <a:r>
               <a:rPr lang="en-US" dirty="0"/>
-              <a:t>A pergunta central da disciplina: qual deve ser o papel do Estado na economia e na sociedade, e qual deve ser o papel do mercado? Ela aparece no dia a dia do gestor e é a base das próximas disciplinas.</a:t>
+              <a:t>A pergunta central da disciplina: como dividir as tarefas entre Estado e mercado para promover o desenvolvimento da economia e o bem-estar da sociedade? Ela aparece no dia a dia do gestor e é a base das próximas disciplinas.</a:t>
             </a:r>
             <a:endParaRPr lang="en-US" dirty="0"/>
           </a:p>
@@ -8118,7 +8118,7 @@
                 <a:ea typeface="Calibri" pitchFamily="34" charset="-122"/>
                 <a:cs typeface="Calibri" pitchFamily="34" charset="-120"/>
               </a:rPr>
-              <a:t>Qual deve ser o papel do Estado na economia e na sociedade, e qual deve ser o papel do mercado?</a:t>
+              <a:t>Como dividir as tarefas entre Estado e mercado para promover o desenvolvimento da economia e o bem-estar da sociedade?</a:t>
             </a:r>
             <a:endParaRPr lang="en-US" sz="2100" dirty="0"/>
           </a:p>

</xml_diff>